<commit_message>
docs: deliver Greek-first trilingual research portal
</commit_message>
<xml_diff>
--- a/docs/downloads/el/DRX_Ministerial_Presentation_EL.pptx
+++ b/docs/downloads/el/DRX_Ministerial_Presentation_EL.pptx
@@ -2,28 +2,28 @@
 <file path=ppt/presentation.xml><?xml version="1.0" encoding="utf-8"?>
 <p:presentation xmlns:p="http://schemas.openxmlformats.org/presentationml/2006/main">
   <p:sldMasterIdLst>
-    <p:sldMasterId xmlns:r="http://schemas.openxmlformats.org/officeDocument/2006/relationships" id="2147483648" r:id="R9871f554890346e4"/>
+    <p:sldMasterId xmlns:r="http://schemas.openxmlformats.org/officeDocument/2006/relationships" id="2147483648" r:id="R196288855a4f418b"/>
   </p:sldMasterIdLst>
   <p:notesMasterIdLst>
-    <p:notesMasterId xmlns:r="http://schemas.openxmlformats.org/officeDocument/2006/relationships" r:id="Ref29093663884b98"/>
+    <p:notesMasterId xmlns:r="http://schemas.openxmlformats.org/officeDocument/2006/relationships" r:id="Rd95ecd9a7677438d"/>
   </p:notesMasterIdLst>
   <p:sldIdLst>
-    <p:sldId xmlns:r="http://schemas.openxmlformats.org/officeDocument/2006/relationships" id="256" r:id="R51a0d549767744e2"/>
-    <p:sldId xmlns:r="http://schemas.openxmlformats.org/officeDocument/2006/relationships" id="257" r:id="R310d26616d2a47b6"/>
-    <p:sldId xmlns:r="http://schemas.openxmlformats.org/officeDocument/2006/relationships" id="258" r:id="Rccfb459c76754f30"/>
-    <p:sldId xmlns:r="http://schemas.openxmlformats.org/officeDocument/2006/relationships" id="259" r:id="R2888ce109f2f4180"/>
-    <p:sldId xmlns:r="http://schemas.openxmlformats.org/officeDocument/2006/relationships" id="260" r:id="R79ae699800374de1"/>
-    <p:sldId xmlns:r="http://schemas.openxmlformats.org/officeDocument/2006/relationships" id="261" r:id="R4997fd9e36ac4e05"/>
-    <p:sldId xmlns:r="http://schemas.openxmlformats.org/officeDocument/2006/relationships" id="262" r:id="Rb304738143204cb8"/>
-    <p:sldId xmlns:r="http://schemas.openxmlformats.org/officeDocument/2006/relationships" id="263" r:id="Ra467557692934af4"/>
-    <p:sldId xmlns:r="http://schemas.openxmlformats.org/officeDocument/2006/relationships" id="264" r:id="Rfa2219f6e3524b68"/>
-    <p:sldId xmlns:r="http://schemas.openxmlformats.org/officeDocument/2006/relationships" id="265" r:id="Re3ebf069ed0f45bc"/>
-    <p:sldId xmlns:r="http://schemas.openxmlformats.org/officeDocument/2006/relationships" id="266" r:id="R4d653e53ca574ae7"/>
-    <p:sldId xmlns:r="http://schemas.openxmlformats.org/officeDocument/2006/relationships" id="267" r:id="R52352be603dc433e"/>
-    <p:sldId xmlns:r="http://schemas.openxmlformats.org/officeDocument/2006/relationships" id="268" r:id="Rcee626623e104a88"/>
-    <p:sldId xmlns:r="http://schemas.openxmlformats.org/officeDocument/2006/relationships" id="269" r:id="R8bfdba68f27d4014"/>
-    <p:sldId xmlns:r="http://schemas.openxmlformats.org/officeDocument/2006/relationships" id="270" r:id="Rca0dde7c83524330"/>
-    <p:sldId xmlns:r="http://schemas.openxmlformats.org/officeDocument/2006/relationships" id="271" r:id="Rd989a1da6e3a4578"/>
+    <p:sldId xmlns:r="http://schemas.openxmlformats.org/officeDocument/2006/relationships" id="256" r:id="R4fa7b17475e14f07"/>
+    <p:sldId xmlns:r="http://schemas.openxmlformats.org/officeDocument/2006/relationships" id="257" r:id="Rcadf78fb237243dd"/>
+    <p:sldId xmlns:r="http://schemas.openxmlformats.org/officeDocument/2006/relationships" id="258" r:id="R878b4d678bdc4a15"/>
+    <p:sldId xmlns:r="http://schemas.openxmlformats.org/officeDocument/2006/relationships" id="259" r:id="Rbde1a575af7e43bc"/>
+    <p:sldId xmlns:r="http://schemas.openxmlformats.org/officeDocument/2006/relationships" id="260" r:id="Rc23f9dedb47042a9"/>
+    <p:sldId xmlns:r="http://schemas.openxmlformats.org/officeDocument/2006/relationships" id="261" r:id="R958eed59a12e4092"/>
+    <p:sldId xmlns:r="http://schemas.openxmlformats.org/officeDocument/2006/relationships" id="262" r:id="R8285a3babe864669"/>
+    <p:sldId xmlns:r="http://schemas.openxmlformats.org/officeDocument/2006/relationships" id="263" r:id="R2e0230c2de9c4e6b"/>
+    <p:sldId xmlns:r="http://schemas.openxmlformats.org/officeDocument/2006/relationships" id="264" r:id="Rda5c3e12dfd0494e"/>
+    <p:sldId xmlns:r="http://schemas.openxmlformats.org/officeDocument/2006/relationships" id="265" r:id="R7d3c7f1235214172"/>
+    <p:sldId xmlns:r="http://schemas.openxmlformats.org/officeDocument/2006/relationships" id="266" r:id="Rd035aa692a19416d"/>
+    <p:sldId xmlns:r="http://schemas.openxmlformats.org/officeDocument/2006/relationships" id="267" r:id="R3f2eb710c0504b77"/>
+    <p:sldId xmlns:r="http://schemas.openxmlformats.org/officeDocument/2006/relationships" id="268" r:id="R4516a5d19fa84527"/>
+    <p:sldId xmlns:r="http://schemas.openxmlformats.org/officeDocument/2006/relationships" id="269" r:id="Ra64d46bb2f3844c2"/>
+    <p:sldId xmlns:r="http://schemas.openxmlformats.org/officeDocument/2006/relationships" id="270" r:id="R324811c78412443e"/>
+    <p:sldId xmlns:r="http://schemas.openxmlformats.org/officeDocument/2006/relationships" id="271" r:id="R9971fd86d1774f81"/>
   </p:sldIdLst>
   <p:sldSz cx="12192000" cy="6858000"/>
   <p:notesSz cx="6858000" cy="9144000"/>
@@ -1701,7 +1701,7 @@
   </p:cSld>
   <p:clrMap bg1="lt1" tx1="dk1" bg2="lt2" tx2="dk2" accent1="accent1" accent2="accent2" accent3="accent3" accent4="accent4" accent5="accent5" accent6="accent6" hlink="hlink" folHlink="folHlink"/>
   <p:sldLayoutIdLst>
-    <p:sldLayoutId xmlns:r="http://schemas.openxmlformats.org/officeDocument/2006/relationships" id="2147483649" r:id="Re7187872bf834dbb"/>
+    <p:sldLayoutId xmlns:r="http://schemas.openxmlformats.org/officeDocument/2006/relationships" id="2147483649" r:id="R5544673595974ee7"/>
   </p:sldLayoutIdLst>
   <p:txStyles>
     <p:titleStyle>
@@ -2252,7 +2252,7 @@
           <p:cNvPr id="12" name="">
             <a:extLst xmlns:a="http://schemas.openxmlformats.org/drawingml/2006/main">
               <a:ext uri="{FF2B5EF4-FFF2-40B4-BE49-F238E27FC236}">
-                <a16:creationId xmlns:a16="http://schemas.microsoft.com/office/drawing/2014/main" id="{9CD006CA-AD13-4DA3-83F6-D67DB603448A}"/>
+                <a16:creationId xmlns:a16="http://schemas.microsoft.com/office/drawing/2014/main" id="{4CA99EBA-3E73-446F-B646-CB4A6E4B0432}"/>
               </a:ext>
             </a:extLst>
           </p:cNvPr>
@@ -2283,7 +2283,7 @@
           <p:cNvPr id="2" name="">
             <a:extLst xmlns:a="http://schemas.openxmlformats.org/drawingml/2006/main">
               <a:ext uri="{FF2B5EF4-FFF2-40B4-BE49-F238E27FC236}">
-                <a16:creationId xmlns:a16="http://schemas.microsoft.com/office/drawing/2014/main" id="{D0FB1CC2-BDBB-4675-86A6-9E5A1E63A6AC}"/>
+                <a16:creationId xmlns:a16="http://schemas.microsoft.com/office/drawing/2014/main" id="{9302F782-2E1B-4118-AC17-46A36B8A2E3A}"/>
               </a:ext>
             </a:extLst>
           </p:cNvPr>
@@ -2314,7 +2314,7 @@
           <p:cNvPr id="3" name="">
             <a:extLst xmlns:a="http://schemas.openxmlformats.org/drawingml/2006/main">
               <a:ext uri="{FF2B5EF4-FFF2-40B4-BE49-F238E27FC236}">
-                <a16:creationId xmlns:a16="http://schemas.microsoft.com/office/drawing/2014/main" id="{75E37488-C868-42C2-AD55-9A8F8AFE8298}"/>
+                <a16:creationId xmlns:a16="http://schemas.microsoft.com/office/drawing/2014/main" id="{758AE0EE-AC63-4214-80D3-AE7D9F374778}"/>
               </a:ext>
             </a:extLst>
           </p:cNvPr>
@@ -2376,7 +2376,7 @@
           <p:cNvPr id="4" name="">
             <a:extLst xmlns:a="http://schemas.openxmlformats.org/drawingml/2006/main">
               <a:ext uri="{FF2B5EF4-FFF2-40B4-BE49-F238E27FC236}">
-                <a16:creationId xmlns:a16="http://schemas.microsoft.com/office/drawing/2014/main" id="{77107A0C-A2A6-4FE4-80E0-7110359E6149}"/>
+                <a16:creationId xmlns:a16="http://schemas.microsoft.com/office/drawing/2014/main" id="{3535D666-A39C-4D44-87C0-DDCB1B43FCD7}"/>
               </a:ext>
             </a:extLst>
           </p:cNvPr>
@@ -2438,7 +2438,7 @@
           <p:cNvPr id="5" name="">
             <a:extLst xmlns:a="http://schemas.openxmlformats.org/drawingml/2006/main">
               <a:ext uri="{FF2B5EF4-FFF2-40B4-BE49-F238E27FC236}">
-                <a16:creationId xmlns:a16="http://schemas.microsoft.com/office/drawing/2014/main" id="{03CFC7A5-C5BF-4CC1-B75C-48F4505203EB}"/>
+                <a16:creationId xmlns:a16="http://schemas.microsoft.com/office/drawing/2014/main" id="{206EBA74-7BC5-4724-99A3-03EBC0F0C0B9}"/>
               </a:ext>
             </a:extLst>
           </p:cNvPr>
@@ -2500,7 +2500,7 @@
           <p:cNvPr id="6" name="">
             <a:extLst xmlns:a="http://schemas.openxmlformats.org/drawingml/2006/main">
               <a:ext uri="{FF2B5EF4-FFF2-40B4-BE49-F238E27FC236}">
-                <a16:creationId xmlns:a16="http://schemas.microsoft.com/office/drawing/2014/main" id="{7879FA35-7128-4179-88C7-4B329D3C6444}"/>
+                <a16:creationId xmlns:a16="http://schemas.microsoft.com/office/drawing/2014/main" id="{D6550C18-BC7F-4E46-9F70-4CCB0C0BCADE}"/>
               </a:ext>
             </a:extLst>
           </p:cNvPr>
@@ -2562,7 +2562,7 @@
           <p:cNvPr id="7" name="">
             <a:extLst xmlns:a="http://schemas.openxmlformats.org/drawingml/2006/main">
               <a:ext uri="{FF2B5EF4-FFF2-40B4-BE49-F238E27FC236}">
-                <a16:creationId xmlns:a16="http://schemas.microsoft.com/office/drawing/2014/main" id="{21353CFD-92A9-4D31-BC2F-A150AD031F39}"/>
+                <a16:creationId xmlns:a16="http://schemas.microsoft.com/office/drawing/2014/main" id="{D0368360-A696-46F9-AE84-0B8D2A7BD817}"/>
               </a:ext>
             </a:extLst>
           </p:cNvPr>
@@ -2624,7 +2624,7 @@
           <p:cNvPr id="8" name="">
             <a:extLst xmlns:a="http://schemas.openxmlformats.org/drawingml/2006/main">
               <a:ext uri="{FF2B5EF4-FFF2-40B4-BE49-F238E27FC236}">
-                <a16:creationId xmlns:a16="http://schemas.microsoft.com/office/drawing/2014/main" id="{7794A69F-6A27-41A9-9C3B-FF69792B0E43}"/>
+                <a16:creationId xmlns:a16="http://schemas.microsoft.com/office/drawing/2014/main" id="{9B0FD73B-843A-484C-8915-604D01072FDB}"/>
               </a:ext>
             </a:extLst>
           </p:cNvPr>
@@ -2686,7 +2686,7 @@
           <p:cNvPr id="9" name="">
             <a:extLst xmlns:a="http://schemas.openxmlformats.org/drawingml/2006/main">
               <a:ext uri="{FF2B5EF4-FFF2-40B4-BE49-F238E27FC236}">
-                <a16:creationId xmlns:a16="http://schemas.microsoft.com/office/drawing/2014/main" id="{374C511F-B864-4CBB-83ED-E785B39C8B8E}"/>
+                <a16:creationId xmlns:a16="http://schemas.microsoft.com/office/drawing/2014/main" id="{40A752B5-15F8-479E-B345-DA21EF69E1DC}"/>
               </a:ext>
             </a:extLst>
           </p:cNvPr>
@@ -2752,7 +2752,7 @@
           <p:nvPr/>
         </p:nvPicPr>
         <p:blipFill>
-          <a:blip xmlns:r="http://schemas.openxmlformats.org/officeDocument/2006/relationships" xmlns:a="http://schemas.openxmlformats.org/drawingml/2006/main" r:embed="R8195e5e697884890"/>
+          <a:blip xmlns:r="http://schemas.openxmlformats.org/officeDocument/2006/relationships" xmlns:a="http://schemas.openxmlformats.org/drawingml/2006/main" r:embed="R7b726b28be5d4d3e"/>
           <a:srcRect xmlns:a="http://schemas.openxmlformats.org/drawingml/2006/main" l="0" t="0" r="0" b="0"/>
           <a:stretch xmlns:a="http://schemas.openxmlformats.org/drawingml/2006/main">
             <a:fillRect l="0" t="0" r="0" b="0"/>
@@ -2773,7 +2773,7 @@
           <p:cNvPr id="11" name="">
             <a:extLst xmlns:a="http://schemas.openxmlformats.org/drawingml/2006/main">
               <a:ext uri="{FF2B5EF4-FFF2-40B4-BE49-F238E27FC236}">
-                <a16:creationId xmlns:a16="http://schemas.microsoft.com/office/drawing/2014/main" id="{9E8EAE10-E193-47A2-B6AB-1B71157930A9}"/>
+                <a16:creationId xmlns:a16="http://schemas.microsoft.com/office/drawing/2014/main" id="{73DB4F14-F061-4900-AC48-4810953DC76E}"/>
               </a:ext>
             </a:extLst>
           </p:cNvPr>
@@ -2833,7 +2833,7 @@
     </p:spTree>
     <p:extLst>
       <p:ext uri="{BB962C8B-B14F-4D97-AF65-F5344CB8AC3E}">
-        <p14:creationId xmlns:p14="http://schemas.microsoft.com/office/powerpoint/2010/main" val="1709962622"/>
+        <p14:creationId xmlns:p14="http://schemas.microsoft.com/office/powerpoint/2010/main" val="28997455"/>
       </p:ext>
     </p:extLst>
   </p:cSld>
@@ -2864,7 +2864,7 @@
           <p:cNvPr id="17" name="">
             <a:extLst xmlns:a="http://schemas.openxmlformats.org/drawingml/2006/main">
               <a:ext uri="{FF2B5EF4-FFF2-40B4-BE49-F238E27FC236}">
-                <a16:creationId xmlns:a16="http://schemas.microsoft.com/office/drawing/2014/main" id="{6BB1077F-B824-4564-BF8C-469CD261B3B8}"/>
+                <a16:creationId xmlns:a16="http://schemas.microsoft.com/office/drawing/2014/main" id="{6B96E7F7-237A-44CA-B578-E5364C443C77}"/>
               </a:ext>
             </a:extLst>
           </p:cNvPr>
@@ -2895,7 +2895,7 @@
           <p:cNvPr id="2" name="">
             <a:extLst xmlns:a="http://schemas.openxmlformats.org/drawingml/2006/main">
               <a:ext uri="{FF2B5EF4-FFF2-40B4-BE49-F238E27FC236}">
-                <a16:creationId xmlns:a16="http://schemas.microsoft.com/office/drawing/2014/main" id="{C98EB440-6180-4C7A-B2D1-93EA53B3B447}"/>
+                <a16:creationId xmlns:a16="http://schemas.microsoft.com/office/drawing/2014/main" id="{93853B56-5DFF-4D85-95D6-B202CFFC551B}"/>
               </a:ext>
             </a:extLst>
           </p:cNvPr>
@@ -2957,7 +2957,7 @@
           <p:cNvPr id="3" name="">
             <a:extLst xmlns:a="http://schemas.openxmlformats.org/drawingml/2006/main">
               <a:ext uri="{FF2B5EF4-FFF2-40B4-BE49-F238E27FC236}">
-                <a16:creationId xmlns:a16="http://schemas.microsoft.com/office/drawing/2014/main" id="{FB0CAF79-4BBB-4E42-B0A6-02799827AB0E}"/>
+                <a16:creationId xmlns:a16="http://schemas.microsoft.com/office/drawing/2014/main" id="{C5CD22E2-CE91-4F3F-93C2-E4D7CAFAEFFF}"/>
               </a:ext>
             </a:extLst>
           </p:cNvPr>
@@ -2982,7 +2982,7 @@
         </p:spPr>
         <p:txBody>
           <a:bodyPr xmlns:a="http://schemas.openxmlformats.org/drawingml/2006/main" lIns="76200" tIns="57150" rIns="76200" bIns="57150" anchor="ctr">
-            <a:normAutofit fontScale="86571"/>
+            <a:normAutofit fontScale="100000"/>
           </a:bodyPr>
           <a:lstStyle xmlns:a="http://schemas.openxmlformats.org/drawingml/2006/main"/>
           <a:p xmlns:a="http://schemas.openxmlformats.org/drawingml/2006/main">
@@ -2991,7 +2991,7 @@
                 <a:spcPct val="108000"/>
               </a:lnSpc>
               <a:buNone/>
-              <a:defRPr sz="2700" b="1">
+              <a:defRPr sz="2250" b="1">
                 <a:solidFill>
                   <a:srgbClr val="071426"/>
                 </a:solidFill>
@@ -3001,7 +3001,7 @@
               </a:defRPr>
             </a:pPr>
             <a:r>
-              <a:rPr sz="2700" b="1">
+              <a:rPr sz="2250" b="1">
                 <a:solidFill>
                   <a:srgbClr val="071426"/>
                 </a:solidFill>
@@ -3019,7 +3019,7 @@
           <p:cNvPr id="4" name="">
             <a:extLst xmlns:a="http://schemas.openxmlformats.org/drawingml/2006/main">
               <a:ext uri="{FF2B5EF4-FFF2-40B4-BE49-F238E27FC236}">
-                <a16:creationId xmlns:a16="http://schemas.microsoft.com/office/drawing/2014/main" id="{CC412FA1-64C9-4947-BE72-25857C03B771}"/>
+                <a16:creationId xmlns:a16="http://schemas.microsoft.com/office/drawing/2014/main" id="{E4261EF6-2BFC-44F0-8B05-58ABF20A082F}"/>
               </a:ext>
             </a:extLst>
           </p:cNvPr>
@@ -3054,7 +3054,7 @@
           <p:nvPr/>
         </p:nvPicPr>
         <p:blipFill>
-          <a:blip xmlns:r="http://schemas.openxmlformats.org/officeDocument/2006/relationships" xmlns:a="http://schemas.openxmlformats.org/drawingml/2006/main" r:embed="R9a6ca0df667846c4"/>
+          <a:blip xmlns:r="http://schemas.openxmlformats.org/officeDocument/2006/relationships" xmlns:a="http://schemas.openxmlformats.org/drawingml/2006/main" r:embed="R3f5068ec5572418d"/>
           <a:srcRect xmlns:a="http://schemas.openxmlformats.org/drawingml/2006/main" l="0" t="0" r="0" b="0"/>
           <a:stretch xmlns:a="http://schemas.openxmlformats.org/drawingml/2006/main">
             <a:fillRect l="0" t="0" r="0" b="0"/>
@@ -3075,7 +3075,7 @@
           <p:cNvPr id="6" name="">
             <a:extLst xmlns:a="http://schemas.openxmlformats.org/drawingml/2006/main">
               <a:ext uri="{FF2B5EF4-FFF2-40B4-BE49-F238E27FC236}">
-                <a16:creationId xmlns:a16="http://schemas.microsoft.com/office/drawing/2014/main" id="{B95F42CE-2904-4A35-9839-339F9BFCB403}"/>
+                <a16:creationId xmlns:a16="http://schemas.microsoft.com/office/drawing/2014/main" id="{27ED67B4-DC60-4CCF-86EF-CE2385FE3146}"/>
               </a:ext>
             </a:extLst>
           </p:cNvPr>
@@ -3137,7 +3137,7 @@
           <p:cNvPr id="7" name="">
             <a:extLst xmlns:a="http://schemas.openxmlformats.org/drawingml/2006/main">
               <a:ext uri="{FF2B5EF4-FFF2-40B4-BE49-F238E27FC236}">
-                <a16:creationId xmlns:a16="http://schemas.microsoft.com/office/drawing/2014/main" id="{EC1F2804-0D15-465C-9649-6ECF38ECCE5C}"/>
+                <a16:creationId xmlns:a16="http://schemas.microsoft.com/office/drawing/2014/main" id="{386B4B0D-7B1E-4841-B22E-AB3D55F53654}"/>
               </a:ext>
             </a:extLst>
           </p:cNvPr>
@@ -3199,7 +3199,7 @@
           <p:cNvPr id="8" name="">
             <a:extLst xmlns:a="http://schemas.openxmlformats.org/drawingml/2006/main">
               <a:ext uri="{FF2B5EF4-FFF2-40B4-BE49-F238E27FC236}">
-                <a16:creationId xmlns:a16="http://schemas.microsoft.com/office/drawing/2014/main" id="{62FAD33E-1ECE-44C2-B9B0-C40D8DCCAD2C}"/>
+                <a16:creationId xmlns:a16="http://schemas.microsoft.com/office/drawing/2014/main" id="{6933833F-7D74-482F-A97E-10DFF9B01438}"/>
               </a:ext>
             </a:extLst>
           </p:cNvPr>
@@ -3234,7 +3234,7 @@
           <p:cNvPr id="9" name="">
             <a:extLst xmlns:a="http://schemas.openxmlformats.org/drawingml/2006/main">
               <a:ext uri="{FF2B5EF4-FFF2-40B4-BE49-F238E27FC236}">
-                <a16:creationId xmlns:a16="http://schemas.microsoft.com/office/drawing/2014/main" id="{CCB74AC2-D990-403F-8C8B-1438F04C9371}"/>
+                <a16:creationId xmlns:a16="http://schemas.microsoft.com/office/drawing/2014/main" id="{8A5E1B95-DF23-4249-9CA8-9E1D67E4D0D7}"/>
               </a:ext>
             </a:extLst>
           </p:cNvPr>
@@ -3265,7 +3265,7 @@
           <p:cNvPr id="10" name="">
             <a:extLst xmlns:a="http://schemas.openxmlformats.org/drawingml/2006/main">
               <a:ext uri="{FF2B5EF4-FFF2-40B4-BE49-F238E27FC236}">
-                <a16:creationId xmlns:a16="http://schemas.microsoft.com/office/drawing/2014/main" id="{8F2510E0-0BF4-4874-B525-C4CAEA91C281}"/>
+                <a16:creationId xmlns:a16="http://schemas.microsoft.com/office/drawing/2014/main" id="{1999A38E-618E-400F-B2E2-04A693011B76}"/>
               </a:ext>
             </a:extLst>
           </p:cNvPr>
@@ -3327,7 +3327,7 @@
           <p:cNvPr id="11" name="">
             <a:extLst xmlns:a="http://schemas.openxmlformats.org/drawingml/2006/main">
               <a:ext uri="{FF2B5EF4-FFF2-40B4-BE49-F238E27FC236}">
-                <a16:creationId xmlns:a16="http://schemas.microsoft.com/office/drawing/2014/main" id="{737A8658-520C-4C24-8A0B-5EF37F9446A3}"/>
+                <a16:creationId xmlns:a16="http://schemas.microsoft.com/office/drawing/2014/main" id="{5ED6B055-6972-4FC5-A012-B5F57F54A9BD}"/>
               </a:ext>
             </a:extLst>
           </p:cNvPr>
@@ -3443,7 +3443,7 @@
           <p:cNvPr id="12" name="">
             <a:extLst xmlns:a="http://schemas.openxmlformats.org/drawingml/2006/main">
               <a:ext uri="{FF2B5EF4-FFF2-40B4-BE49-F238E27FC236}">
-                <a16:creationId xmlns:a16="http://schemas.microsoft.com/office/drawing/2014/main" id="{20C40EFA-578F-441F-90A5-D3488CD10CC2}"/>
+                <a16:creationId xmlns:a16="http://schemas.microsoft.com/office/drawing/2014/main" id="{4E99206A-F5A6-464E-AF1B-87D5EE9DFE48}"/>
               </a:ext>
             </a:extLst>
           </p:cNvPr>
@@ -3478,7 +3478,7 @@
           <p:cNvPr id="13" name="">
             <a:extLst xmlns:a="http://schemas.openxmlformats.org/drawingml/2006/main">
               <a:ext uri="{FF2B5EF4-FFF2-40B4-BE49-F238E27FC236}">
-                <a16:creationId xmlns:a16="http://schemas.microsoft.com/office/drawing/2014/main" id="{AC928EDA-CAA6-4506-965A-315C23BC4CDF}"/>
+                <a16:creationId xmlns:a16="http://schemas.microsoft.com/office/drawing/2014/main" id="{29A3BA98-5769-46A2-BA75-6C210333C583}"/>
               </a:ext>
             </a:extLst>
           </p:cNvPr>
@@ -3509,7 +3509,7 @@
           <p:cNvPr id="14" name="">
             <a:extLst xmlns:a="http://schemas.openxmlformats.org/drawingml/2006/main">
               <a:ext uri="{FF2B5EF4-FFF2-40B4-BE49-F238E27FC236}">
-                <a16:creationId xmlns:a16="http://schemas.microsoft.com/office/drawing/2014/main" id="{88F6A0A2-9410-457D-928D-6E58E52877DA}"/>
+                <a16:creationId xmlns:a16="http://schemas.microsoft.com/office/drawing/2014/main" id="{F1C901CC-9525-485D-BA25-CBF9574D8478}"/>
               </a:ext>
             </a:extLst>
           </p:cNvPr>
@@ -3571,7 +3571,7 @@
           <p:cNvPr id="15" name="">
             <a:extLst xmlns:a="http://schemas.openxmlformats.org/drawingml/2006/main">
               <a:ext uri="{FF2B5EF4-FFF2-40B4-BE49-F238E27FC236}">
-                <a16:creationId xmlns:a16="http://schemas.microsoft.com/office/drawing/2014/main" id="{4F671B05-9E5A-4B02-BFE9-43E373FB5CDA}"/>
+                <a16:creationId xmlns:a16="http://schemas.microsoft.com/office/drawing/2014/main" id="{2D847351-DAA1-4BF3-9902-C0195942A27A}"/>
               </a:ext>
             </a:extLst>
           </p:cNvPr>
@@ -3687,7 +3687,7 @@
           <p:cNvPr id="16" name="">
             <a:extLst xmlns:a="http://schemas.openxmlformats.org/drawingml/2006/main">
               <a:ext uri="{FF2B5EF4-FFF2-40B4-BE49-F238E27FC236}">
-                <a16:creationId xmlns:a16="http://schemas.microsoft.com/office/drawing/2014/main" id="{E0AA923E-5DD0-4119-94AC-77FFD6438BDD}"/>
+                <a16:creationId xmlns:a16="http://schemas.microsoft.com/office/drawing/2014/main" id="{F56141A1-0014-4490-A104-673582CC242A}"/>
               </a:ext>
             </a:extLst>
           </p:cNvPr>
@@ -3749,7 +3749,7 @@
     </p:spTree>
     <p:extLst>
       <p:ext uri="{BB962C8B-B14F-4D97-AF65-F5344CB8AC3E}">
-        <p14:creationId xmlns:p14="http://schemas.microsoft.com/office/powerpoint/2010/main" val="1030196586"/>
+        <p14:creationId xmlns:p14="http://schemas.microsoft.com/office/powerpoint/2010/main" val="286101656"/>
       </p:ext>
     </p:extLst>
   </p:cSld>
@@ -3780,7 +3780,7 @@
           <p:cNvPr id="25" name="">
             <a:extLst xmlns:a="http://schemas.openxmlformats.org/drawingml/2006/main">
               <a:ext uri="{FF2B5EF4-FFF2-40B4-BE49-F238E27FC236}">
-                <a16:creationId xmlns:a16="http://schemas.microsoft.com/office/drawing/2014/main" id="{D225BD4A-16E4-4EC9-AC5C-54F0F58855A7}"/>
+                <a16:creationId xmlns:a16="http://schemas.microsoft.com/office/drawing/2014/main" id="{7D115CCA-B5E2-4BFE-BBF9-3869B25CBDEC}"/>
               </a:ext>
             </a:extLst>
           </p:cNvPr>
@@ -3811,7 +3811,7 @@
           <p:cNvPr id="2" name="">
             <a:extLst xmlns:a="http://schemas.openxmlformats.org/drawingml/2006/main">
               <a:ext uri="{FF2B5EF4-FFF2-40B4-BE49-F238E27FC236}">
-                <a16:creationId xmlns:a16="http://schemas.microsoft.com/office/drawing/2014/main" id="{51B922E0-AF31-470B-B1FF-52D8167D2F90}"/>
+                <a16:creationId xmlns:a16="http://schemas.microsoft.com/office/drawing/2014/main" id="{3E267EE2-B8EC-4181-9A8F-60181E9F3D48}"/>
               </a:ext>
             </a:extLst>
           </p:cNvPr>
@@ -3863,7 +3863,7 @@
                 <a:ea typeface="Aptos"/>
                 <a:cs typeface="Aptos"/>
               </a:rPr>
-              <a:t>ΤΡΑΠΕΖΕΣ</a:t>
+              <a:t>ΠΑΓΚΟΣΜΙΑ ΟΙΚΟΝΟΜΙΑ</a:t>
             </a:r>
           </a:p>
         </p:txBody>
@@ -3873,7 +3873,7 @@
           <p:cNvPr id="3" name="">
             <a:extLst xmlns:a="http://schemas.openxmlformats.org/drawingml/2006/main">
               <a:ext uri="{FF2B5EF4-FFF2-40B4-BE49-F238E27FC236}">
-                <a16:creationId xmlns:a16="http://schemas.microsoft.com/office/drawing/2014/main" id="{072F5B41-1EDA-428D-A86F-2563E690E032}"/>
+                <a16:creationId xmlns:a16="http://schemas.microsoft.com/office/drawing/2014/main" id="{2E69E348-5E2F-449E-9982-25E1BAB2C292}"/>
               </a:ext>
             </a:extLst>
           </p:cNvPr>
@@ -3907,7 +3907,7 @@
                 <a:spcPct val="108000"/>
               </a:lnSpc>
               <a:buNone/>
-              <a:defRPr sz="3150" b="1">
+              <a:defRPr sz="2250" b="1">
                 <a:solidFill>
                   <a:srgbClr val="071426"/>
                 </a:solidFill>
@@ -3917,7 +3917,7 @@
               </a:defRPr>
             </a:pPr>
             <a:r>
-              <a:rPr sz="3150" b="1">
+              <a:rPr sz="2250" b="1">
                 <a:solidFill>
                   <a:srgbClr val="071426"/>
                 </a:solidFill>
@@ -3935,7 +3935,7 @@
           <p:cNvPr id="4" name="">
             <a:extLst xmlns:a="http://schemas.openxmlformats.org/drawingml/2006/main">
               <a:ext uri="{FF2B5EF4-FFF2-40B4-BE49-F238E27FC236}">
-                <a16:creationId xmlns:a16="http://schemas.microsoft.com/office/drawing/2014/main" id="{8D58E797-C326-4888-B26F-E459DE85E2B2}"/>
+                <a16:creationId xmlns:a16="http://schemas.microsoft.com/office/drawing/2014/main" id="{6F7FA234-DEED-49FC-BC7E-DE911FBCEE6F}"/>
               </a:ext>
             </a:extLst>
           </p:cNvPr>
@@ -3970,7 +3970,7 @@
           <p:nvPr/>
         </p:nvPicPr>
         <p:blipFill>
-          <a:blip xmlns:r="http://schemas.openxmlformats.org/officeDocument/2006/relationships" xmlns:a="http://schemas.openxmlformats.org/drawingml/2006/main" r:embed="R6c342f864ccc4822"/>
+          <a:blip xmlns:r="http://schemas.openxmlformats.org/officeDocument/2006/relationships" xmlns:a="http://schemas.openxmlformats.org/drawingml/2006/main" r:embed="Rd5d3bb544f894410"/>
           <a:srcRect xmlns:a="http://schemas.openxmlformats.org/drawingml/2006/main" l="0" t="0" r="0" b="0"/>
           <a:stretch xmlns:a="http://schemas.openxmlformats.org/drawingml/2006/main">
             <a:fillRect l="0" t="0" r="0" b="0"/>
@@ -3991,7 +3991,7 @@
           <p:cNvPr id="6" name="">
             <a:extLst xmlns:a="http://schemas.openxmlformats.org/drawingml/2006/main">
               <a:ext uri="{FF2B5EF4-FFF2-40B4-BE49-F238E27FC236}">
-                <a16:creationId xmlns:a16="http://schemas.microsoft.com/office/drawing/2014/main" id="{8FBB20DB-7083-4FE3-ACE5-5ABC4676AA4A}"/>
+                <a16:creationId xmlns:a16="http://schemas.microsoft.com/office/drawing/2014/main" id="{7ACB9B98-BC65-45AD-87F5-0736BAFA57D8}"/>
               </a:ext>
             </a:extLst>
           </p:cNvPr>
@@ -4053,7 +4053,7 @@
           <p:cNvPr id="7" name="">
             <a:extLst xmlns:a="http://schemas.openxmlformats.org/drawingml/2006/main">
               <a:ext uri="{FF2B5EF4-FFF2-40B4-BE49-F238E27FC236}">
-                <a16:creationId xmlns:a16="http://schemas.microsoft.com/office/drawing/2014/main" id="{1718A8BC-A8A7-48ED-93A2-DEAA1DC657EF}"/>
+                <a16:creationId xmlns:a16="http://schemas.microsoft.com/office/drawing/2014/main" id="{B6038E16-B056-470A-9C6C-BD62EB7E2B34}"/>
               </a:ext>
             </a:extLst>
           </p:cNvPr>
@@ -4115,7 +4115,7 @@
           <p:cNvPr id="8" name="">
             <a:extLst xmlns:a="http://schemas.openxmlformats.org/drawingml/2006/main">
               <a:ext uri="{FF2B5EF4-FFF2-40B4-BE49-F238E27FC236}">
-                <a16:creationId xmlns:a16="http://schemas.microsoft.com/office/drawing/2014/main" id="{F18B95D5-6CF0-4E61-87C4-B50F4D3212F0}"/>
+                <a16:creationId xmlns:a16="http://schemas.microsoft.com/office/drawing/2014/main" id="{5498C571-F96F-4EE6-BD9B-70A9E27F2A9B}"/>
               </a:ext>
             </a:extLst>
           </p:cNvPr>
@@ -4150,7 +4150,7 @@
           <p:cNvPr id="9" name="">
             <a:extLst xmlns:a="http://schemas.openxmlformats.org/drawingml/2006/main">
               <a:ext uri="{FF2B5EF4-FFF2-40B4-BE49-F238E27FC236}">
-                <a16:creationId xmlns:a16="http://schemas.microsoft.com/office/drawing/2014/main" id="{CAC10A09-B48D-4D4A-8A9A-974CE779F172}"/>
+                <a16:creationId xmlns:a16="http://schemas.microsoft.com/office/drawing/2014/main" id="{76755059-EC44-44DE-961F-A095E6B27B00}"/>
               </a:ext>
             </a:extLst>
           </p:cNvPr>
@@ -4181,7 +4181,7 @@
           <p:cNvPr id="10" name="">
             <a:extLst xmlns:a="http://schemas.openxmlformats.org/drawingml/2006/main">
               <a:ext uri="{FF2B5EF4-FFF2-40B4-BE49-F238E27FC236}">
-                <a16:creationId xmlns:a16="http://schemas.microsoft.com/office/drawing/2014/main" id="{5592E5D0-24E2-4231-A4EC-4167063C9F67}"/>
+                <a16:creationId xmlns:a16="http://schemas.microsoft.com/office/drawing/2014/main" id="{3423C287-0C0B-4C74-A833-CFC87EE3D776}"/>
               </a:ext>
             </a:extLst>
           </p:cNvPr>
@@ -4243,7 +4243,7 @@
           <p:cNvPr id="11" name="">
             <a:extLst xmlns:a="http://schemas.openxmlformats.org/drawingml/2006/main">
               <a:ext uri="{FF2B5EF4-FFF2-40B4-BE49-F238E27FC236}">
-                <a16:creationId xmlns:a16="http://schemas.microsoft.com/office/drawing/2014/main" id="{C6688BB1-4BA9-408F-9058-04B207DC7860}"/>
+                <a16:creationId xmlns:a16="http://schemas.microsoft.com/office/drawing/2014/main" id="{F3FD2344-C8D5-45D9-A8AE-AAC1ABC98A6A}"/>
               </a:ext>
             </a:extLst>
           </p:cNvPr>
@@ -4305,7 +4305,7 @@
           <p:cNvPr id="12" name="">
             <a:extLst xmlns:a="http://schemas.openxmlformats.org/drawingml/2006/main">
               <a:ext uri="{FF2B5EF4-FFF2-40B4-BE49-F238E27FC236}">
-                <a16:creationId xmlns:a16="http://schemas.microsoft.com/office/drawing/2014/main" id="{570F9611-D148-46FE-B926-EF9B12033D93}"/>
+                <a16:creationId xmlns:a16="http://schemas.microsoft.com/office/drawing/2014/main" id="{30D75C05-97B7-4974-98C7-994DED9E7AE4}"/>
               </a:ext>
             </a:extLst>
           </p:cNvPr>
@@ -4340,7 +4340,7 @@
           <p:cNvPr id="13" name="">
             <a:extLst xmlns:a="http://schemas.openxmlformats.org/drawingml/2006/main">
               <a:ext uri="{FF2B5EF4-FFF2-40B4-BE49-F238E27FC236}">
-                <a16:creationId xmlns:a16="http://schemas.microsoft.com/office/drawing/2014/main" id="{F10FE900-F6C4-4502-8BB7-DFC65AAE4185}"/>
+                <a16:creationId xmlns:a16="http://schemas.microsoft.com/office/drawing/2014/main" id="{AB713A57-6A0F-49BF-AC0D-7488DFF7AD5B}"/>
               </a:ext>
             </a:extLst>
           </p:cNvPr>
@@ -4371,7 +4371,7 @@
           <p:cNvPr id="14" name="">
             <a:extLst xmlns:a="http://schemas.openxmlformats.org/drawingml/2006/main">
               <a:ext uri="{FF2B5EF4-FFF2-40B4-BE49-F238E27FC236}">
-                <a16:creationId xmlns:a16="http://schemas.microsoft.com/office/drawing/2014/main" id="{536BB582-CFAF-4EBC-A2D6-060BBC0DC087}"/>
+                <a16:creationId xmlns:a16="http://schemas.microsoft.com/office/drawing/2014/main" id="{B620ECD6-C0F6-4458-8A70-053A8527A9D7}"/>
               </a:ext>
             </a:extLst>
           </p:cNvPr>
@@ -4433,7 +4433,7 @@
           <p:cNvPr id="15" name="">
             <a:extLst xmlns:a="http://schemas.openxmlformats.org/drawingml/2006/main">
               <a:ext uri="{FF2B5EF4-FFF2-40B4-BE49-F238E27FC236}">
-                <a16:creationId xmlns:a16="http://schemas.microsoft.com/office/drawing/2014/main" id="{2CE3FA3A-9DF2-45C4-AB97-FD1EB9DFB2FD}"/>
+                <a16:creationId xmlns:a16="http://schemas.microsoft.com/office/drawing/2014/main" id="{16E49D33-8ACC-4615-89EE-0F762A6C2A12}"/>
               </a:ext>
             </a:extLst>
           </p:cNvPr>
@@ -4485,7 +4485,7 @@
                 <a:ea typeface="Aptos"/>
                 <a:cs typeface="Aptos"/>
               </a:rPr>
-              <a:t>Ταξιδιωτικά έσοδα 2025</a:t>
+              <a:t>Ταξιδιωτικά έσοδα 2025: 23,6268 δισ. ευρώ.</a:t>
             </a:r>
           </a:p>
         </p:txBody>
@@ -4495,7 +4495,7 @@
           <p:cNvPr id="16" name="">
             <a:extLst xmlns:a="http://schemas.openxmlformats.org/drawingml/2006/main">
               <a:ext uri="{FF2B5EF4-FFF2-40B4-BE49-F238E27FC236}">
-                <a16:creationId xmlns:a16="http://schemas.microsoft.com/office/drawing/2014/main" id="{2EE958E7-3A44-4F4B-84C6-ED7A7FE2A8C7}"/>
+                <a16:creationId xmlns:a16="http://schemas.microsoft.com/office/drawing/2014/main" id="{05A4BB9C-DE76-4FDE-9796-B38AD0819D6D}"/>
               </a:ext>
             </a:extLst>
           </p:cNvPr>
@@ -4530,7 +4530,7 @@
           <p:cNvPr id="17" name="">
             <a:extLst xmlns:a="http://schemas.openxmlformats.org/drawingml/2006/main">
               <a:ext uri="{FF2B5EF4-FFF2-40B4-BE49-F238E27FC236}">
-                <a16:creationId xmlns:a16="http://schemas.microsoft.com/office/drawing/2014/main" id="{9EB78819-D064-4B4F-9195-7C70F56CAE8D}"/>
+                <a16:creationId xmlns:a16="http://schemas.microsoft.com/office/drawing/2014/main" id="{19E73FC2-7BD0-4908-B523-A57CB29AA376}"/>
               </a:ext>
             </a:extLst>
           </p:cNvPr>
@@ -4561,7 +4561,7 @@
           <p:cNvPr id="18" name="">
             <a:extLst xmlns:a="http://schemas.openxmlformats.org/drawingml/2006/main">
               <a:ext uri="{FF2B5EF4-FFF2-40B4-BE49-F238E27FC236}">
-                <a16:creationId xmlns:a16="http://schemas.microsoft.com/office/drawing/2014/main" id="{03415CED-565E-4174-8214-5DE08E0CDDF6}"/>
+                <a16:creationId xmlns:a16="http://schemas.microsoft.com/office/drawing/2014/main" id="{64210AF9-8C95-4CF1-84A4-BC73DBDFF77F}"/>
               </a:ext>
             </a:extLst>
           </p:cNvPr>
@@ -4623,7 +4623,7 @@
           <p:cNvPr id="19" name="">
             <a:extLst xmlns:a="http://schemas.openxmlformats.org/drawingml/2006/main">
               <a:ext uri="{FF2B5EF4-FFF2-40B4-BE49-F238E27FC236}">
-                <a16:creationId xmlns:a16="http://schemas.microsoft.com/office/drawing/2014/main" id="{1E8480C3-8678-4DE6-87AA-073B4D273E95}"/>
+                <a16:creationId xmlns:a16="http://schemas.microsoft.com/office/drawing/2014/main" id="{17B1F727-5D9A-4C2F-9C56-AFCE35311FA2}"/>
               </a:ext>
             </a:extLst>
           </p:cNvPr>
@@ -4685,7 +4685,7 @@
           <p:cNvPr id="20" name="">
             <a:extLst xmlns:a="http://schemas.openxmlformats.org/drawingml/2006/main">
               <a:ext uri="{FF2B5EF4-FFF2-40B4-BE49-F238E27FC236}">
-                <a16:creationId xmlns:a16="http://schemas.microsoft.com/office/drawing/2014/main" id="{0AD447D4-CCE6-4DFA-A367-919C3EA0E01F}"/>
+                <a16:creationId xmlns:a16="http://schemas.microsoft.com/office/drawing/2014/main" id="{0DE27DEE-0AA8-452E-8CF3-1393BFD568CE}"/>
               </a:ext>
             </a:extLst>
           </p:cNvPr>
@@ -4720,7 +4720,7 @@
           <p:cNvPr id="21" name="">
             <a:extLst xmlns:a="http://schemas.openxmlformats.org/drawingml/2006/main">
               <a:ext uri="{FF2B5EF4-FFF2-40B4-BE49-F238E27FC236}">
-                <a16:creationId xmlns:a16="http://schemas.microsoft.com/office/drawing/2014/main" id="{87C99F1A-132A-455A-9635-ED6DFCFDB5C5}"/>
+                <a16:creationId xmlns:a16="http://schemas.microsoft.com/office/drawing/2014/main" id="{7C96BAC6-EAF8-48F1-B8F5-EAFCF80D68BC}"/>
               </a:ext>
             </a:extLst>
           </p:cNvPr>
@@ -4751,7 +4751,7 @@
           <p:cNvPr id="22" name="">
             <a:extLst xmlns:a="http://schemas.openxmlformats.org/drawingml/2006/main">
               <a:ext uri="{FF2B5EF4-FFF2-40B4-BE49-F238E27FC236}">
-                <a16:creationId xmlns:a16="http://schemas.microsoft.com/office/drawing/2014/main" id="{79C6A424-912D-43E6-A254-36A66264336B}"/>
+                <a16:creationId xmlns:a16="http://schemas.microsoft.com/office/drawing/2014/main" id="{F7FF23D7-F9DE-466A-A719-EE35E2FFC624}"/>
               </a:ext>
             </a:extLst>
           </p:cNvPr>
@@ -4813,7 +4813,7 @@
           <p:cNvPr id="23" name="">
             <a:extLst xmlns:a="http://schemas.openxmlformats.org/drawingml/2006/main">
               <a:ext uri="{FF2B5EF4-FFF2-40B4-BE49-F238E27FC236}">
-                <a16:creationId xmlns:a16="http://schemas.microsoft.com/office/drawing/2014/main" id="{2785E768-E18D-4266-A28C-7E27DFD2560B}"/>
+                <a16:creationId xmlns:a16="http://schemas.microsoft.com/office/drawing/2014/main" id="{3F9D6F2A-ABC4-4B5C-9C4F-EAC67B7E0C70}"/>
               </a:ext>
             </a:extLst>
           </p:cNvPr>
@@ -4875,7 +4875,7 @@
           <p:cNvPr id="24" name="">
             <a:extLst xmlns:a="http://schemas.openxmlformats.org/drawingml/2006/main">
               <a:ext uri="{FF2B5EF4-FFF2-40B4-BE49-F238E27FC236}">
-                <a16:creationId xmlns:a16="http://schemas.microsoft.com/office/drawing/2014/main" id="{5EBE8640-8B3F-479E-8807-48FF747E5D3E}"/>
+                <a16:creationId xmlns:a16="http://schemas.microsoft.com/office/drawing/2014/main" id="{9B536588-D7CB-47AF-A980-6306E03481D3}"/>
               </a:ext>
             </a:extLst>
           </p:cNvPr>
@@ -4937,7 +4937,7 @@
     </p:spTree>
     <p:extLst>
       <p:ext uri="{BB962C8B-B14F-4D97-AF65-F5344CB8AC3E}">
-        <p14:creationId xmlns:p14="http://schemas.microsoft.com/office/powerpoint/2010/main" val="922306789"/>
+        <p14:creationId xmlns:p14="http://schemas.microsoft.com/office/powerpoint/2010/main" val="438094736"/>
       </p:ext>
     </p:extLst>
   </p:cSld>
@@ -4968,7 +4968,7 @@
           <p:cNvPr id="17" name="">
             <a:extLst xmlns:a="http://schemas.openxmlformats.org/drawingml/2006/main">
               <a:ext uri="{FF2B5EF4-FFF2-40B4-BE49-F238E27FC236}">
-                <a16:creationId xmlns:a16="http://schemas.microsoft.com/office/drawing/2014/main" id="{0C4B5640-A77B-4416-B4FB-9914EA5EFC85}"/>
+                <a16:creationId xmlns:a16="http://schemas.microsoft.com/office/drawing/2014/main" id="{9BFF1AD5-8672-4F22-8E55-8B5783320C50}"/>
               </a:ext>
             </a:extLst>
           </p:cNvPr>
@@ -4999,7 +4999,7 @@
           <p:cNvPr id="2" name="">
             <a:extLst xmlns:a="http://schemas.openxmlformats.org/drawingml/2006/main">
               <a:ext uri="{FF2B5EF4-FFF2-40B4-BE49-F238E27FC236}">
-                <a16:creationId xmlns:a16="http://schemas.microsoft.com/office/drawing/2014/main" id="{39770BFA-CA44-4D04-9218-7268A9BED43C}"/>
+                <a16:creationId xmlns:a16="http://schemas.microsoft.com/office/drawing/2014/main" id="{CD7DCD18-767F-4F0A-8521-D32620407AEE}"/>
               </a:ext>
             </a:extLst>
           </p:cNvPr>
@@ -5051,7 +5051,7 @@
                 <a:ea typeface="Aptos"/>
                 <a:cs typeface="Aptos"/>
               </a:rPr>
-              <a:t>ΠΑΓΚΟΣΜΙΑ ΟΙΚΟΝΟΜΙΑ</a:t>
+              <a:t>ΔΙΚΑΙΟ</a:t>
             </a:r>
           </a:p>
         </p:txBody>
@@ -5061,7 +5061,7 @@
           <p:cNvPr id="3" name="">
             <a:extLst xmlns:a="http://schemas.openxmlformats.org/drawingml/2006/main">
               <a:ext uri="{FF2B5EF4-FFF2-40B4-BE49-F238E27FC236}">
-                <a16:creationId xmlns:a16="http://schemas.microsoft.com/office/drawing/2014/main" id="{B973C420-4DE1-4187-AAFA-8B3D506C165A}"/>
+                <a16:creationId xmlns:a16="http://schemas.microsoft.com/office/drawing/2014/main" id="{E5BF4043-BA86-439F-BE14-08735ABEEFCD}"/>
               </a:ext>
             </a:extLst>
           </p:cNvPr>
@@ -5095,7 +5095,7 @@
                 <a:spcPct val="108000"/>
               </a:lnSpc>
               <a:buNone/>
-              <a:defRPr sz="3150" b="1">
+              <a:defRPr sz="2550" b="1">
                 <a:solidFill>
                   <a:srgbClr val="071426"/>
                 </a:solidFill>
@@ -5105,7 +5105,7 @@
               </a:defRPr>
             </a:pPr>
             <a:r>
-              <a:rPr sz="3150" b="1">
+              <a:rPr sz="2550" b="1">
                 <a:solidFill>
                   <a:srgbClr val="071426"/>
                 </a:solidFill>
@@ -5123,7 +5123,7 @@
           <p:cNvPr id="4" name="">
             <a:extLst xmlns:a="http://schemas.openxmlformats.org/drawingml/2006/main">
               <a:ext uri="{FF2B5EF4-FFF2-40B4-BE49-F238E27FC236}">
-                <a16:creationId xmlns:a16="http://schemas.microsoft.com/office/drawing/2014/main" id="{FC134107-CF0E-47EA-882E-87864F530102}"/>
+                <a16:creationId xmlns:a16="http://schemas.microsoft.com/office/drawing/2014/main" id="{6576FD2F-66FC-47B4-975A-C5952D3C3C70}"/>
               </a:ext>
             </a:extLst>
           </p:cNvPr>
@@ -5158,7 +5158,7 @@
           <p:nvPr/>
         </p:nvPicPr>
         <p:blipFill>
-          <a:blip xmlns:r="http://schemas.openxmlformats.org/officeDocument/2006/relationships" xmlns:a="http://schemas.openxmlformats.org/drawingml/2006/main" r:embed="R4ba57d14da5347f2"/>
+          <a:blip xmlns:r="http://schemas.openxmlformats.org/officeDocument/2006/relationships" xmlns:a="http://schemas.openxmlformats.org/drawingml/2006/main" r:embed="Rfb1d342ccc054096"/>
           <a:srcRect xmlns:a="http://schemas.openxmlformats.org/drawingml/2006/main" l="0" t="0" r="0" b="0"/>
           <a:stretch xmlns:a="http://schemas.openxmlformats.org/drawingml/2006/main">
             <a:fillRect l="0" t="0" r="0" b="0"/>
@@ -5179,7 +5179,7 @@
           <p:cNvPr id="6" name="">
             <a:extLst xmlns:a="http://schemas.openxmlformats.org/drawingml/2006/main">
               <a:ext uri="{FF2B5EF4-FFF2-40B4-BE49-F238E27FC236}">
-                <a16:creationId xmlns:a16="http://schemas.microsoft.com/office/drawing/2014/main" id="{3D2D260E-18BE-406C-A757-05105D884751}"/>
+                <a16:creationId xmlns:a16="http://schemas.microsoft.com/office/drawing/2014/main" id="{B10A36D6-E181-4C09-805E-BF5B2C0AC191}"/>
               </a:ext>
             </a:extLst>
           </p:cNvPr>
@@ -5241,7 +5241,7 @@
           <p:cNvPr id="7" name="">
             <a:extLst xmlns:a="http://schemas.openxmlformats.org/drawingml/2006/main">
               <a:ext uri="{FF2B5EF4-FFF2-40B4-BE49-F238E27FC236}">
-                <a16:creationId xmlns:a16="http://schemas.microsoft.com/office/drawing/2014/main" id="{22DFA94B-C826-45AA-91F1-008DFF79FF98}"/>
+                <a16:creationId xmlns:a16="http://schemas.microsoft.com/office/drawing/2014/main" id="{9F03F801-0433-41DA-9F6D-5422DB47476A}"/>
               </a:ext>
             </a:extLst>
           </p:cNvPr>
@@ -5303,7 +5303,7 @@
           <p:cNvPr id="8" name="">
             <a:extLst xmlns:a="http://schemas.openxmlformats.org/drawingml/2006/main">
               <a:ext uri="{FF2B5EF4-FFF2-40B4-BE49-F238E27FC236}">
-                <a16:creationId xmlns:a16="http://schemas.microsoft.com/office/drawing/2014/main" id="{9FCF850F-0439-4AA7-AD95-208082408D3E}"/>
+                <a16:creationId xmlns:a16="http://schemas.microsoft.com/office/drawing/2014/main" id="{801651A7-11D3-4717-B81E-02857BF107EB}"/>
               </a:ext>
             </a:extLst>
           </p:cNvPr>
@@ -5338,7 +5338,7 @@
           <p:cNvPr id="9" name="">
             <a:extLst xmlns:a="http://schemas.openxmlformats.org/drawingml/2006/main">
               <a:ext uri="{FF2B5EF4-FFF2-40B4-BE49-F238E27FC236}">
-                <a16:creationId xmlns:a16="http://schemas.microsoft.com/office/drawing/2014/main" id="{506AF0C5-4304-494C-96EF-CC612F3CCF79}"/>
+                <a16:creationId xmlns:a16="http://schemas.microsoft.com/office/drawing/2014/main" id="{AA0AAD8D-45A2-44F5-A422-C58C44E8B6E9}"/>
               </a:ext>
             </a:extLst>
           </p:cNvPr>
@@ -5369,7 +5369,7 @@
           <p:cNvPr id="10" name="">
             <a:extLst xmlns:a="http://schemas.openxmlformats.org/drawingml/2006/main">
               <a:ext uri="{FF2B5EF4-FFF2-40B4-BE49-F238E27FC236}">
-                <a16:creationId xmlns:a16="http://schemas.microsoft.com/office/drawing/2014/main" id="{74BB852F-D98C-48DE-96F4-6E8D875F8DE3}"/>
+                <a16:creationId xmlns:a16="http://schemas.microsoft.com/office/drawing/2014/main" id="{418AED24-0B8C-439F-B30B-CFB8F407E732}"/>
               </a:ext>
             </a:extLst>
           </p:cNvPr>
@@ -5431,7 +5431,7 @@
           <p:cNvPr id="11" name="">
             <a:extLst xmlns:a="http://schemas.openxmlformats.org/drawingml/2006/main">
               <a:ext uri="{FF2B5EF4-FFF2-40B4-BE49-F238E27FC236}">
-                <a16:creationId xmlns:a16="http://schemas.microsoft.com/office/drawing/2014/main" id="{9B6DACAA-C872-4D24-84F3-6E86D1F310F5}"/>
+                <a16:creationId xmlns:a16="http://schemas.microsoft.com/office/drawing/2014/main" id="{20307AF2-9964-4199-A218-2E0F043AC8DA}"/>
               </a:ext>
             </a:extLst>
           </p:cNvPr>
@@ -5547,7 +5547,7 @@
           <p:cNvPr id="12" name="">
             <a:extLst xmlns:a="http://schemas.openxmlformats.org/drawingml/2006/main">
               <a:ext uri="{FF2B5EF4-FFF2-40B4-BE49-F238E27FC236}">
-                <a16:creationId xmlns:a16="http://schemas.microsoft.com/office/drawing/2014/main" id="{A44CED2F-AEFF-4B00-8D91-516E2B7259D7}"/>
+                <a16:creationId xmlns:a16="http://schemas.microsoft.com/office/drawing/2014/main" id="{BD1108BC-A517-4FF0-B82B-AA003D6241D0}"/>
               </a:ext>
             </a:extLst>
           </p:cNvPr>
@@ -5582,7 +5582,7 @@
           <p:cNvPr id="13" name="">
             <a:extLst xmlns:a="http://schemas.openxmlformats.org/drawingml/2006/main">
               <a:ext uri="{FF2B5EF4-FFF2-40B4-BE49-F238E27FC236}">
-                <a16:creationId xmlns:a16="http://schemas.microsoft.com/office/drawing/2014/main" id="{7E65830B-1F4A-4607-9FC8-5167E6A72479}"/>
+                <a16:creationId xmlns:a16="http://schemas.microsoft.com/office/drawing/2014/main" id="{41B1B966-5481-4F47-9020-1BD0C4981B7D}"/>
               </a:ext>
             </a:extLst>
           </p:cNvPr>
@@ -5613,7 +5613,7 @@
           <p:cNvPr id="14" name="">
             <a:extLst xmlns:a="http://schemas.openxmlformats.org/drawingml/2006/main">
               <a:ext uri="{FF2B5EF4-FFF2-40B4-BE49-F238E27FC236}">
-                <a16:creationId xmlns:a16="http://schemas.microsoft.com/office/drawing/2014/main" id="{4F405D64-E350-4149-A035-BA1FFFDA12EE}"/>
+                <a16:creationId xmlns:a16="http://schemas.microsoft.com/office/drawing/2014/main" id="{2C0DF05D-0D1A-488E-AE12-E5E14C262C6F}"/>
               </a:ext>
             </a:extLst>
           </p:cNvPr>
@@ -5675,7 +5675,7 @@
           <p:cNvPr id="15" name="">
             <a:extLst xmlns:a="http://schemas.openxmlformats.org/drawingml/2006/main">
               <a:ext uri="{FF2B5EF4-FFF2-40B4-BE49-F238E27FC236}">
-                <a16:creationId xmlns:a16="http://schemas.microsoft.com/office/drawing/2014/main" id="{7BAFA1E3-0F02-4886-B396-DC8FE84E3789}"/>
+                <a16:creationId xmlns:a16="http://schemas.microsoft.com/office/drawing/2014/main" id="{D216DF08-43F6-4063-B3FF-C8A1DE2B2347}"/>
               </a:ext>
             </a:extLst>
           </p:cNvPr>
@@ -5764,7 +5764,7 @@
           <p:cNvPr id="16" name="">
             <a:extLst xmlns:a="http://schemas.openxmlformats.org/drawingml/2006/main">
               <a:ext uri="{FF2B5EF4-FFF2-40B4-BE49-F238E27FC236}">
-                <a16:creationId xmlns:a16="http://schemas.microsoft.com/office/drawing/2014/main" id="{DAACFA37-EB93-44B8-B06A-DDA0A7A81795}"/>
+                <a16:creationId xmlns:a16="http://schemas.microsoft.com/office/drawing/2014/main" id="{72F9248D-B879-4C26-8EE6-40346B95BA33}"/>
               </a:ext>
             </a:extLst>
           </p:cNvPr>
@@ -5826,7 +5826,7 @@
     </p:spTree>
     <p:extLst>
       <p:ext uri="{BB962C8B-B14F-4D97-AF65-F5344CB8AC3E}">
-        <p14:creationId xmlns:p14="http://schemas.microsoft.com/office/powerpoint/2010/main" val="132441880"/>
+        <p14:creationId xmlns:p14="http://schemas.microsoft.com/office/powerpoint/2010/main" val="489687084"/>
       </p:ext>
     </p:extLst>
   </p:cSld>
@@ -5857,7 +5857,7 @@
           <p:cNvPr id="32" name="">
             <a:extLst xmlns:a="http://schemas.openxmlformats.org/drawingml/2006/main">
               <a:ext uri="{FF2B5EF4-FFF2-40B4-BE49-F238E27FC236}">
-                <a16:creationId xmlns:a16="http://schemas.microsoft.com/office/drawing/2014/main" id="{18C2BE39-A7E2-4DF5-BE0A-FAB5A3FBA54E}"/>
+                <a16:creationId xmlns:a16="http://schemas.microsoft.com/office/drawing/2014/main" id="{7765BF02-C2F2-47BA-AF4E-1AA5E7EDD358}"/>
               </a:ext>
             </a:extLst>
           </p:cNvPr>
@@ -5888,7 +5888,7 @@
           <p:cNvPr id="2" name="">
             <a:extLst xmlns:a="http://schemas.openxmlformats.org/drawingml/2006/main">
               <a:ext uri="{FF2B5EF4-FFF2-40B4-BE49-F238E27FC236}">
-                <a16:creationId xmlns:a16="http://schemas.microsoft.com/office/drawing/2014/main" id="{29BED3B1-90AA-4C0B-B1E0-2EE6BD87E0BE}"/>
+                <a16:creationId xmlns:a16="http://schemas.microsoft.com/office/drawing/2014/main" id="{4FBF312E-E357-4B04-97DE-7F3471DA4B1E}"/>
               </a:ext>
             </a:extLst>
           </p:cNvPr>
@@ -5940,7 +5940,7 @@
                 <a:ea typeface="Aptos"/>
                 <a:cs typeface="Aptos"/>
               </a:rPr>
-              <a:t>ΠΑΓΚΟΣΜΙΑ ΟΙΚΟΝΟΜΙΑ</a:t>
+              <a:t>ΚΙΝΔΥΝΟΙ</a:t>
             </a:r>
           </a:p>
         </p:txBody>
@@ -5950,7 +5950,7 @@
           <p:cNvPr id="3" name="">
             <a:extLst xmlns:a="http://schemas.openxmlformats.org/drawingml/2006/main">
               <a:ext uri="{FF2B5EF4-FFF2-40B4-BE49-F238E27FC236}">
-                <a16:creationId xmlns:a16="http://schemas.microsoft.com/office/drawing/2014/main" id="{31B4EE57-3062-474C-9EC8-18DE07532E6C}"/>
+                <a16:creationId xmlns:a16="http://schemas.microsoft.com/office/drawing/2014/main" id="{63401F14-388D-471C-B7D8-8BA5637C95DC}"/>
               </a:ext>
             </a:extLst>
           </p:cNvPr>
@@ -5975,7 +5975,7 @@
         </p:spPr>
         <p:txBody>
           <a:bodyPr xmlns:a="http://schemas.openxmlformats.org/drawingml/2006/main" lIns="76200" tIns="57150" rIns="76200" bIns="57150" anchor="ctr">
-            <a:normAutofit fontScale="99744"/>
+            <a:normAutofit fontScale="100000"/>
           </a:bodyPr>
           <a:lstStyle xmlns:a="http://schemas.openxmlformats.org/drawingml/2006/main"/>
           <a:p xmlns:a="http://schemas.openxmlformats.org/drawingml/2006/main">
@@ -5984,7 +5984,7 @@
                 <a:spcPct val="108000"/>
               </a:lnSpc>
               <a:buNone/>
-              <a:defRPr sz="3150" b="1">
+              <a:defRPr sz="2250" b="1">
                 <a:solidFill>
                   <a:srgbClr val="071426"/>
                 </a:solidFill>
@@ -5994,7 +5994,7 @@
               </a:defRPr>
             </a:pPr>
             <a:r>
-              <a:rPr sz="3150" b="1">
+              <a:rPr sz="2250" b="1">
                 <a:solidFill>
                   <a:srgbClr val="071426"/>
                 </a:solidFill>
@@ -6012,7 +6012,7 @@
           <p:cNvPr id="4" name="">
             <a:extLst xmlns:a="http://schemas.openxmlformats.org/drawingml/2006/main">
               <a:ext uri="{FF2B5EF4-FFF2-40B4-BE49-F238E27FC236}">
-                <a16:creationId xmlns:a16="http://schemas.microsoft.com/office/drawing/2014/main" id="{C34F2E92-2FB4-478F-8748-D740D96D10E3}"/>
+                <a16:creationId xmlns:a16="http://schemas.microsoft.com/office/drawing/2014/main" id="{05660F22-7B07-4E18-B333-95F645E4A69D}"/>
               </a:ext>
             </a:extLst>
           </p:cNvPr>
@@ -6047,7 +6047,7 @@
           <p:nvPr/>
         </p:nvPicPr>
         <p:blipFill>
-          <a:blip xmlns:r="http://schemas.openxmlformats.org/officeDocument/2006/relationships" xmlns:a="http://schemas.openxmlformats.org/drawingml/2006/main" r:embed="Rf023698b9e044ce7"/>
+          <a:blip xmlns:r="http://schemas.openxmlformats.org/officeDocument/2006/relationships" xmlns:a="http://schemas.openxmlformats.org/drawingml/2006/main" r:embed="R82ed080ea3074d0d"/>
           <a:srcRect xmlns:a="http://schemas.openxmlformats.org/drawingml/2006/main" l="0" t="0" r="0" b="0"/>
           <a:stretch xmlns:a="http://schemas.openxmlformats.org/drawingml/2006/main">
             <a:fillRect l="0" t="0" r="0" b="0"/>
@@ -6068,7 +6068,7 @@
           <p:cNvPr id="6" name="">
             <a:extLst xmlns:a="http://schemas.openxmlformats.org/drawingml/2006/main">
               <a:ext uri="{FF2B5EF4-FFF2-40B4-BE49-F238E27FC236}">
-                <a16:creationId xmlns:a16="http://schemas.microsoft.com/office/drawing/2014/main" id="{DD10A715-EC94-469F-92C3-8A9FB6E09518}"/>
+                <a16:creationId xmlns:a16="http://schemas.microsoft.com/office/drawing/2014/main" id="{4ADD9E39-56EC-4FD6-9FF4-99648C1477D3}"/>
               </a:ext>
             </a:extLst>
           </p:cNvPr>
@@ -6130,7 +6130,7 @@
           <p:cNvPr id="7" name="">
             <a:extLst xmlns:a="http://schemas.openxmlformats.org/drawingml/2006/main">
               <a:ext uri="{FF2B5EF4-FFF2-40B4-BE49-F238E27FC236}">
-                <a16:creationId xmlns:a16="http://schemas.microsoft.com/office/drawing/2014/main" id="{93E64417-3445-4685-BB63-94253419566E}"/>
+                <a16:creationId xmlns:a16="http://schemas.microsoft.com/office/drawing/2014/main" id="{003A2BC9-CF79-4AF3-8D29-A4DCBEDD4B61}"/>
               </a:ext>
             </a:extLst>
           </p:cNvPr>
@@ -6192,7 +6192,7 @@
           <p:cNvPr id="8" name="">
             <a:extLst xmlns:a="http://schemas.openxmlformats.org/drawingml/2006/main">
               <a:ext uri="{FF2B5EF4-FFF2-40B4-BE49-F238E27FC236}">
-                <a16:creationId xmlns:a16="http://schemas.microsoft.com/office/drawing/2014/main" id="{4E971BA3-05B2-4058-9F78-56435CFF063B}"/>
+                <a16:creationId xmlns:a16="http://schemas.microsoft.com/office/drawing/2014/main" id="{E4B42892-BACC-4206-A1ED-000BA19F686B}"/>
               </a:ext>
             </a:extLst>
           </p:cNvPr>
@@ -6227,7 +6227,7 @@
           <p:cNvPr id="9" name="">
             <a:extLst xmlns:a="http://schemas.openxmlformats.org/drawingml/2006/main">
               <a:ext uri="{FF2B5EF4-FFF2-40B4-BE49-F238E27FC236}">
-                <a16:creationId xmlns:a16="http://schemas.microsoft.com/office/drawing/2014/main" id="{214E1556-AF0D-471F-AB8C-48D7299D7759}"/>
+                <a16:creationId xmlns:a16="http://schemas.microsoft.com/office/drawing/2014/main" id="{02EE04D0-203E-46BF-8D98-40FCEED72159}"/>
               </a:ext>
             </a:extLst>
           </p:cNvPr>
@@ -6258,7 +6258,7 @@
           <p:cNvPr id="10" name="">
             <a:extLst xmlns:a="http://schemas.openxmlformats.org/drawingml/2006/main">
               <a:ext uri="{FF2B5EF4-FFF2-40B4-BE49-F238E27FC236}">
-                <a16:creationId xmlns:a16="http://schemas.microsoft.com/office/drawing/2014/main" id="{E7B81C10-B4B7-43DB-99F0-F40FD61A638B}"/>
+                <a16:creationId xmlns:a16="http://schemas.microsoft.com/office/drawing/2014/main" id="{5C220099-A2CD-4C21-BBEF-1FAC9EA85AD3}"/>
               </a:ext>
             </a:extLst>
           </p:cNvPr>
@@ -6320,7 +6320,7 @@
           <p:cNvPr id="11" name="">
             <a:extLst xmlns:a="http://schemas.openxmlformats.org/drawingml/2006/main">
               <a:ext uri="{FF2B5EF4-FFF2-40B4-BE49-F238E27FC236}">
-                <a16:creationId xmlns:a16="http://schemas.microsoft.com/office/drawing/2014/main" id="{68CDDC83-F7DD-4078-B911-1A58A8FD126C}"/>
+                <a16:creationId xmlns:a16="http://schemas.microsoft.com/office/drawing/2014/main" id="{7D941D87-883C-41A5-9A3A-25B4B8273C0F}"/>
               </a:ext>
             </a:extLst>
           </p:cNvPr>
@@ -6382,7 +6382,7 @@
           <p:cNvPr id="12" name="">
             <a:extLst xmlns:a="http://schemas.openxmlformats.org/drawingml/2006/main">
               <a:ext uri="{FF2B5EF4-FFF2-40B4-BE49-F238E27FC236}">
-                <a16:creationId xmlns:a16="http://schemas.microsoft.com/office/drawing/2014/main" id="{BA7F7139-2809-4621-98BE-7488308B017E}"/>
+                <a16:creationId xmlns:a16="http://schemas.microsoft.com/office/drawing/2014/main" id="{6D6FA0BB-BF1B-495F-A563-08B04C4F7CD0}"/>
               </a:ext>
             </a:extLst>
           </p:cNvPr>
@@ -6417,7 +6417,7 @@
           <p:cNvPr id="13" name="">
             <a:extLst xmlns:a="http://schemas.openxmlformats.org/drawingml/2006/main">
               <a:ext uri="{FF2B5EF4-FFF2-40B4-BE49-F238E27FC236}">
-                <a16:creationId xmlns:a16="http://schemas.microsoft.com/office/drawing/2014/main" id="{1BEC4654-7125-4E4B-BC33-C1A95D4F4466}"/>
+                <a16:creationId xmlns:a16="http://schemas.microsoft.com/office/drawing/2014/main" id="{775D12CE-E68F-4B61-BA37-36C23E5ACD88}"/>
               </a:ext>
             </a:extLst>
           </p:cNvPr>
@@ -6448,7 +6448,7 @@
           <p:cNvPr id="14" name="">
             <a:extLst xmlns:a="http://schemas.openxmlformats.org/drawingml/2006/main">
               <a:ext uri="{FF2B5EF4-FFF2-40B4-BE49-F238E27FC236}">
-                <a16:creationId xmlns:a16="http://schemas.microsoft.com/office/drawing/2014/main" id="{CD9D921F-4F54-483A-AB69-613E0CA985E6}"/>
+                <a16:creationId xmlns:a16="http://schemas.microsoft.com/office/drawing/2014/main" id="{B1E4D949-B160-4B68-BED0-8654BF131ED8}"/>
               </a:ext>
             </a:extLst>
           </p:cNvPr>
@@ -6510,7 +6510,7 @@
           <p:cNvPr id="15" name="">
             <a:extLst xmlns:a="http://schemas.openxmlformats.org/drawingml/2006/main">
               <a:ext uri="{FF2B5EF4-FFF2-40B4-BE49-F238E27FC236}">
-                <a16:creationId xmlns:a16="http://schemas.microsoft.com/office/drawing/2014/main" id="{B641BA7F-57F5-4173-B37D-72A0F0413890}"/>
+                <a16:creationId xmlns:a16="http://schemas.microsoft.com/office/drawing/2014/main" id="{E185C76D-35DF-42C2-B2AB-70995EFE75E4}"/>
               </a:ext>
             </a:extLst>
           </p:cNvPr>
@@ -6572,7 +6572,7 @@
           <p:cNvPr id="16" name="">
             <a:extLst xmlns:a="http://schemas.openxmlformats.org/drawingml/2006/main">
               <a:ext uri="{FF2B5EF4-FFF2-40B4-BE49-F238E27FC236}">
-                <a16:creationId xmlns:a16="http://schemas.microsoft.com/office/drawing/2014/main" id="{4E51CEE0-839F-4857-8086-60C78C5D3DD6}"/>
+                <a16:creationId xmlns:a16="http://schemas.microsoft.com/office/drawing/2014/main" id="{892B4D53-6247-42F2-895B-E6F5B49964DA}"/>
               </a:ext>
             </a:extLst>
           </p:cNvPr>
@@ -6607,7 +6607,7 @@
           <p:cNvPr id="17" name="">
             <a:extLst xmlns:a="http://schemas.openxmlformats.org/drawingml/2006/main">
               <a:ext uri="{FF2B5EF4-FFF2-40B4-BE49-F238E27FC236}">
-                <a16:creationId xmlns:a16="http://schemas.microsoft.com/office/drawing/2014/main" id="{E44E3981-6DC3-4592-89E4-058AB7DBE400}"/>
+                <a16:creationId xmlns:a16="http://schemas.microsoft.com/office/drawing/2014/main" id="{785C8E5A-6E93-49F2-BB10-A9C74D038133}"/>
               </a:ext>
             </a:extLst>
           </p:cNvPr>
@@ -6638,7 +6638,7 @@
           <p:cNvPr id="18" name="">
             <a:extLst xmlns:a="http://schemas.openxmlformats.org/drawingml/2006/main">
               <a:ext uri="{FF2B5EF4-FFF2-40B4-BE49-F238E27FC236}">
-                <a16:creationId xmlns:a16="http://schemas.microsoft.com/office/drawing/2014/main" id="{E1D899AC-C0CA-4208-B2AF-502CCF8FDEB5}"/>
+                <a16:creationId xmlns:a16="http://schemas.microsoft.com/office/drawing/2014/main" id="{0B95646A-2C97-4117-83BC-B30CCF6EE16F}"/>
               </a:ext>
             </a:extLst>
           </p:cNvPr>
@@ -6700,7 +6700,7 @@
           <p:cNvPr id="19" name="">
             <a:extLst xmlns:a="http://schemas.openxmlformats.org/drawingml/2006/main">
               <a:ext uri="{FF2B5EF4-FFF2-40B4-BE49-F238E27FC236}">
-                <a16:creationId xmlns:a16="http://schemas.microsoft.com/office/drawing/2014/main" id="{3EF080F3-E781-4D7D-89D6-F638C022F465}"/>
+                <a16:creationId xmlns:a16="http://schemas.microsoft.com/office/drawing/2014/main" id="{B831B05A-6BA3-43CD-9FB3-9E3A2C28641B}"/>
               </a:ext>
             </a:extLst>
           </p:cNvPr>
@@ -6762,7 +6762,7 @@
           <p:cNvPr id="20" name="">
             <a:extLst xmlns:a="http://schemas.openxmlformats.org/drawingml/2006/main">
               <a:ext uri="{FF2B5EF4-FFF2-40B4-BE49-F238E27FC236}">
-                <a16:creationId xmlns:a16="http://schemas.microsoft.com/office/drawing/2014/main" id="{39ECC8C6-28B2-41C6-AD3D-96CB9C65C6FF}"/>
+                <a16:creationId xmlns:a16="http://schemas.microsoft.com/office/drawing/2014/main" id="{3D62DB29-F652-4D3A-9872-9A9DC1661E16}"/>
               </a:ext>
             </a:extLst>
           </p:cNvPr>
@@ -6797,7 +6797,7 @@
           <p:cNvPr id="21" name="">
             <a:extLst xmlns:a="http://schemas.openxmlformats.org/drawingml/2006/main">
               <a:ext uri="{FF2B5EF4-FFF2-40B4-BE49-F238E27FC236}">
-                <a16:creationId xmlns:a16="http://schemas.microsoft.com/office/drawing/2014/main" id="{A7911FCC-288D-4D8A-B262-25F9E1356805}"/>
+                <a16:creationId xmlns:a16="http://schemas.microsoft.com/office/drawing/2014/main" id="{331973C8-A7C1-4EFC-A8CB-6EABADF0E1B3}"/>
               </a:ext>
             </a:extLst>
           </p:cNvPr>
@@ -6828,7 +6828,7 @@
           <p:cNvPr id="22" name="">
             <a:extLst xmlns:a="http://schemas.openxmlformats.org/drawingml/2006/main">
               <a:ext uri="{FF2B5EF4-FFF2-40B4-BE49-F238E27FC236}">
-                <a16:creationId xmlns:a16="http://schemas.microsoft.com/office/drawing/2014/main" id="{0489A6AC-CD63-4F26-9A98-91191B6BA473}"/>
+                <a16:creationId xmlns:a16="http://schemas.microsoft.com/office/drawing/2014/main" id="{CEF02098-71D2-4493-88EF-F6CC70318466}"/>
               </a:ext>
             </a:extLst>
           </p:cNvPr>
@@ -6890,7 +6890,7 @@
           <p:cNvPr id="23" name="">
             <a:extLst xmlns:a="http://schemas.openxmlformats.org/drawingml/2006/main">
               <a:ext uri="{FF2B5EF4-FFF2-40B4-BE49-F238E27FC236}">
-                <a16:creationId xmlns:a16="http://schemas.microsoft.com/office/drawing/2014/main" id="{1404DBDC-686F-4F01-8BD2-FFA952FD2008}"/>
+                <a16:creationId xmlns:a16="http://schemas.microsoft.com/office/drawing/2014/main" id="{E421E1C4-0217-4151-BCE8-35D700AFA8CD}"/>
               </a:ext>
             </a:extLst>
           </p:cNvPr>
@@ -6952,7 +6952,7 @@
           <p:cNvPr id="24" name="">
             <a:extLst xmlns:a="http://schemas.openxmlformats.org/drawingml/2006/main">
               <a:ext uri="{FF2B5EF4-FFF2-40B4-BE49-F238E27FC236}">
-                <a16:creationId xmlns:a16="http://schemas.microsoft.com/office/drawing/2014/main" id="{F9342CD3-F643-48E4-905D-D62DD24C7B34}"/>
+                <a16:creationId xmlns:a16="http://schemas.microsoft.com/office/drawing/2014/main" id="{19D9E3FF-EB5A-4FA4-AFF6-0AD56FE6D274}"/>
               </a:ext>
             </a:extLst>
           </p:cNvPr>
@@ -6987,7 +6987,7 @@
           <p:cNvPr id="25" name="">
             <a:extLst xmlns:a="http://schemas.openxmlformats.org/drawingml/2006/main">
               <a:ext uri="{FF2B5EF4-FFF2-40B4-BE49-F238E27FC236}">
-                <a16:creationId xmlns:a16="http://schemas.microsoft.com/office/drawing/2014/main" id="{6569BFBD-2893-405E-BD82-5D6D14135BB1}"/>
+                <a16:creationId xmlns:a16="http://schemas.microsoft.com/office/drawing/2014/main" id="{5A9846C5-E7F8-499F-B5AF-E9ABE99392AE}"/>
               </a:ext>
             </a:extLst>
           </p:cNvPr>
@@ -7018,7 +7018,7 @@
           <p:cNvPr id="26" name="">
             <a:extLst xmlns:a="http://schemas.openxmlformats.org/drawingml/2006/main">
               <a:ext uri="{FF2B5EF4-FFF2-40B4-BE49-F238E27FC236}">
-                <a16:creationId xmlns:a16="http://schemas.microsoft.com/office/drawing/2014/main" id="{B0524716-857D-4E87-9150-55BE25D243DF}"/>
+                <a16:creationId xmlns:a16="http://schemas.microsoft.com/office/drawing/2014/main" id="{41A27B50-5C7F-46C9-9409-F0631DD745E3}"/>
               </a:ext>
             </a:extLst>
           </p:cNvPr>
@@ -7080,7 +7080,7 @@
           <p:cNvPr id="27" name="">
             <a:extLst xmlns:a="http://schemas.openxmlformats.org/drawingml/2006/main">
               <a:ext uri="{FF2B5EF4-FFF2-40B4-BE49-F238E27FC236}">
-                <a16:creationId xmlns:a16="http://schemas.microsoft.com/office/drawing/2014/main" id="{DE9FF5F7-035B-49D8-AA61-CB7DFC3784AB}"/>
+                <a16:creationId xmlns:a16="http://schemas.microsoft.com/office/drawing/2014/main" id="{29A81492-DF1E-4521-93EC-ADA154C0719A}"/>
               </a:ext>
             </a:extLst>
           </p:cNvPr>
@@ -7142,7 +7142,7 @@
           <p:cNvPr id="28" name="">
             <a:extLst xmlns:a="http://schemas.openxmlformats.org/drawingml/2006/main">
               <a:ext uri="{FF2B5EF4-FFF2-40B4-BE49-F238E27FC236}">
-                <a16:creationId xmlns:a16="http://schemas.microsoft.com/office/drawing/2014/main" id="{46C907DC-77CF-4E6E-85A3-19BF4A6B5737}"/>
+                <a16:creationId xmlns:a16="http://schemas.microsoft.com/office/drawing/2014/main" id="{5634490C-4E35-45C3-BCF5-1A402C29F38D}"/>
               </a:ext>
             </a:extLst>
           </p:cNvPr>
@@ -7177,7 +7177,7 @@
           <p:cNvPr id="29" name="">
             <a:extLst xmlns:a="http://schemas.openxmlformats.org/drawingml/2006/main">
               <a:ext uri="{FF2B5EF4-FFF2-40B4-BE49-F238E27FC236}">
-                <a16:creationId xmlns:a16="http://schemas.microsoft.com/office/drawing/2014/main" id="{58271623-9416-4F74-93B3-AAA5DB3FEC3D}"/>
+                <a16:creationId xmlns:a16="http://schemas.microsoft.com/office/drawing/2014/main" id="{AD4CD25F-BF04-4731-9567-F1FFA301C620}"/>
               </a:ext>
             </a:extLst>
           </p:cNvPr>
@@ -7208,7 +7208,7 @@
           <p:cNvPr id="30" name="">
             <a:extLst xmlns:a="http://schemas.openxmlformats.org/drawingml/2006/main">
               <a:ext uri="{FF2B5EF4-FFF2-40B4-BE49-F238E27FC236}">
-                <a16:creationId xmlns:a16="http://schemas.microsoft.com/office/drawing/2014/main" id="{C5836EFF-44B7-4222-A6C2-0CC9B9782A44}"/>
+                <a16:creationId xmlns:a16="http://schemas.microsoft.com/office/drawing/2014/main" id="{A26DD0F6-1DB3-4112-830E-08F9C05C8BB3}"/>
               </a:ext>
             </a:extLst>
           </p:cNvPr>
@@ -7270,7 +7270,7 @@
           <p:cNvPr id="31" name="">
             <a:extLst xmlns:a="http://schemas.openxmlformats.org/drawingml/2006/main">
               <a:ext uri="{FF2B5EF4-FFF2-40B4-BE49-F238E27FC236}">
-                <a16:creationId xmlns:a16="http://schemas.microsoft.com/office/drawing/2014/main" id="{51AC8CFA-0889-4E13-A3C2-51FB58AB2291}"/>
+                <a16:creationId xmlns:a16="http://schemas.microsoft.com/office/drawing/2014/main" id="{02BFDE9E-2AFC-46DA-AC86-AAF7DCEB9B3E}"/>
               </a:ext>
             </a:extLst>
           </p:cNvPr>
@@ -7330,7 +7330,7 @@
     </p:spTree>
     <p:extLst>
       <p:ext uri="{BB962C8B-B14F-4D97-AF65-F5344CB8AC3E}">
-        <p14:creationId xmlns:p14="http://schemas.microsoft.com/office/powerpoint/2010/main" val="1113248998"/>
+        <p14:creationId xmlns:p14="http://schemas.microsoft.com/office/powerpoint/2010/main" val="550505039"/>
       </p:ext>
     </p:extLst>
   </p:cSld>
@@ -7361,7 +7361,7 @@
           <p:cNvPr id="26" name="">
             <a:extLst xmlns:a="http://schemas.openxmlformats.org/drawingml/2006/main">
               <a:ext uri="{FF2B5EF4-FFF2-40B4-BE49-F238E27FC236}">
-                <a16:creationId xmlns:a16="http://schemas.microsoft.com/office/drawing/2014/main" id="{081B1669-4260-484C-B629-0DA0C74940CD}"/>
+                <a16:creationId xmlns:a16="http://schemas.microsoft.com/office/drawing/2014/main" id="{FF140D93-11EE-4A53-9A4A-BFEFFAEDB2D8}"/>
               </a:ext>
             </a:extLst>
           </p:cNvPr>
@@ -7392,7 +7392,7 @@
           <p:cNvPr id="2" name="">
             <a:extLst xmlns:a="http://schemas.openxmlformats.org/drawingml/2006/main">
               <a:ext uri="{FF2B5EF4-FFF2-40B4-BE49-F238E27FC236}">
-                <a16:creationId xmlns:a16="http://schemas.microsoft.com/office/drawing/2014/main" id="{8FC73DEB-45D4-4B00-95E8-E63EA938E164}"/>
+                <a16:creationId xmlns:a16="http://schemas.microsoft.com/office/drawing/2014/main" id="{8499EC50-BD01-43B1-BD37-2E227DE1DC57}"/>
               </a:ext>
             </a:extLst>
           </p:cNvPr>
@@ -7444,7 +7444,7 @@
                 <a:ea typeface="Aptos"/>
                 <a:cs typeface="Aptos"/>
               </a:rPr>
-              <a:t>ΚΙΝΔΥΝΟΙ</a:t>
+              <a:t>ΦΑΣΗ 0</a:t>
             </a:r>
           </a:p>
         </p:txBody>
@@ -7454,7 +7454,7 @@
           <p:cNvPr id="3" name="">
             <a:extLst xmlns:a="http://schemas.openxmlformats.org/drawingml/2006/main">
               <a:ext uri="{FF2B5EF4-FFF2-40B4-BE49-F238E27FC236}">
-                <a16:creationId xmlns:a16="http://schemas.microsoft.com/office/drawing/2014/main" id="{AF31973C-BE68-408A-8D00-9044F92EF633}"/>
+                <a16:creationId xmlns:a16="http://schemas.microsoft.com/office/drawing/2014/main" id="{961DD252-24DB-4901-BFD6-E92F65D61AF6}"/>
               </a:ext>
             </a:extLst>
           </p:cNvPr>
@@ -7488,7 +7488,7 @@
                 <a:spcPct val="108000"/>
               </a:lnSpc>
               <a:buNone/>
-              <a:defRPr sz="3150" b="1">
+              <a:defRPr sz="2250" b="1">
                 <a:solidFill>
                   <a:srgbClr val="071426"/>
                 </a:solidFill>
@@ -7498,7 +7498,7 @@
               </a:defRPr>
             </a:pPr>
             <a:r>
-              <a:rPr sz="3150" b="1">
+              <a:rPr sz="2250" b="1">
                 <a:solidFill>
                   <a:srgbClr val="071426"/>
                 </a:solidFill>
@@ -7516,7 +7516,7 @@
           <p:cNvPr id="4" name="">
             <a:extLst xmlns:a="http://schemas.openxmlformats.org/drawingml/2006/main">
               <a:ext uri="{FF2B5EF4-FFF2-40B4-BE49-F238E27FC236}">
-                <a16:creationId xmlns:a16="http://schemas.microsoft.com/office/drawing/2014/main" id="{745A3424-C7A8-46AA-99AE-906763BE8620}"/>
+                <a16:creationId xmlns:a16="http://schemas.microsoft.com/office/drawing/2014/main" id="{831FC56E-221E-4711-868E-B3C6AAB4FABE}"/>
               </a:ext>
             </a:extLst>
           </p:cNvPr>
@@ -7551,7 +7551,7 @@
           <p:nvPr/>
         </p:nvPicPr>
         <p:blipFill>
-          <a:blip xmlns:r="http://schemas.openxmlformats.org/officeDocument/2006/relationships" xmlns:a="http://schemas.openxmlformats.org/drawingml/2006/main" r:embed="Rdbb556914fc74779"/>
+          <a:blip xmlns:r="http://schemas.openxmlformats.org/officeDocument/2006/relationships" xmlns:a="http://schemas.openxmlformats.org/drawingml/2006/main" r:embed="Rbe7d7d65f8604e2e"/>
           <a:srcRect xmlns:a="http://schemas.openxmlformats.org/drawingml/2006/main" l="0" t="0" r="0" b="0"/>
           <a:stretch xmlns:a="http://schemas.openxmlformats.org/drawingml/2006/main">
             <a:fillRect l="0" t="0" r="0" b="0"/>
@@ -7572,7 +7572,7 @@
           <p:cNvPr id="6" name="">
             <a:extLst xmlns:a="http://schemas.openxmlformats.org/drawingml/2006/main">
               <a:ext uri="{FF2B5EF4-FFF2-40B4-BE49-F238E27FC236}">
-                <a16:creationId xmlns:a16="http://schemas.microsoft.com/office/drawing/2014/main" id="{34437EF7-422B-42B5-9F34-30861F3A1C0A}"/>
+                <a16:creationId xmlns:a16="http://schemas.microsoft.com/office/drawing/2014/main" id="{9F9C74C2-59C4-486B-8D05-5513C7726E83}"/>
               </a:ext>
             </a:extLst>
           </p:cNvPr>
@@ -7634,7 +7634,7 @@
           <p:cNvPr id="7" name="">
             <a:extLst xmlns:a="http://schemas.openxmlformats.org/drawingml/2006/main">
               <a:ext uri="{FF2B5EF4-FFF2-40B4-BE49-F238E27FC236}">
-                <a16:creationId xmlns:a16="http://schemas.microsoft.com/office/drawing/2014/main" id="{5D67372A-E52A-46E2-814E-2DF3538DA3D0}"/>
+                <a16:creationId xmlns:a16="http://schemas.microsoft.com/office/drawing/2014/main" id="{22F1AD30-58EE-4987-B51E-12C3F5701A85}"/>
               </a:ext>
             </a:extLst>
           </p:cNvPr>
@@ -7696,7 +7696,7 @@
           <p:cNvPr id="8" name="">
             <a:extLst xmlns:a="http://schemas.openxmlformats.org/drawingml/2006/main">
               <a:ext uri="{FF2B5EF4-FFF2-40B4-BE49-F238E27FC236}">
-                <a16:creationId xmlns:a16="http://schemas.microsoft.com/office/drawing/2014/main" id="{D21A383D-9C31-45CF-B27F-8B7291F585AD}"/>
+                <a16:creationId xmlns:a16="http://schemas.microsoft.com/office/drawing/2014/main" id="{DA7A0B98-6F5E-434C-A3BB-A5AC89708140}"/>
               </a:ext>
             </a:extLst>
           </p:cNvPr>
@@ -7731,7 +7731,7 @@
           <p:cNvPr id="9" name="">
             <a:extLst xmlns:a="http://schemas.openxmlformats.org/drawingml/2006/main">
               <a:ext uri="{FF2B5EF4-FFF2-40B4-BE49-F238E27FC236}">
-                <a16:creationId xmlns:a16="http://schemas.microsoft.com/office/drawing/2014/main" id="{5CFDFE10-356F-4296-8264-CD50EBEE3F2D}"/>
+                <a16:creationId xmlns:a16="http://schemas.microsoft.com/office/drawing/2014/main" id="{24F95A7C-E291-4EEA-98E5-BF53B9C9959C}"/>
               </a:ext>
             </a:extLst>
           </p:cNvPr>
@@ -7793,7 +7793,7 @@
           <p:cNvPr id="10" name="">
             <a:extLst xmlns:a="http://schemas.openxmlformats.org/drawingml/2006/main">
               <a:ext uri="{FF2B5EF4-FFF2-40B4-BE49-F238E27FC236}">
-                <a16:creationId xmlns:a16="http://schemas.microsoft.com/office/drawing/2014/main" id="{A36D7D77-1DC6-49B4-BEB1-32062FFF3790}"/>
+                <a16:creationId xmlns:a16="http://schemas.microsoft.com/office/drawing/2014/main" id="{D91C30E9-7792-41CC-B94C-7628AA88EB83}"/>
               </a:ext>
             </a:extLst>
           </p:cNvPr>
@@ -7855,7 +7855,7 @@
           <p:cNvPr id="11" name="">
             <a:extLst xmlns:a="http://schemas.openxmlformats.org/drawingml/2006/main">
               <a:ext uri="{FF2B5EF4-FFF2-40B4-BE49-F238E27FC236}">
-                <a16:creationId xmlns:a16="http://schemas.microsoft.com/office/drawing/2014/main" id="{7F8E41F1-37B5-4DD7-B612-C4E4D0F9D963}"/>
+                <a16:creationId xmlns:a16="http://schemas.microsoft.com/office/drawing/2014/main" id="{369A993E-D48E-4E23-AB53-A4F1FE96EBBE}"/>
               </a:ext>
             </a:extLst>
           </p:cNvPr>
@@ -7890,7 +7890,7 @@
           <p:cNvPr id="12" name="">
             <a:extLst xmlns:a="http://schemas.openxmlformats.org/drawingml/2006/main">
               <a:ext uri="{FF2B5EF4-FFF2-40B4-BE49-F238E27FC236}">
-                <a16:creationId xmlns:a16="http://schemas.microsoft.com/office/drawing/2014/main" id="{8844644F-0493-46F6-8368-A08310AB2A77}"/>
+                <a16:creationId xmlns:a16="http://schemas.microsoft.com/office/drawing/2014/main" id="{CEADA7D7-5902-48D6-A6E4-8878686F8CBF}"/>
               </a:ext>
             </a:extLst>
           </p:cNvPr>
@@ -7952,7 +7952,7 @@
           <p:cNvPr id="13" name="">
             <a:extLst xmlns:a="http://schemas.openxmlformats.org/drawingml/2006/main">
               <a:ext uri="{FF2B5EF4-FFF2-40B4-BE49-F238E27FC236}">
-                <a16:creationId xmlns:a16="http://schemas.microsoft.com/office/drawing/2014/main" id="{D78FA0A7-D4AC-4D9F-953D-CE2060B651EC}"/>
+                <a16:creationId xmlns:a16="http://schemas.microsoft.com/office/drawing/2014/main" id="{69BA8D08-A6B9-4D9B-B492-E215F6E273DF}"/>
               </a:ext>
             </a:extLst>
           </p:cNvPr>
@@ -8014,7 +8014,7 @@
           <p:cNvPr id="14" name="">
             <a:extLst xmlns:a="http://schemas.openxmlformats.org/drawingml/2006/main">
               <a:ext uri="{FF2B5EF4-FFF2-40B4-BE49-F238E27FC236}">
-                <a16:creationId xmlns:a16="http://schemas.microsoft.com/office/drawing/2014/main" id="{1DACE861-617B-45D9-95B6-96A41A5918E8}"/>
+                <a16:creationId xmlns:a16="http://schemas.microsoft.com/office/drawing/2014/main" id="{55E233A4-7370-4563-9DDB-4CCBFC955F08}"/>
               </a:ext>
             </a:extLst>
           </p:cNvPr>
@@ -8049,7 +8049,7 @@
           <p:cNvPr id="15" name="">
             <a:extLst xmlns:a="http://schemas.openxmlformats.org/drawingml/2006/main">
               <a:ext uri="{FF2B5EF4-FFF2-40B4-BE49-F238E27FC236}">
-                <a16:creationId xmlns:a16="http://schemas.microsoft.com/office/drawing/2014/main" id="{D2D86B7B-F1DF-4029-83DC-BFFC07DE184B}"/>
+                <a16:creationId xmlns:a16="http://schemas.microsoft.com/office/drawing/2014/main" id="{DEB6949F-F8CA-49AA-8BF3-608AFDD29DAC}"/>
               </a:ext>
             </a:extLst>
           </p:cNvPr>
@@ -8111,7 +8111,7 @@
           <p:cNvPr id="16" name="">
             <a:extLst xmlns:a="http://schemas.openxmlformats.org/drawingml/2006/main">
               <a:ext uri="{FF2B5EF4-FFF2-40B4-BE49-F238E27FC236}">
-                <a16:creationId xmlns:a16="http://schemas.microsoft.com/office/drawing/2014/main" id="{F350D569-3CD1-4434-98F4-7A388A989486}"/>
+                <a16:creationId xmlns:a16="http://schemas.microsoft.com/office/drawing/2014/main" id="{33D9C1A1-0430-4980-A52F-7B93F2BA041F}"/>
               </a:ext>
             </a:extLst>
           </p:cNvPr>
@@ -8173,7 +8173,7 @@
           <p:cNvPr id="17" name="">
             <a:extLst xmlns:a="http://schemas.openxmlformats.org/drawingml/2006/main">
               <a:ext uri="{FF2B5EF4-FFF2-40B4-BE49-F238E27FC236}">
-                <a16:creationId xmlns:a16="http://schemas.microsoft.com/office/drawing/2014/main" id="{B3135384-820E-4640-A3C5-253C672C8B47}"/>
+                <a16:creationId xmlns:a16="http://schemas.microsoft.com/office/drawing/2014/main" id="{3AAC6A36-E1B6-4F60-86D9-E4FBE84152B2}"/>
               </a:ext>
             </a:extLst>
           </p:cNvPr>
@@ -8208,7 +8208,7 @@
           <p:cNvPr id="18" name="">
             <a:extLst xmlns:a="http://schemas.openxmlformats.org/drawingml/2006/main">
               <a:ext uri="{FF2B5EF4-FFF2-40B4-BE49-F238E27FC236}">
-                <a16:creationId xmlns:a16="http://schemas.microsoft.com/office/drawing/2014/main" id="{E9847645-7A14-4E95-A0FE-13883B6E98B9}"/>
+                <a16:creationId xmlns:a16="http://schemas.microsoft.com/office/drawing/2014/main" id="{F69246A8-0AA7-45D9-BADA-28CB776BB790}"/>
               </a:ext>
             </a:extLst>
           </p:cNvPr>
@@ -8270,7 +8270,7 @@
           <p:cNvPr id="19" name="">
             <a:extLst xmlns:a="http://schemas.openxmlformats.org/drawingml/2006/main">
               <a:ext uri="{FF2B5EF4-FFF2-40B4-BE49-F238E27FC236}">
-                <a16:creationId xmlns:a16="http://schemas.microsoft.com/office/drawing/2014/main" id="{7C577D10-BCE8-4072-B6C2-C80793EFFC5D}"/>
+                <a16:creationId xmlns:a16="http://schemas.microsoft.com/office/drawing/2014/main" id="{01699826-5164-4E8D-A4C6-DDE7F1434FA1}"/>
               </a:ext>
             </a:extLst>
           </p:cNvPr>
@@ -8332,7 +8332,7 @@
           <p:cNvPr id="20" name="">
             <a:extLst xmlns:a="http://schemas.openxmlformats.org/drawingml/2006/main">
               <a:ext uri="{FF2B5EF4-FFF2-40B4-BE49-F238E27FC236}">
-                <a16:creationId xmlns:a16="http://schemas.microsoft.com/office/drawing/2014/main" id="{6E7B95BD-A8CD-4965-AE69-AADDE84E2572}"/>
+                <a16:creationId xmlns:a16="http://schemas.microsoft.com/office/drawing/2014/main" id="{53E9ED60-4E90-4B39-9832-2706A736931F}"/>
               </a:ext>
             </a:extLst>
           </p:cNvPr>
@@ -8367,7 +8367,7 @@
           <p:cNvPr id="21" name="">
             <a:extLst xmlns:a="http://schemas.openxmlformats.org/drawingml/2006/main">
               <a:ext uri="{FF2B5EF4-FFF2-40B4-BE49-F238E27FC236}">
-                <a16:creationId xmlns:a16="http://schemas.microsoft.com/office/drawing/2014/main" id="{302F6895-0241-46AD-AD36-0E545C7FA7EC}"/>
+                <a16:creationId xmlns:a16="http://schemas.microsoft.com/office/drawing/2014/main" id="{EAB3D219-0422-491D-8E9C-0DD4752D0C90}"/>
               </a:ext>
             </a:extLst>
           </p:cNvPr>
@@ -8429,7 +8429,7 @@
           <p:cNvPr id="22" name="">
             <a:extLst xmlns:a="http://schemas.openxmlformats.org/drawingml/2006/main">
               <a:ext uri="{FF2B5EF4-FFF2-40B4-BE49-F238E27FC236}">
-                <a16:creationId xmlns:a16="http://schemas.microsoft.com/office/drawing/2014/main" id="{52ADEDC3-4817-4BE9-8831-9A08B1641F7B}"/>
+                <a16:creationId xmlns:a16="http://schemas.microsoft.com/office/drawing/2014/main" id="{DB8199A6-1C12-4538-AD54-DD0F70C0A916}"/>
               </a:ext>
             </a:extLst>
           </p:cNvPr>
@@ -8491,7 +8491,7 @@
           <p:cNvPr id="23" name="">
             <a:extLst xmlns:a="http://schemas.openxmlformats.org/drawingml/2006/main">
               <a:ext uri="{FF2B5EF4-FFF2-40B4-BE49-F238E27FC236}">
-                <a16:creationId xmlns:a16="http://schemas.microsoft.com/office/drawing/2014/main" id="{ED5C43C0-CF9B-4CF1-9BCF-7D46778D6387}"/>
+                <a16:creationId xmlns:a16="http://schemas.microsoft.com/office/drawing/2014/main" id="{36804704-B086-43BB-B243-0C73E9A581CB}"/>
               </a:ext>
             </a:extLst>
           </p:cNvPr>
@@ -8526,7 +8526,7 @@
           <p:cNvPr id="24" name="">
             <a:extLst xmlns:a="http://schemas.openxmlformats.org/drawingml/2006/main">
               <a:ext uri="{FF2B5EF4-FFF2-40B4-BE49-F238E27FC236}">
-                <a16:creationId xmlns:a16="http://schemas.microsoft.com/office/drawing/2014/main" id="{3F67C390-49FC-4EE2-8220-C29852645142}"/>
+                <a16:creationId xmlns:a16="http://schemas.microsoft.com/office/drawing/2014/main" id="{233EE1DA-5C31-44DA-9CE9-6C8286096720}"/>
               </a:ext>
             </a:extLst>
           </p:cNvPr>
@@ -8588,7 +8588,7 @@
           <p:cNvPr id="25" name="">
             <a:extLst xmlns:a="http://schemas.openxmlformats.org/drawingml/2006/main">
               <a:ext uri="{FF2B5EF4-FFF2-40B4-BE49-F238E27FC236}">
-                <a16:creationId xmlns:a16="http://schemas.microsoft.com/office/drawing/2014/main" id="{17B16134-76B1-437F-A9C8-E0FA18732E57}"/>
+                <a16:creationId xmlns:a16="http://schemas.microsoft.com/office/drawing/2014/main" id="{5B415390-DD03-4796-8375-B990512F2179}"/>
               </a:ext>
             </a:extLst>
           </p:cNvPr>
@@ -8648,7 +8648,7 @@
     </p:spTree>
     <p:extLst>
       <p:ext uri="{BB962C8B-B14F-4D97-AF65-F5344CB8AC3E}">
-        <p14:creationId xmlns:p14="http://schemas.microsoft.com/office/powerpoint/2010/main" val="1335780115"/>
+        <p14:creationId xmlns:p14="http://schemas.microsoft.com/office/powerpoint/2010/main" val="1084229625"/>
       </p:ext>
     </p:extLst>
   </p:cSld>
@@ -8679,7 +8679,7 @@
           <p:cNvPr id="26" name="">
             <a:extLst xmlns:a="http://schemas.openxmlformats.org/drawingml/2006/main">
               <a:ext uri="{FF2B5EF4-FFF2-40B4-BE49-F238E27FC236}">
-                <a16:creationId xmlns:a16="http://schemas.microsoft.com/office/drawing/2014/main" id="{A2083196-1495-4EAF-9413-152338981FF4}"/>
+                <a16:creationId xmlns:a16="http://schemas.microsoft.com/office/drawing/2014/main" id="{67A5CA01-73D1-48F0-AB14-446F0E589014}"/>
               </a:ext>
             </a:extLst>
           </p:cNvPr>
@@ -8710,7 +8710,7 @@
           <p:cNvPr id="2" name="">
             <a:extLst xmlns:a="http://schemas.openxmlformats.org/drawingml/2006/main">
               <a:ext uri="{FF2B5EF4-FFF2-40B4-BE49-F238E27FC236}">
-                <a16:creationId xmlns:a16="http://schemas.microsoft.com/office/drawing/2014/main" id="{EA73E20B-B90B-4FB0-8D76-72BE0C479BBD}"/>
+                <a16:creationId xmlns:a16="http://schemas.microsoft.com/office/drawing/2014/main" id="{FC6D7891-442F-4B67-9559-932A32DC6D60}"/>
               </a:ext>
             </a:extLst>
           </p:cNvPr>
@@ -8762,7 +8762,7 @@
                 <a:ea typeface="Aptos"/>
                 <a:cs typeface="Aptos"/>
               </a:rPr>
-              <a:t>ΚΙΝΔΥΝΟΙ</a:t>
+              <a:t>ΦΑΣΗ 0</a:t>
             </a:r>
           </a:p>
         </p:txBody>
@@ -8772,7 +8772,7 @@
           <p:cNvPr id="3" name="">
             <a:extLst xmlns:a="http://schemas.openxmlformats.org/drawingml/2006/main">
               <a:ext uri="{FF2B5EF4-FFF2-40B4-BE49-F238E27FC236}">
-                <a16:creationId xmlns:a16="http://schemas.microsoft.com/office/drawing/2014/main" id="{7EE9FE55-EAEF-4B40-84AA-896A23352324}"/>
+                <a16:creationId xmlns:a16="http://schemas.microsoft.com/office/drawing/2014/main" id="{CFAF3112-6A5E-4DB5-AE2F-D3220591D0B2}"/>
               </a:ext>
             </a:extLst>
           </p:cNvPr>
@@ -8806,7 +8806,7 @@
                 <a:spcPct val="108000"/>
               </a:lnSpc>
               <a:buNone/>
-              <a:defRPr sz="3150" b="1">
+              <a:defRPr sz="2550" b="1">
                 <a:solidFill>
                   <a:srgbClr val="071426"/>
                 </a:solidFill>
@@ -8816,7 +8816,7 @@
               </a:defRPr>
             </a:pPr>
             <a:r>
-              <a:rPr sz="3150" b="1">
+              <a:rPr sz="2550" b="1">
                 <a:solidFill>
                   <a:srgbClr val="071426"/>
                 </a:solidFill>
@@ -8834,7 +8834,7 @@
           <p:cNvPr id="4" name="">
             <a:extLst xmlns:a="http://schemas.openxmlformats.org/drawingml/2006/main">
               <a:ext uri="{FF2B5EF4-FFF2-40B4-BE49-F238E27FC236}">
-                <a16:creationId xmlns:a16="http://schemas.microsoft.com/office/drawing/2014/main" id="{7A6B545E-844A-459F-AA1A-550208326E13}"/>
+                <a16:creationId xmlns:a16="http://schemas.microsoft.com/office/drawing/2014/main" id="{9BE10E8E-9ECD-42A7-BDEC-2648D6C5DFEA}"/>
               </a:ext>
             </a:extLst>
           </p:cNvPr>
@@ -8869,7 +8869,7 @@
           <p:nvPr/>
         </p:nvPicPr>
         <p:blipFill>
-          <a:blip xmlns:r="http://schemas.openxmlformats.org/officeDocument/2006/relationships" xmlns:a="http://schemas.openxmlformats.org/drawingml/2006/main" r:embed="R3a0e6613e9254ab6"/>
+          <a:blip xmlns:r="http://schemas.openxmlformats.org/officeDocument/2006/relationships" xmlns:a="http://schemas.openxmlformats.org/drawingml/2006/main" r:embed="R9a24569e57334033"/>
           <a:srcRect xmlns:a="http://schemas.openxmlformats.org/drawingml/2006/main" l="0" t="0" r="0" b="0"/>
           <a:stretch xmlns:a="http://schemas.openxmlformats.org/drawingml/2006/main">
             <a:fillRect l="0" t="0" r="0" b="0"/>
@@ -8890,7 +8890,7 @@
           <p:cNvPr id="6" name="">
             <a:extLst xmlns:a="http://schemas.openxmlformats.org/drawingml/2006/main">
               <a:ext uri="{FF2B5EF4-FFF2-40B4-BE49-F238E27FC236}">
-                <a16:creationId xmlns:a16="http://schemas.microsoft.com/office/drawing/2014/main" id="{50EB381E-F3C6-483C-B802-9D7CAD3F31F1}"/>
+                <a16:creationId xmlns:a16="http://schemas.microsoft.com/office/drawing/2014/main" id="{BC1CD9AA-C911-4214-AC85-07FD39BFB660}"/>
               </a:ext>
             </a:extLst>
           </p:cNvPr>
@@ -8952,7 +8952,7 @@
           <p:cNvPr id="7" name="">
             <a:extLst xmlns:a="http://schemas.openxmlformats.org/drawingml/2006/main">
               <a:ext uri="{FF2B5EF4-FFF2-40B4-BE49-F238E27FC236}">
-                <a16:creationId xmlns:a16="http://schemas.microsoft.com/office/drawing/2014/main" id="{C7129AB7-5B29-486E-9F25-724BB80CE941}"/>
+                <a16:creationId xmlns:a16="http://schemas.microsoft.com/office/drawing/2014/main" id="{33CCDC6F-B6AD-40C6-9ADD-702F08DEBE48}"/>
               </a:ext>
             </a:extLst>
           </p:cNvPr>
@@ -9014,7 +9014,7 @@
           <p:cNvPr id="8" name="">
             <a:extLst xmlns:a="http://schemas.openxmlformats.org/drawingml/2006/main">
               <a:ext uri="{FF2B5EF4-FFF2-40B4-BE49-F238E27FC236}">
-                <a16:creationId xmlns:a16="http://schemas.microsoft.com/office/drawing/2014/main" id="{727EA6E8-837A-4AB2-AF72-9620E4A2346D}"/>
+                <a16:creationId xmlns:a16="http://schemas.microsoft.com/office/drawing/2014/main" id="{C10FB82E-7FE3-45D8-9572-76FE5CE2AABD}"/>
               </a:ext>
             </a:extLst>
           </p:cNvPr>
@@ -9076,7 +9076,7 @@
           <p:cNvPr id="9" name="">
             <a:extLst xmlns:a="http://schemas.openxmlformats.org/drawingml/2006/main">
               <a:ext uri="{FF2B5EF4-FFF2-40B4-BE49-F238E27FC236}">
-                <a16:creationId xmlns:a16="http://schemas.microsoft.com/office/drawing/2014/main" id="{EADF9D60-F801-44EE-B44F-F87A65C45C86}"/>
+                <a16:creationId xmlns:a16="http://schemas.microsoft.com/office/drawing/2014/main" id="{A567ED03-EBDB-4977-9AC7-990DA2E9DC9B}"/>
               </a:ext>
             </a:extLst>
           </p:cNvPr>
@@ -9111,7 +9111,7 @@
           <p:cNvPr id="10" name="">
             <a:extLst xmlns:a="http://schemas.openxmlformats.org/drawingml/2006/main">
               <a:ext uri="{FF2B5EF4-FFF2-40B4-BE49-F238E27FC236}">
-                <a16:creationId xmlns:a16="http://schemas.microsoft.com/office/drawing/2014/main" id="{7C06DE55-E678-4AE5-85FC-2DAC3A97FF55}"/>
+                <a16:creationId xmlns:a16="http://schemas.microsoft.com/office/drawing/2014/main" id="{660E6B39-5ABE-4ACE-A4CD-D78D76F12E6F}"/>
               </a:ext>
             </a:extLst>
           </p:cNvPr>
@@ -9142,7 +9142,7 @@
           <p:cNvPr id="11" name="">
             <a:extLst xmlns:a="http://schemas.openxmlformats.org/drawingml/2006/main">
               <a:ext uri="{FF2B5EF4-FFF2-40B4-BE49-F238E27FC236}">
-                <a16:creationId xmlns:a16="http://schemas.microsoft.com/office/drawing/2014/main" id="{F0B4BA54-166A-436A-9A4D-A9D69402FDA5}"/>
+                <a16:creationId xmlns:a16="http://schemas.microsoft.com/office/drawing/2014/main" id="{279C7961-2F17-4508-9322-30DCC5079BEE}"/>
               </a:ext>
             </a:extLst>
           </p:cNvPr>
@@ -9204,7 +9204,7 @@
           <p:cNvPr id="12" name="">
             <a:extLst xmlns:a="http://schemas.openxmlformats.org/drawingml/2006/main">
               <a:ext uri="{FF2B5EF4-FFF2-40B4-BE49-F238E27FC236}">
-                <a16:creationId xmlns:a16="http://schemas.microsoft.com/office/drawing/2014/main" id="{91462358-A806-4173-A3B0-AF21A81F1853}"/>
+                <a16:creationId xmlns:a16="http://schemas.microsoft.com/office/drawing/2014/main" id="{1E28DD6F-5061-4ED4-BC2D-EC88E0A4EBEA}"/>
               </a:ext>
             </a:extLst>
           </p:cNvPr>
@@ -9266,7 +9266,7 @@
           <p:cNvPr id="13" name="">
             <a:extLst xmlns:a="http://schemas.openxmlformats.org/drawingml/2006/main">
               <a:ext uri="{FF2B5EF4-FFF2-40B4-BE49-F238E27FC236}">
-                <a16:creationId xmlns:a16="http://schemas.microsoft.com/office/drawing/2014/main" id="{2328E411-582F-40CA-9F09-C6FDE8445992}"/>
+                <a16:creationId xmlns:a16="http://schemas.microsoft.com/office/drawing/2014/main" id="{2D5EEB9D-64CC-44BC-BEC6-BBA9A4C4CB83}"/>
               </a:ext>
             </a:extLst>
           </p:cNvPr>
@@ -9301,7 +9301,7 @@
           <p:cNvPr id="14" name="">
             <a:extLst xmlns:a="http://schemas.openxmlformats.org/drawingml/2006/main">
               <a:ext uri="{FF2B5EF4-FFF2-40B4-BE49-F238E27FC236}">
-                <a16:creationId xmlns:a16="http://schemas.microsoft.com/office/drawing/2014/main" id="{73A6D4D4-DC93-4B3D-AC0E-7AED7BF80402}"/>
+                <a16:creationId xmlns:a16="http://schemas.microsoft.com/office/drawing/2014/main" id="{6387BD77-19CC-4524-AD93-1B36CEF331CA}"/>
               </a:ext>
             </a:extLst>
           </p:cNvPr>
@@ -9332,7 +9332,7 @@
           <p:cNvPr id="15" name="">
             <a:extLst xmlns:a="http://schemas.openxmlformats.org/drawingml/2006/main">
               <a:ext uri="{FF2B5EF4-FFF2-40B4-BE49-F238E27FC236}">
-                <a16:creationId xmlns:a16="http://schemas.microsoft.com/office/drawing/2014/main" id="{57763ABF-26EC-4FFD-9EC2-C4E2AC0FD168}"/>
+                <a16:creationId xmlns:a16="http://schemas.microsoft.com/office/drawing/2014/main" id="{9F5BFB6C-696F-49F9-AF03-E15AB535F49E}"/>
               </a:ext>
             </a:extLst>
           </p:cNvPr>
@@ -9394,7 +9394,7 @@
           <p:cNvPr id="16" name="">
             <a:extLst xmlns:a="http://schemas.openxmlformats.org/drawingml/2006/main">
               <a:ext uri="{FF2B5EF4-FFF2-40B4-BE49-F238E27FC236}">
-                <a16:creationId xmlns:a16="http://schemas.microsoft.com/office/drawing/2014/main" id="{DF7972A1-E9D6-4353-8431-2D298472C874}"/>
+                <a16:creationId xmlns:a16="http://schemas.microsoft.com/office/drawing/2014/main" id="{D574CC77-C34A-427B-8D50-54D23C4CD7D1}"/>
               </a:ext>
             </a:extLst>
           </p:cNvPr>
@@ -9456,7 +9456,7 @@
           <p:cNvPr id="17" name="">
             <a:extLst xmlns:a="http://schemas.openxmlformats.org/drawingml/2006/main">
               <a:ext uri="{FF2B5EF4-FFF2-40B4-BE49-F238E27FC236}">
-                <a16:creationId xmlns:a16="http://schemas.microsoft.com/office/drawing/2014/main" id="{DCE09EC0-B03A-4822-AB66-37F1EC64694F}"/>
+                <a16:creationId xmlns:a16="http://schemas.microsoft.com/office/drawing/2014/main" id="{FBDFF711-80CD-4E5A-9C24-02419D117123}"/>
               </a:ext>
             </a:extLst>
           </p:cNvPr>
@@ -9491,7 +9491,7 @@
           <p:cNvPr id="18" name="">
             <a:extLst xmlns:a="http://schemas.openxmlformats.org/drawingml/2006/main">
               <a:ext uri="{FF2B5EF4-FFF2-40B4-BE49-F238E27FC236}">
-                <a16:creationId xmlns:a16="http://schemas.microsoft.com/office/drawing/2014/main" id="{216F6BB8-7A58-48B8-93A0-DDAFCBE4CE84}"/>
+                <a16:creationId xmlns:a16="http://schemas.microsoft.com/office/drawing/2014/main" id="{3BEEA995-7C98-44FB-91E8-414B4ED29CC9}"/>
               </a:ext>
             </a:extLst>
           </p:cNvPr>
@@ -9522,7 +9522,7 @@
           <p:cNvPr id="19" name="">
             <a:extLst xmlns:a="http://schemas.openxmlformats.org/drawingml/2006/main">
               <a:ext uri="{FF2B5EF4-FFF2-40B4-BE49-F238E27FC236}">
-                <a16:creationId xmlns:a16="http://schemas.microsoft.com/office/drawing/2014/main" id="{B58CE334-7B74-4733-BDFF-47272706345A}"/>
+                <a16:creationId xmlns:a16="http://schemas.microsoft.com/office/drawing/2014/main" id="{DA8DB510-52AA-44B7-B5FD-5B6151631D4D}"/>
               </a:ext>
             </a:extLst>
           </p:cNvPr>
@@ -9584,7 +9584,7 @@
           <p:cNvPr id="20" name="">
             <a:extLst xmlns:a="http://schemas.openxmlformats.org/drawingml/2006/main">
               <a:ext uri="{FF2B5EF4-FFF2-40B4-BE49-F238E27FC236}">
-                <a16:creationId xmlns:a16="http://schemas.microsoft.com/office/drawing/2014/main" id="{0650B1B1-9354-4D25-B82B-A2572547E8B7}"/>
+                <a16:creationId xmlns:a16="http://schemas.microsoft.com/office/drawing/2014/main" id="{2ED1BC9F-0F19-436A-858F-9CE58B07078E}"/>
               </a:ext>
             </a:extLst>
           </p:cNvPr>
@@ -9646,7 +9646,7 @@
           <p:cNvPr id="21" name="">
             <a:extLst xmlns:a="http://schemas.openxmlformats.org/drawingml/2006/main">
               <a:ext uri="{FF2B5EF4-FFF2-40B4-BE49-F238E27FC236}">
-                <a16:creationId xmlns:a16="http://schemas.microsoft.com/office/drawing/2014/main" id="{E82C506A-F796-4A97-B027-380671DD35DC}"/>
+                <a16:creationId xmlns:a16="http://schemas.microsoft.com/office/drawing/2014/main" id="{66B184D2-1289-44B3-9934-40144D6D8A83}"/>
               </a:ext>
             </a:extLst>
           </p:cNvPr>
@@ -9681,7 +9681,7 @@
           <p:cNvPr id="22" name="">
             <a:extLst xmlns:a="http://schemas.openxmlformats.org/drawingml/2006/main">
               <a:ext uri="{FF2B5EF4-FFF2-40B4-BE49-F238E27FC236}">
-                <a16:creationId xmlns:a16="http://schemas.microsoft.com/office/drawing/2014/main" id="{5CD936E5-5F07-4FD3-A02E-392BED7E8DC2}"/>
+                <a16:creationId xmlns:a16="http://schemas.microsoft.com/office/drawing/2014/main" id="{B80D88B4-120C-4E21-AEDA-3FB516825B8C}"/>
               </a:ext>
             </a:extLst>
           </p:cNvPr>
@@ -9712,7 +9712,7 @@
           <p:cNvPr id="23" name="">
             <a:extLst xmlns:a="http://schemas.openxmlformats.org/drawingml/2006/main">
               <a:ext uri="{FF2B5EF4-FFF2-40B4-BE49-F238E27FC236}">
-                <a16:creationId xmlns:a16="http://schemas.microsoft.com/office/drawing/2014/main" id="{B29D6EDF-EA4F-494F-A831-3BE862B2F4E0}"/>
+                <a16:creationId xmlns:a16="http://schemas.microsoft.com/office/drawing/2014/main" id="{C265E049-B50E-4F9B-938F-23128090D259}"/>
               </a:ext>
             </a:extLst>
           </p:cNvPr>
@@ -9774,7 +9774,7 @@
           <p:cNvPr id="24" name="">
             <a:extLst xmlns:a="http://schemas.openxmlformats.org/drawingml/2006/main">
               <a:ext uri="{FF2B5EF4-FFF2-40B4-BE49-F238E27FC236}">
-                <a16:creationId xmlns:a16="http://schemas.microsoft.com/office/drawing/2014/main" id="{9FABF3F2-02D5-4E7A-978C-822B2DC15F04}"/>
+                <a16:creationId xmlns:a16="http://schemas.microsoft.com/office/drawing/2014/main" id="{3915BC5A-5AF5-41FC-8DCD-D3596BA6E4B4}"/>
               </a:ext>
             </a:extLst>
           </p:cNvPr>
@@ -9836,7 +9836,7 @@
           <p:cNvPr id="25" name="">
             <a:extLst xmlns:a="http://schemas.openxmlformats.org/drawingml/2006/main">
               <a:ext uri="{FF2B5EF4-FFF2-40B4-BE49-F238E27FC236}">
-                <a16:creationId xmlns:a16="http://schemas.microsoft.com/office/drawing/2014/main" id="{D8D21A54-A069-4440-8C50-5C11532205DC}"/>
+                <a16:creationId xmlns:a16="http://schemas.microsoft.com/office/drawing/2014/main" id="{6BE4A0B8-1013-4537-8944-92941C723DDC}"/>
               </a:ext>
             </a:extLst>
           </p:cNvPr>
@@ -9898,7 +9898,7 @@
     </p:spTree>
     <p:extLst>
       <p:ext uri="{BB962C8B-B14F-4D97-AF65-F5344CB8AC3E}">
-        <p14:creationId xmlns:p14="http://schemas.microsoft.com/office/powerpoint/2010/main" val="195308556"/>
+        <p14:creationId xmlns:p14="http://schemas.microsoft.com/office/powerpoint/2010/main" val="2033560369"/>
       </p:ext>
     </p:extLst>
   </p:cSld>
@@ -9929,7 +9929,7 @@
           <p:cNvPr id="24" name="">
             <a:extLst xmlns:a="http://schemas.openxmlformats.org/drawingml/2006/main">
               <a:ext uri="{FF2B5EF4-FFF2-40B4-BE49-F238E27FC236}">
-                <a16:creationId xmlns:a16="http://schemas.microsoft.com/office/drawing/2014/main" id="{9C825C8E-9F89-4688-9DD4-94BFDEB4DED0}"/>
+                <a16:creationId xmlns:a16="http://schemas.microsoft.com/office/drawing/2014/main" id="{228CDE51-CEAA-49C1-9663-D8E550CB99E8}"/>
               </a:ext>
             </a:extLst>
           </p:cNvPr>
@@ -9960,7 +9960,7 @@
           <p:cNvPr id="2" name="">
             <a:extLst xmlns:a="http://schemas.openxmlformats.org/drawingml/2006/main">
               <a:ext uri="{FF2B5EF4-FFF2-40B4-BE49-F238E27FC236}">
-                <a16:creationId xmlns:a16="http://schemas.microsoft.com/office/drawing/2014/main" id="{5A7479FA-EE71-40D1-B2A3-234DAFF85EB4}"/>
+                <a16:creationId xmlns:a16="http://schemas.microsoft.com/office/drawing/2014/main" id="{07341AEE-6A58-4D36-ADB4-EA540915FBF5}"/>
               </a:ext>
             </a:extLst>
           </p:cNvPr>
@@ -10012,7 +10012,7 @@
                 <a:ea typeface="Aptos"/>
                 <a:cs typeface="Aptos"/>
               </a:rPr>
-              <a:t>ΦΑΣΗ 0</a:t>
+              <a:t>ΑΠΟΦΑΣΗ</a:t>
             </a:r>
           </a:p>
         </p:txBody>
@@ -10022,7 +10022,7 @@
           <p:cNvPr id="3" name="">
             <a:extLst xmlns:a="http://schemas.openxmlformats.org/drawingml/2006/main">
               <a:ext uri="{FF2B5EF4-FFF2-40B4-BE49-F238E27FC236}">
-                <a16:creationId xmlns:a16="http://schemas.microsoft.com/office/drawing/2014/main" id="{FFAF3EE6-9920-4636-BF2A-C09693464B7F}"/>
+                <a16:creationId xmlns:a16="http://schemas.microsoft.com/office/drawing/2014/main" id="{0126AF86-A18F-4F66-A28D-934EE0BE4434}"/>
               </a:ext>
             </a:extLst>
           </p:cNvPr>
@@ -10056,7 +10056,7 @@
                 <a:spcPct val="108000"/>
               </a:lnSpc>
               <a:buNone/>
-              <a:defRPr sz="3150" b="1">
+              <a:defRPr sz="2550" b="1">
                 <a:solidFill>
                   <a:srgbClr val="071426"/>
                 </a:solidFill>
@@ -10066,7 +10066,7 @@
               </a:defRPr>
             </a:pPr>
             <a:r>
-              <a:rPr sz="3150" b="1">
+              <a:rPr sz="2550" b="1">
                 <a:solidFill>
                   <a:srgbClr val="071426"/>
                 </a:solidFill>
@@ -10084,7 +10084,7 @@
           <p:cNvPr id="4" name="">
             <a:extLst xmlns:a="http://schemas.openxmlformats.org/drawingml/2006/main">
               <a:ext uri="{FF2B5EF4-FFF2-40B4-BE49-F238E27FC236}">
-                <a16:creationId xmlns:a16="http://schemas.microsoft.com/office/drawing/2014/main" id="{C0632EF4-D25E-4875-9B67-5331A1F9AE1A}"/>
+                <a16:creationId xmlns:a16="http://schemas.microsoft.com/office/drawing/2014/main" id="{C3366E14-3D15-49BA-A54D-665B9B4D362C}"/>
               </a:ext>
             </a:extLst>
           </p:cNvPr>
@@ -10119,7 +10119,7 @@
           <p:nvPr/>
         </p:nvPicPr>
         <p:blipFill>
-          <a:blip xmlns:r="http://schemas.openxmlformats.org/officeDocument/2006/relationships" xmlns:a="http://schemas.openxmlformats.org/drawingml/2006/main" r:embed="R95c6e40437fb4419"/>
+          <a:blip xmlns:r="http://schemas.openxmlformats.org/officeDocument/2006/relationships" xmlns:a="http://schemas.openxmlformats.org/drawingml/2006/main" r:embed="R867b99ee9d754e26"/>
           <a:srcRect xmlns:a="http://schemas.openxmlformats.org/drawingml/2006/main" l="0" t="0" r="0" b="0"/>
           <a:stretch xmlns:a="http://schemas.openxmlformats.org/drawingml/2006/main">
             <a:fillRect l="0" t="0" r="0" b="0"/>
@@ -10140,7 +10140,7 @@
           <p:cNvPr id="6" name="">
             <a:extLst xmlns:a="http://schemas.openxmlformats.org/drawingml/2006/main">
               <a:ext uri="{FF2B5EF4-FFF2-40B4-BE49-F238E27FC236}">
-                <a16:creationId xmlns:a16="http://schemas.microsoft.com/office/drawing/2014/main" id="{7C56D597-C874-41A1-8582-3875EA134CC1}"/>
+                <a16:creationId xmlns:a16="http://schemas.microsoft.com/office/drawing/2014/main" id="{17DA49FC-5D77-415F-90CD-A2A85BF7DD4E}"/>
               </a:ext>
             </a:extLst>
           </p:cNvPr>
@@ -10202,7 +10202,7 @@
           <p:cNvPr id="7" name="">
             <a:extLst xmlns:a="http://schemas.openxmlformats.org/drawingml/2006/main">
               <a:ext uri="{FF2B5EF4-FFF2-40B4-BE49-F238E27FC236}">
-                <a16:creationId xmlns:a16="http://schemas.microsoft.com/office/drawing/2014/main" id="{BC3DD52A-7607-45D5-ADCB-20E92ADFD0A9}"/>
+                <a16:creationId xmlns:a16="http://schemas.microsoft.com/office/drawing/2014/main" id="{0A252320-6371-4087-B2FB-69238415636B}"/>
               </a:ext>
             </a:extLst>
           </p:cNvPr>
@@ -10264,7 +10264,7 @@
           <p:cNvPr id="8" name="">
             <a:extLst xmlns:a="http://schemas.openxmlformats.org/drawingml/2006/main">
               <a:ext uri="{FF2B5EF4-FFF2-40B4-BE49-F238E27FC236}">
-                <a16:creationId xmlns:a16="http://schemas.microsoft.com/office/drawing/2014/main" id="{95DFAE2C-0506-47EF-A55C-2ACDFA7F7449}"/>
+                <a16:creationId xmlns:a16="http://schemas.microsoft.com/office/drawing/2014/main" id="{E0419717-A95A-4A87-9175-EEC547BF6520}"/>
               </a:ext>
             </a:extLst>
           </p:cNvPr>
@@ -10295,7 +10295,7 @@
           <p:cNvPr id="9" name="">
             <a:extLst xmlns:a="http://schemas.openxmlformats.org/drawingml/2006/main">
               <a:ext uri="{FF2B5EF4-FFF2-40B4-BE49-F238E27FC236}">
-                <a16:creationId xmlns:a16="http://schemas.microsoft.com/office/drawing/2014/main" id="{B33E892F-F3DD-45DB-86BD-D2A63C65E3BF}"/>
+                <a16:creationId xmlns:a16="http://schemas.microsoft.com/office/drawing/2014/main" id="{2692DDBC-8518-40AF-99FB-288E7708591B}"/>
               </a:ext>
             </a:extLst>
           </p:cNvPr>
@@ -10357,7 +10357,7 @@
           <p:cNvPr id="10" name="">
             <a:extLst xmlns:a="http://schemas.openxmlformats.org/drawingml/2006/main">
               <a:ext uri="{FF2B5EF4-FFF2-40B4-BE49-F238E27FC236}">
-                <a16:creationId xmlns:a16="http://schemas.microsoft.com/office/drawing/2014/main" id="{36A39830-8F47-422A-9300-4FE7FE5B7713}"/>
+                <a16:creationId xmlns:a16="http://schemas.microsoft.com/office/drawing/2014/main" id="{F8F57D88-7F64-4D74-9F5B-4F937369993B}"/>
               </a:ext>
             </a:extLst>
           </p:cNvPr>
@@ -10419,7 +10419,7 @@
           <p:cNvPr id="11" name="">
             <a:extLst xmlns:a="http://schemas.openxmlformats.org/drawingml/2006/main">
               <a:ext uri="{FF2B5EF4-FFF2-40B4-BE49-F238E27FC236}">
-                <a16:creationId xmlns:a16="http://schemas.microsoft.com/office/drawing/2014/main" id="{52B21536-446B-40DB-A7DF-81F2EF31C5C4}"/>
+                <a16:creationId xmlns:a16="http://schemas.microsoft.com/office/drawing/2014/main" id="{73051A46-7546-4D6E-90DA-03AB4E835DE1}"/>
               </a:ext>
             </a:extLst>
           </p:cNvPr>
@@ -10450,7 +10450,7 @@
           <p:cNvPr id="12" name="">
             <a:extLst xmlns:a="http://schemas.openxmlformats.org/drawingml/2006/main">
               <a:ext uri="{FF2B5EF4-FFF2-40B4-BE49-F238E27FC236}">
-                <a16:creationId xmlns:a16="http://schemas.microsoft.com/office/drawing/2014/main" id="{FD220083-F950-4A57-B640-C5B5D4C4051F}"/>
+                <a16:creationId xmlns:a16="http://schemas.microsoft.com/office/drawing/2014/main" id="{D681713C-5980-4A4D-A973-098E9BFED3D5}"/>
               </a:ext>
             </a:extLst>
           </p:cNvPr>
@@ -10512,7 +10512,7 @@
           <p:cNvPr id="13" name="">
             <a:extLst xmlns:a="http://schemas.openxmlformats.org/drawingml/2006/main">
               <a:ext uri="{FF2B5EF4-FFF2-40B4-BE49-F238E27FC236}">
-                <a16:creationId xmlns:a16="http://schemas.microsoft.com/office/drawing/2014/main" id="{A34269A0-1C95-4ACE-A625-88955D096365}"/>
+                <a16:creationId xmlns:a16="http://schemas.microsoft.com/office/drawing/2014/main" id="{391153BC-68C4-4807-9F25-9ABE178D6ACE}"/>
               </a:ext>
             </a:extLst>
           </p:cNvPr>
@@ -10574,7 +10574,7 @@
           <p:cNvPr id="14" name="">
             <a:extLst xmlns:a="http://schemas.openxmlformats.org/drawingml/2006/main">
               <a:ext uri="{FF2B5EF4-FFF2-40B4-BE49-F238E27FC236}">
-                <a16:creationId xmlns:a16="http://schemas.microsoft.com/office/drawing/2014/main" id="{E183CC79-EADF-4716-9372-579E240A5C91}"/>
+                <a16:creationId xmlns:a16="http://schemas.microsoft.com/office/drawing/2014/main" id="{76823E8E-AE89-4D4D-8DDD-78B29C6C03EE}"/>
               </a:ext>
             </a:extLst>
           </p:cNvPr>
@@ -10605,7 +10605,7 @@
           <p:cNvPr id="15" name="">
             <a:extLst xmlns:a="http://schemas.openxmlformats.org/drawingml/2006/main">
               <a:ext uri="{FF2B5EF4-FFF2-40B4-BE49-F238E27FC236}">
-                <a16:creationId xmlns:a16="http://schemas.microsoft.com/office/drawing/2014/main" id="{F7535DBB-B998-45DD-A46D-5F2ACE1011A1}"/>
+                <a16:creationId xmlns:a16="http://schemas.microsoft.com/office/drawing/2014/main" id="{469ACB02-2A18-44ED-8EC0-BAF1FDE323B5}"/>
               </a:ext>
             </a:extLst>
           </p:cNvPr>
@@ -10667,7 +10667,7 @@
           <p:cNvPr id="16" name="">
             <a:extLst xmlns:a="http://schemas.openxmlformats.org/drawingml/2006/main">
               <a:ext uri="{FF2B5EF4-FFF2-40B4-BE49-F238E27FC236}">
-                <a16:creationId xmlns:a16="http://schemas.microsoft.com/office/drawing/2014/main" id="{17D2625A-05BF-47D1-8A17-0F4E1775C3A1}"/>
+                <a16:creationId xmlns:a16="http://schemas.microsoft.com/office/drawing/2014/main" id="{5ABA628B-E8C3-43DD-AFB9-D7203A1924CB}"/>
               </a:ext>
             </a:extLst>
           </p:cNvPr>
@@ -10729,7 +10729,7 @@
           <p:cNvPr id="17" name="">
             <a:extLst xmlns:a="http://schemas.openxmlformats.org/drawingml/2006/main">
               <a:ext uri="{FF2B5EF4-FFF2-40B4-BE49-F238E27FC236}">
-                <a16:creationId xmlns:a16="http://schemas.microsoft.com/office/drawing/2014/main" id="{B148C553-EA84-4A3F-89BE-C061816A5C46}"/>
+                <a16:creationId xmlns:a16="http://schemas.microsoft.com/office/drawing/2014/main" id="{48A00E3F-083C-498E-B6CB-1B86F4EB737C}"/>
               </a:ext>
             </a:extLst>
           </p:cNvPr>
@@ -10760,7 +10760,7 @@
           <p:cNvPr id="18" name="">
             <a:extLst xmlns:a="http://schemas.openxmlformats.org/drawingml/2006/main">
               <a:ext uri="{FF2B5EF4-FFF2-40B4-BE49-F238E27FC236}">
-                <a16:creationId xmlns:a16="http://schemas.microsoft.com/office/drawing/2014/main" id="{974EBB1D-F8D0-469D-9ACF-950872EDE047}"/>
+                <a16:creationId xmlns:a16="http://schemas.microsoft.com/office/drawing/2014/main" id="{A71625B6-20DA-4337-BE5D-2E1076F63DEF}"/>
               </a:ext>
             </a:extLst>
           </p:cNvPr>
@@ -10822,7 +10822,7 @@
           <p:cNvPr id="19" name="">
             <a:extLst xmlns:a="http://schemas.openxmlformats.org/drawingml/2006/main">
               <a:ext uri="{FF2B5EF4-FFF2-40B4-BE49-F238E27FC236}">
-                <a16:creationId xmlns:a16="http://schemas.microsoft.com/office/drawing/2014/main" id="{8976B431-7A6D-405D-86AC-E8B7DBF313C9}"/>
+                <a16:creationId xmlns:a16="http://schemas.microsoft.com/office/drawing/2014/main" id="{B452ACA2-C149-418E-BCE3-75A7CD05EDFD}"/>
               </a:ext>
             </a:extLst>
           </p:cNvPr>
@@ -10884,7 +10884,7 @@
           <p:cNvPr id="20" name="">
             <a:extLst xmlns:a="http://schemas.openxmlformats.org/drawingml/2006/main">
               <a:ext uri="{FF2B5EF4-FFF2-40B4-BE49-F238E27FC236}">
-                <a16:creationId xmlns:a16="http://schemas.microsoft.com/office/drawing/2014/main" id="{2A9885B8-E09B-43A4-84AD-82803CDECBED}"/>
+                <a16:creationId xmlns:a16="http://schemas.microsoft.com/office/drawing/2014/main" id="{20005413-2200-44E5-A9B7-DF244AC6F3A9}"/>
               </a:ext>
             </a:extLst>
           </p:cNvPr>
@@ -10915,7 +10915,7 @@
           <p:cNvPr id="21" name="">
             <a:extLst xmlns:a="http://schemas.openxmlformats.org/drawingml/2006/main">
               <a:ext uri="{FF2B5EF4-FFF2-40B4-BE49-F238E27FC236}">
-                <a16:creationId xmlns:a16="http://schemas.microsoft.com/office/drawing/2014/main" id="{7BF5D615-4212-4E78-9D1A-EB69FD4F664E}"/>
+                <a16:creationId xmlns:a16="http://schemas.microsoft.com/office/drawing/2014/main" id="{64F5C4B3-259E-4104-945F-FF34E2D38101}"/>
               </a:ext>
             </a:extLst>
           </p:cNvPr>
@@ -10977,7 +10977,7 @@
           <p:cNvPr id="22" name="">
             <a:extLst xmlns:a="http://schemas.openxmlformats.org/drawingml/2006/main">
               <a:ext uri="{FF2B5EF4-FFF2-40B4-BE49-F238E27FC236}">
-                <a16:creationId xmlns:a16="http://schemas.microsoft.com/office/drawing/2014/main" id="{E629E994-6C69-4789-8DCA-DB37F0CE8676}"/>
+                <a16:creationId xmlns:a16="http://schemas.microsoft.com/office/drawing/2014/main" id="{4C4ABEEF-5B8B-41AC-ACF1-0350FBE33BF5}"/>
               </a:ext>
             </a:extLst>
           </p:cNvPr>
@@ -11039,7 +11039,7 @@
           <p:cNvPr id="23" name="">
             <a:extLst xmlns:a="http://schemas.openxmlformats.org/drawingml/2006/main">
               <a:ext uri="{FF2B5EF4-FFF2-40B4-BE49-F238E27FC236}">
-                <a16:creationId xmlns:a16="http://schemas.microsoft.com/office/drawing/2014/main" id="{9BE54A5C-C1E4-47F9-A587-A96E19117586}"/>
+                <a16:creationId xmlns:a16="http://schemas.microsoft.com/office/drawing/2014/main" id="{E688E51F-2547-43A0-9911-A87CBF94EEEF}"/>
               </a:ext>
             </a:extLst>
           </p:cNvPr>
@@ -11101,7 +11101,7 @@
     </p:spTree>
     <p:extLst>
       <p:ext uri="{BB962C8B-B14F-4D97-AF65-F5344CB8AC3E}">
-        <p14:creationId xmlns:p14="http://schemas.microsoft.com/office/powerpoint/2010/main" val="462442244"/>
+        <p14:creationId xmlns:p14="http://schemas.microsoft.com/office/powerpoint/2010/main" val="1885294482"/>
       </p:ext>
     </p:extLst>
   </p:cSld>
@@ -11132,7 +11132,7 @@
           <p:cNvPr id="22" name="">
             <a:extLst xmlns:a="http://schemas.openxmlformats.org/drawingml/2006/main">
               <a:ext uri="{FF2B5EF4-FFF2-40B4-BE49-F238E27FC236}">
-                <a16:creationId xmlns:a16="http://schemas.microsoft.com/office/drawing/2014/main" id="{59E541F4-15D4-4B1D-A360-BFD7F3930C7C}"/>
+                <a16:creationId xmlns:a16="http://schemas.microsoft.com/office/drawing/2014/main" id="{FE4CB7BC-ABE2-4549-9EA7-BE55391F57BF}"/>
               </a:ext>
             </a:extLst>
           </p:cNvPr>
@@ -11163,7 +11163,7 @@
           <p:cNvPr id="2" name="">
             <a:extLst xmlns:a="http://schemas.openxmlformats.org/drawingml/2006/main">
               <a:ext uri="{FF2B5EF4-FFF2-40B4-BE49-F238E27FC236}">
-                <a16:creationId xmlns:a16="http://schemas.microsoft.com/office/drawing/2014/main" id="{497A87A7-A26A-4D01-B8EB-2B022AE9620F}"/>
+                <a16:creationId xmlns:a16="http://schemas.microsoft.com/office/drawing/2014/main" id="{38D1AE89-426F-4BB8-A5FE-BC04816397EF}"/>
               </a:ext>
             </a:extLst>
           </p:cNvPr>
@@ -11225,7 +11225,7 @@
           <p:cNvPr id="3" name="">
             <a:extLst xmlns:a="http://schemas.openxmlformats.org/drawingml/2006/main">
               <a:ext uri="{FF2B5EF4-FFF2-40B4-BE49-F238E27FC236}">
-                <a16:creationId xmlns:a16="http://schemas.microsoft.com/office/drawing/2014/main" id="{926F7F79-CBBC-448A-867F-B70E29B3E95C}"/>
+                <a16:creationId xmlns:a16="http://schemas.microsoft.com/office/drawing/2014/main" id="{C4672953-9A9A-4A47-9E14-02FC1EE46722}"/>
               </a:ext>
             </a:extLst>
           </p:cNvPr>
@@ -11259,7 +11259,7 @@
                 <a:spcPct val="108000"/>
               </a:lnSpc>
               <a:buNone/>
-              <a:defRPr sz="3150" b="1">
+              <a:defRPr sz="2550" b="1">
                 <a:solidFill>
                   <a:srgbClr val="071426"/>
                 </a:solidFill>
@@ -11269,7 +11269,7 @@
               </a:defRPr>
             </a:pPr>
             <a:r>
-              <a:rPr sz="3150" b="1">
+              <a:rPr sz="2550" b="1">
                 <a:solidFill>
                   <a:srgbClr val="071426"/>
                 </a:solidFill>
@@ -11287,7 +11287,7 @@
           <p:cNvPr id="4" name="">
             <a:extLst xmlns:a="http://schemas.openxmlformats.org/drawingml/2006/main">
               <a:ext uri="{FF2B5EF4-FFF2-40B4-BE49-F238E27FC236}">
-                <a16:creationId xmlns:a16="http://schemas.microsoft.com/office/drawing/2014/main" id="{2804F11A-37DA-42DF-92B3-2417B8AF1B32}"/>
+                <a16:creationId xmlns:a16="http://schemas.microsoft.com/office/drawing/2014/main" id="{967C1367-4405-4AEC-BCA3-FA2123ACBFBB}"/>
               </a:ext>
             </a:extLst>
           </p:cNvPr>
@@ -11322,7 +11322,7 @@
           <p:nvPr/>
         </p:nvPicPr>
         <p:blipFill>
-          <a:blip xmlns:r="http://schemas.openxmlformats.org/officeDocument/2006/relationships" xmlns:a="http://schemas.openxmlformats.org/drawingml/2006/main" r:embed="R675e26de21444b56"/>
+          <a:blip xmlns:r="http://schemas.openxmlformats.org/officeDocument/2006/relationships" xmlns:a="http://schemas.openxmlformats.org/drawingml/2006/main" r:embed="R6515e48059534c93"/>
           <a:srcRect xmlns:a="http://schemas.openxmlformats.org/drawingml/2006/main" l="0" t="0" r="0" b="0"/>
           <a:stretch xmlns:a="http://schemas.openxmlformats.org/drawingml/2006/main">
             <a:fillRect l="0" t="0" r="0" b="0"/>
@@ -11343,7 +11343,7 @@
           <p:cNvPr id="6" name="">
             <a:extLst xmlns:a="http://schemas.openxmlformats.org/drawingml/2006/main">
               <a:ext uri="{FF2B5EF4-FFF2-40B4-BE49-F238E27FC236}">
-                <a16:creationId xmlns:a16="http://schemas.microsoft.com/office/drawing/2014/main" id="{1DB11527-A322-498D-88B9-576EC5697701}"/>
+                <a16:creationId xmlns:a16="http://schemas.microsoft.com/office/drawing/2014/main" id="{142D60BC-CA02-48DB-AE37-158461CC8B4B}"/>
               </a:ext>
             </a:extLst>
           </p:cNvPr>
@@ -11405,7 +11405,7 @@
           <p:cNvPr id="7" name="">
             <a:extLst xmlns:a="http://schemas.openxmlformats.org/drawingml/2006/main">
               <a:ext uri="{FF2B5EF4-FFF2-40B4-BE49-F238E27FC236}">
-                <a16:creationId xmlns:a16="http://schemas.microsoft.com/office/drawing/2014/main" id="{24CC1F4F-1768-4017-91CC-96CE32EFF15A}"/>
+                <a16:creationId xmlns:a16="http://schemas.microsoft.com/office/drawing/2014/main" id="{AFFAB637-44E6-4A04-A7BC-964D960AE718}"/>
               </a:ext>
             </a:extLst>
           </p:cNvPr>
@@ -11467,19 +11467,19 @@
           <p:cNvPr id="8" name="">
             <a:extLst xmlns:a="http://schemas.openxmlformats.org/drawingml/2006/main">
               <a:ext uri="{FF2B5EF4-FFF2-40B4-BE49-F238E27FC236}">
-                <a16:creationId xmlns:a16="http://schemas.microsoft.com/office/drawing/2014/main" id="{C93C48D0-1C32-4376-AE81-61616B4DBF34}"/>
-              </a:ext>
-            </a:extLst>
-          </p:cNvPr>
-          <p:cNvSpPr>
-            <a:spLocks xmlns:a="http://schemas.openxmlformats.org/drawingml/2006/main" noGrp="1"/>
-          </p:cNvSpPr>
-          <p:nvPr/>
-        </p:nvSpPr>
-        <p:spPr>
-          <a:xfrm xmlns:a="http://schemas.openxmlformats.org/drawingml/2006/main">
-            <a:off x="609600" y="1847850"/>
-            <a:ext cx="10972800" cy="495300"/>
+                <a16:creationId xmlns:a16="http://schemas.microsoft.com/office/drawing/2014/main" id="{820F3E8E-A74B-45B1-A4C7-00C79C283BAB}"/>
+              </a:ext>
+            </a:extLst>
+          </p:cNvPr>
+          <p:cNvSpPr>
+            <a:spLocks xmlns:a="http://schemas.openxmlformats.org/drawingml/2006/main" noGrp="1"/>
+          </p:cNvSpPr>
+          <p:nvPr/>
+        </p:nvSpPr>
+        <p:spPr>
+          <a:xfrm xmlns:a="http://schemas.openxmlformats.org/drawingml/2006/main">
+            <a:off x="609600" y="1752600"/>
+            <a:ext cx="10972800" cy="400050"/>
           </a:xfrm>
           <a:prstGeom xmlns:a="http://schemas.openxmlformats.org/drawingml/2006/main" prst="rect">
             <a:avLst/>
@@ -11501,7 +11501,7 @@
                 <a:spcPct val="108000"/>
               </a:lnSpc>
               <a:buNone/>
-              <a:defRPr sz="1875" b="1">
+              <a:defRPr sz="1575" b="1">
                 <a:solidFill>
                   <a:srgbClr val="1B4F78"/>
                 </a:solidFill>
@@ -11511,7 +11511,7 @@
               </a:defRPr>
             </a:pPr>
             <a:r>
-              <a:rPr sz="1875" b="1">
+              <a:rPr sz="1575" b="1">
                 <a:solidFill>
                   <a:srgbClr val="1B4F78"/>
                 </a:solidFill>
@@ -11529,23 +11529,23 @@
           <p:cNvPr id="9" name="">
             <a:extLst xmlns:a="http://schemas.openxmlformats.org/drawingml/2006/main">
               <a:ext uri="{FF2B5EF4-FFF2-40B4-BE49-F238E27FC236}">
-                <a16:creationId xmlns:a16="http://schemas.microsoft.com/office/drawing/2014/main" id="{7282F953-2E01-4877-A1E7-F49F9202BDFD}"/>
-              </a:ext>
-            </a:extLst>
-          </p:cNvPr>
-          <p:cNvSpPr>
-            <a:spLocks xmlns:a="http://schemas.openxmlformats.org/drawingml/2006/main" noGrp="1"/>
-          </p:cNvSpPr>
-          <p:nvPr/>
-        </p:nvSpPr>
-        <p:spPr>
-          <a:xfrm xmlns:a="http://schemas.openxmlformats.org/drawingml/2006/main">
-            <a:off x="609600" y="1885950"/>
-            <a:ext cx="5400675" cy="1962150"/>
+                <a16:creationId xmlns:a16="http://schemas.microsoft.com/office/drawing/2014/main" id="{5311BC22-69B0-4783-BC67-89BEF83D037F}"/>
+              </a:ext>
+            </a:extLst>
+          </p:cNvPr>
+          <p:cNvSpPr>
+            <a:spLocks xmlns:a="http://schemas.openxmlformats.org/drawingml/2006/main" noGrp="1"/>
+          </p:cNvSpPr>
+          <p:nvPr/>
+        </p:nvSpPr>
+        <p:spPr>
+          <a:xfrm xmlns:a="http://schemas.openxmlformats.org/drawingml/2006/main">
+            <a:off x="609600" y="2266950"/>
+            <a:ext cx="5400675" cy="1571625"/>
           </a:xfrm>
           <a:prstGeom xmlns:a="http://schemas.openxmlformats.org/drawingml/2006/main" prst="roundRect">
             <a:avLst>
-              <a:gd name="adj" fmla="val 8738"/>
+              <a:gd name="adj" fmla="val 10909"/>
             </a:avLst>
           </a:prstGeom>
           <a:solidFill xmlns:a="http://schemas.openxmlformats.org/drawingml/2006/main">
@@ -11564,19 +11564,19 @@
           <p:cNvPr id="10" name="">
             <a:extLst xmlns:a="http://schemas.openxmlformats.org/drawingml/2006/main">
               <a:ext uri="{FF2B5EF4-FFF2-40B4-BE49-F238E27FC236}">
-                <a16:creationId xmlns:a16="http://schemas.microsoft.com/office/drawing/2014/main" id="{93B4FA11-EB22-4137-81B5-ACC4335E8A0E}"/>
-              </a:ext>
-            </a:extLst>
-          </p:cNvPr>
-          <p:cNvSpPr>
-            <a:spLocks xmlns:a="http://schemas.openxmlformats.org/drawingml/2006/main" noGrp="1"/>
-          </p:cNvSpPr>
-          <p:nvPr/>
-        </p:nvSpPr>
-        <p:spPr>
-          <a:xfrm xmlns:a="http://schemas.openxmlformats.org/drawingml/2006/main">
-            <a:off x="609600" y="1885950"/>
-            <a:ext cx="66675" cy="1962150"/>
+                <a16:creationId xmlns:a16="http://schemas.microsoft.com/office/drawing/2014/main" id="{4C28E38B-A03B-4B50-9455-0BF6B1DFDA29}"/>
+              </a:ext>
+            </a:extLst>
+          </p:cNvPr>
+          <p:cNvSpPr>
+            <a:spLocks xmlns:a="http://schemas.openxmlformats.org/drawingml/2006/main" noGrp="1"/>
+          </p:cNvSpPr>
+          <p:nvPr/>
+        </p:nvSpPr>
+        <p:spPr>
+          <a:xfrm xmlns:a="http://schemas.openxmlformats.org/drawingml/2006/main">
+            <a:off x="609600" y="2266950"/>
+            <a:ext cx="66675" cy="1571625"/>
           </a:xfrm>
           <a:prstGeom xmlns:a="http://schemas.openxmlformats.org/drawingml/2006/main" prst="rect">
             <a:avLst/>
@@ -11595,18 +11595,18 @@
           <p:cNvPr id="11" name="">
             <a:extLst xmlns:a="http://schemas.openxmlformats.org/drawingml/2006/main">
               <a:ext uri="{FF2B5EF4-FFF2-40B4-BE49-F238E27FC236}">
-                <a16:creationId xmlns:a16="http://schemas.microsoft.com/office/drawing/2014/main" id="{E6CD9668-21D2-4D70-9021-3E708B27B150}"/>
-              </a:ext>
-            </a:extLst>
-          </p:cNvPr>
-          <p:cNvSpPr>
-            <a:spLocks xmlns:a="http://schemas.openxmlformats.org/drawingml/2006/main" noGrp="1"/>
-          </p:cNvSpPr>
-          <p:nvPr/>
-        </p:nvSpPr>
-        <p:spPr>
-          <a:xfrm xmlns:a="http://schemas.openxmlformats.org/drawingml/2006/main">
-            <a:off x="819150" y="2038350"/>
+                <a16:creationId xmlns:a16="http://schemas.microsoft.com/office/drawing/2014/main" id="{9D5798EB-E6F0-4C93-AE03-11E66A198A51}"/>
+              </a:ext>
+            </a:extLst>
+          </p:cNvPr>
+          <p:cNvSpPr>
+            <a:spLocks xmlns:a="http://schemas.openxmlformats.org/drawingml/2006/main" noGrp="1"/>
+          </p:cNvSpPr>
+          <p:nvPr/>
+        </p:nvSpPr>
+        <p:spPr>
+          <a:xfrm xmlns:a="http://schemas.openxmlformats.org/drawingml/2006/main">
+            <a:off x="819150" y="2419350"/>
             <a:ext cx="5038725" cy="419100"/>
           </a:xfrm>
           <a:prstGeom xmlns:a="http://schemas.openxmlformats.org/drawingml/2006/main" prst="rect">
@@ -11657,23 +11657,23 @@
           <p:cNvPr id="12" name="">
             <a:extLst xmlns:a="http://schemas.openxmlformats.org/drawingml/2006/main">
               <a:ext uri="{FF2B5EF4-FFF2-40B4-BE49-F238E27FC236}">
-                <a16:creationId xmlns:a16="http://schemas.microsoft.com/office/drawing/2014/main" id="{A099F997-632C-4528-AF86-BC191BE0FC12}"/>
-              </a:ext>
-            </a:extLst>
-          </p:cNvPr>
-          <p:cNvSpPr>
-            <a:spLocks xmlns:a="http://schemas.openxmlformats.org/drawingml/2006/main" noGrp="1"/>
-          </p:cNvSpPr>
-          <p:nvPr/>
-        </p:nvSpPr>
-        <p:spPr>
-          <a:xfrm xmlns:a="http://schemas.openxmlformats.org/drawingml/2006/main">
-            <a:off x="6181725" y="1885950"/>
-            <a:ext cx="5400675" cy="1962150"/>
+                <a16:creationId xmlns:a16="http://schemas.microsoft.com/office/drawing/2014/main" id="{F7CE4D3D-B0B1-466A-A981-4A2751401B77}"/>
+              </a:ext>
+            </a:extLst>
+          </p:cNvPr>
+          <p:cNvSpPr>
+            <a:spLocks xmlns:a="http://schemas.openxmlformats.org/drawingml/2006/main" noGrp="1"/>
+          </p:cNvSpPr>
+          <p:nvPr/>
+        </p:nvSpPr>
+        <p:spPr>
+          <a:xfrm xmlns:a="http://schemas.openxmlformats.org/drawingml/2006/main">
+            <a:off x="6181725" y="2266950"/>
+            <a:ext cx="5400675" cy="1571625"/>
           </a:xfrm>
           <a:prstGeom xmlns:a="http://schemas.openxmlformats.org/drawingml/2006/main" prst="roundRect">
             <a:avLst>
-              <a:gd name="adj" fmla="val 8738"/>
+              <a:gd name="adj" fmla="val 10909"/>
             </a:avLst>
           </a:prstGeom>
           <a:solidFill xmlns:a="http://schemas.openxmlformats.org/drawingml/2006/main">
@@ -11692,19 +11692,19 @@
           <p:cNvPr id="13" name="">
             <a:extLst xmlns:a="http://schemas.openxmlformats.org/drawingml/2006/main">
               <a:ext uri="{FF2B5EF4-FFF2-40B4-BE49-F238E27FC236}">
-                <a16:creationId xmlns:a16="http://schemas.microsoft.com/office/drawing/2014/main" id="{D524BA5D-75AE-4F0A-9B19-BB87F39B7B8A}"/>
-              </a:ext>
-            </a:extLst>
-          </p:cNvPr>
-          <p:cNvSpPr>
-            <a:spLocks xmlns:a="http://schemas.openxmlformats.org/drawingml/2006/main" noGrp="1"/>
-          </p:cNvSpPr>
-          <p:nvPr/>
-        </p:nvSpPr>
-        <p:spPr>
-          <a:xfrm xmlns:a="http://schemas.openxmlformats.org/drawingml/2006/main">
-            <a:off x="6181725" y="1885950"/>
-            <a:ext cx="66675" cy="1962150"/>
+                <a16:creationId xmlns:a16="http://schemas.microsoft.com/office/drawing/2014/main" id="{82347691-F04E-4E92-A2EE-61B55C0936C0}"/>
+              </a:ext>
+            </a:extLst>
+          </p:cNvPr>
+          <p:cNvSpPr>
+            <a:spLocks xmlns:a="http://schemas.openxmlformats.org/drawingml/2006/main" noGrp="1"/>
+          </p:cNvSpPr>
+          <p:nvPr/>
+        </p:nvSpPr>
+        <p:spPr>
+          <a:xfrm xmlns:a="http://schemas.openxmlformats.org/drawingml/2006/main">
+            <a:off x="6181725" y="2266950"/>
+            <a:ext cx="66675" cy="1571625"/>
           </a:xfrm>
           <a:prstGeom xmlns:a="http://schemas.openxmlformats.org/drawingml/2006/main" prst="rect">
             <a:avLst/>
@@ -11723,18 +11723,18 @@
           <p:cNvPr id="14" name="">
             <a:extLst xmlns:a="http://schemas.openxmlformats.org/drawingml/2006/main">
               <a:ext uri="{FF2B5EF4-FFF2-40B4-BE49-F238E27FC236}">
-                <a16:creationId xmlns:a16="http://schemas.microsoft.com/office/drawing/2014/main" id="{A712443B-D0E0-46C8-B422-7E08FE07A5DE}"/>
-              </a:ext>
-            </a:extLst>
-          </p:cNvPr>
-          <p:cNvSpPr>
-            <a:spLocks xmlns:a="http://schemas.openxmlformats.org/drawingml/2006/main" noGrp="1"/>
-          </p:cNvSpPr>
-          <p:nvPr/>
-        </p:nvSpPr>
-        <p:spPr>
-          <a:xfrm xmlns:a="http://schemas.openxmlformats.org/drawingml/2006/main">
-            <a:off x="6391275" y="2038350"/>
+                <a16:creationId xmlns:a16="http://schemas.microsoft.com/office/drawing/2014/main" id="{5F1B802F-C645-4D2C-B8E7-5FC7DEBB5C41}"/>
+              </a:ext>
+            </a:extLst>
+          </p:cNvPr>
+          <p:cNvSpPr>
+            <a:spLocks xmlns:a="http://schemas.openxmlformats.org/drawingml/2006/main" noGrp="1"/>
+          </p:cNvSpPr>
+          <p:nvPr/>
+        </p:nvSpPr>
+        <p:spPr>
+          <a:xfrm xmlns:a="http://schemas.openxmlformats.org/drawingml/2006/main">
+            <a:off x="6391275" y="2419350"/>
             <a:ext cx="5038725" cy="419100"/>
           </a:xfrm>
           <a:prstGeom xmlns:a="http://schemas.openxmlformats.org/drawingml/2006/main" prst="rect">
@@ -11785,23 +11785,23 @@
           <p:cNvPr id="15" name="">
             <a:extLst xmlns:a="http://schemas.openxmlformats.org/drawingml/2006/main">
               <a:ext uri="{FF2B5EF4-FFF2-40B4-BE49-F238E27FC236}">
-                <a16:creationId xmlns:a16="http://schemas.microsoft.com/office/drawing/2014/main" id="{56EA88D1-52E8-419A-A3BA-84F71299B948}"/>
-              </a:ext>
-            </a:extLst>
-          </p:cNvPr>
-          <p:cNvSpPr>
-            <a:spLocks xmlns:a="http://schemas.openxmlformats.org/drawingml/2006/main" noGrp="1"/>
-          </p:cNvSpPr>
-          <p:nvPr/>
-        </p:nvSpPr>
-        <p:spPr>
-          <a:xfrm xmlns:a="http://schemas.openxmlformats.org/drawingml/2006/main">
-            <a:off x="609600" y="4019550"/>
-            <a:ext cx="5400675" cy="1962150"/>
+                <a16:creationId xmlns:a16="http://schemas.microsoft.com/office/drawing/2014/main" id="{03305BE6-90DD-419C-8FB1-508F4A137BF6}"/>
+              </a:ext>
+            </a:extLst>
+          </p:cNvPr>
+          <p:cNvSpPr>
+            <a:spLocks xmlns:a="http://schemas.openxmlformats.org/drawingml/2006/main" noGrp="1"/>
+          </p:cNvSpPr>
+          <p:nvPr/>
+        </p:nvSpPr>
+        <p:spPr>
+          <a:xfrm xmlns:a="http://schemas.openxmlformats.org/drawingml/2006/main">
+            <a:off x="609600" y="4010025"/>
+            <a:ext cx="5400675" cy="1571625"/>
           </a:xfrm>
           <a:prstGeom xmlns:a="http://schemas.openxmlformats.org/drawingml/2006/main" prst="roundRect">
             <a:avLst>
-              <a:gd name="adj" fmla="val 8738"/>
+              <a:gd name="adj" fmla="val 10909"/>
             </a:avLst>
           </a:prstGeom>
           <a:solidFill xmlns:a="http://schemas.openxmlformats.org/drawingml/2006/main">
@@ -11820,19 +11820,19 @@
           <p:cNvPr id="16" name="">
             <a:extLst xmlns:a="http://schemas.openxmlformats.org/drawingml/2006/main">
               <a:ext uri="{FF2B5EF4-FFF2-40B4-BE49-F238E27FC236}">
-                <a16:creationId xmlns:a16="http://schemas.microsoft.com/office/drawing/2014/main" id="{2B6E585C-2A66-4235-9C87-4575D4FC1809}"/>
-              </a:ext>
-            </a:extLst>
-          </p:cNvPr>
-          <p:cNvSpPr>
-            <a:spLocks xmlns:a="http://schemas.openxmlformats.org/drawingml/2006/main" noGrp="1"/>
-          </p:cNvSpPr>
-          <p:nvPr/>
-        </p:nvSpPr>
-        <p:spPr>
-          <a:xfrm xmlns:a="http://schemas.openxmlformats.org/drawingml/2006/main">
-            <a:off x="609600" y="4019550"/>
-            <a:ext cx="66675" cy="1962150"/>
+                <a16:creationId xmlns:a16="http://schemas.microsoft.com/office/drawing/2014/main" id="{65D88912-3C1C-48CE-B461-AD3FCABACAF6}"/>
+              </a:ext>
+            </a:extLst>
+          </p:cNvPr>
+          <p:cNvSpPr>
+            <a:spLocks xmlns:a="http://schemas.openxmlformats.org/drawingml/2006/main" noGrp="1"/>
+          </p:cNvSpPr>
+          <p:nvPr/>
+        </p:nvSpPr>
+        <p:spPr>
+          <a:xfrm xmlns:a="http://schemas.openxmlformats.org/drawingml/2006/main">
+            <a:off x="609600" y="4010025"/>
+            <a:ext cx="66675" cy="1571625"/>
           </a:xfrm>
           <a:prstGeom xmlns:a="http://schemas.openxmlformats.org/drawingml/2006/main" prst="rect">
             <a:avLst/>
@@ -11851,18 +11851,18 @@
           <p:cNvPr id="17" name="">
             <a:extLst xmlns:a="http://schemas.openxmlformats.org/drawingml/2006/main">
               <a:ext uri="{FF2B5EF4-FFF2-40B4-BE49-F238E27FC236}">
-                <a16:creationId xmlns:a16="http://schemas.microsoft.com/office/drawing/2014/main" id="{6E19095E-A59C-427B-9DAD-912DE4C25274}"/>
-              </a:ext>
-            </a:extLst>
-          </p:cNvPr>
-          <p:cNvSpPr>
-            <a:spLocks xmlns:a="http://schemas.openxmlformats.org/drawingml/2006/main" noGrp="1"/>
-          </p:cNvSpPr>
-          <p:nvPr/>
-        </p:nvSpPr>
-        <p:spPr>
-          <a:xfrm xmlns:a="http://schemas.openxmlformats.org/drawingml/2006/main">
-            <a:off x="819150" y="4171950"/>
+                <a16:creationId xmlns:a16="http://schemas.microsoft.com/office/drawing/2014/main" id="{A9F16722-0F78-4F9A-916A-F3F47251E31C}"/>
+              </a:ext>
+            </a:extLst>
+          </p:cNvPr>
+          <p:cNvSpPr>
+            <a:spLocks xmlns:a="http://schemas.openxmlformats.org/drawingml/2006/main" noGrp="1"/>
+          </p:cNvSpPr>
+          <p:nvPr/>
+        </p:nvSpPr>
+        <p:spPr>
+          <a:xfrm xmlns:a="http://schemas.openxmlformats.org/drawingml/2006/main">
+            <a:off x="819150" y="4162425"/>
             <a:ext cx="5038725" cy="419100"/>
           </a:xfrm>
           <a:prstGeom xmlns:a="http://schemas.openxmlformats.org/drawingml/2006/main" prst="rect">
@@ -11913,23 +11913,23 @@
           <p:cNvPr id="18" name="">
             <a:extLst xmlns:a="http://schemas.openxmlformats.org/drawingml/2006/main">
               <a:ext uri="{FF2B5EF4-FFF2-40B4-BE49-F238E27FC236}">
-                <a16:creationId xmlns:a16="http://schemas.microsoft.com/office/drawing/2014/main" id="{1BCC597E-01A7-4637-87FB-A65CEF19BB87}"/>
-              </a:ext>
-            </a:extLst>
-          </p:cNvPr>
-          <p:cNvSpPr>
-            <a:spLocks xmlns:a="http://schemas.openxmlformats.org/drawingml/2006/main" noGrp="1"/>
-          </p:cNvSpPr>
-          <p:nvPr/>
-        </p:nvSpPr>
-        <p:spPr>
-          <a:xfrm xmlns:a="http://schemas.openxmlformats.org/drawingml/2006/main">
-            <a:off x="6181725" y="4019550"/>
-            <a:ext cx="5400675" cy="1962150"/>
+                <a16:creationId xmlns:a16="http://schemas.microsoft.com/office/drawing/2014/main" id="{B0F96BF3-B08E-4349-A464-DDE5C91BC48D}"/>
+              </a:ext>
+            </a:extLst>
+          </p:cNvPr>
+          <p:cNvSpPr>
+            <a:spLocks xmlns:a="http://schemas.openxmlformats.org/drawingml/2006/main" noGrp="1"/>
+          </p:cNvSpPr>
+          <p:nvPr/>
+        </p:nvSpPr>
+        <p:spPr>
+          <a:xfrm xmlns:a="http://schemas.openxmlformats.org/drawingml/2006/main">
+            <a:off x="6181725" y="4010025"/>
+            <a:ext cx="5400675" cy="1571625"/>
           </a:xfrm>
           <a:prstGeom xmlns:a="http://schemas.openxmlformats.org/drawingml/2006/main" prst="roundRect">
             <a:avLst>
-              <a:gd name="adj" fmla="val 8738"/>
+              <a:gd name="adj" fmla="val 10909"/>
             </a:avLst>
           </a:prstGeom>
           <a:solidFill xmlns:a="http://schemas.openxmlformats.org/drawingml/2006/main">
@@ -11948,19 +11948,19 @@
           <p:cNvPr id="19" name="">
             <a:extLst xmlns:a="http://schemas.openxmlformats.org/drawingml/2006/main">
               <a:ext uri="{FF2B5EF4-FFF2-40B4-BE49-F238E27FC236}">
-                <a16:creationId xmlns:a16="http://schemas.microsoft.com/office/drawing/2014/main" id="{0DCFE145-5E38-43D5-968D-108FFBEECA0E}"/>
-              </a:ext>
-            </a:extLst>
-          </p:cNvPr>
-          <p:cNvSpPr>
-            <a:spLocks xmlns:a="http://schemas.openxmlformats.org/drawingml/2006/main" noGrp="1"/>
-          </p:cNvSpPr>
-          <p:nvPr/>
-        </p:nvSpPr>
-        <p:spPr>
-          <a:xfrm xmlns:a="http://schemas.openxmlformats.org/drawingml/2006/main">
-            <a:off x="6181725" y="4019550"/>
-            <a:ext cx="66675" cy="1962150"/>
+                <a16:creationId xmlns:a16="http://schemas.microsoft.com/office/drawing/2014/main" id="{08FBD764-5DA1-444A-B9BE-601601887CE2}"/>
+              </a:ext>
+            </a:extLst>
+          </p:cNvPr>
+          <p:cNvSpPr>
+            <a:spLocks xmlns:a="http://schemas.openxmlformats.org/drawingml/2006/main" noGrp="1"/>
+          </p:cNvSpPr>
+          <p:nvPr/>
+        </p:nvSpPr>
+        <p:spPr>
+          <a:xfrm xmlns:a="http://schemas.openxmlformats.org/drawingml/2006/main">
+            <a:off x="6181725" y="4010025"/>
+            <a:ext cx="66675" cy="1571625"/>
           </a:xfrm>
           <a:prstGeom xmlns:a="http://schemas.openxmlformats.org/drawingml/2006/main" prst="rect">
             <a:avLst/>
@@ -11979,18 +11979,18 @@
           <p:cNvPr id="20" name="">
             <a:extLst xmlns:a="http://schemas.openxmlformats.org/drawingml/2006/main">
               <a:ext uri="{FF2B5EF4-FFF2-40B4-BE49-F238E27FC236}">
-                <a16:creationId xmlns:a16="http://schemas.microsoft.com/office/drawing/2014/main" id="{AF689991-5A5B-43D9-BEC1-73AB423880D5}"/>
-              </a:ext>
-            </a:extLst>
-          </p:cNvPr>
-          <p:cNvSpPr>
-            <a:spLocks xmlns:a="http://schemas.openxmlformats.org/drawingml/2006/main" noGrp="1"/>
-          </p:cNvSpPr>
-          <p:nvPr/>
-        </p:nvSpPr>
-        <p:spPr>
-          <a:xfrm xmlns:a="http://schemas.openxmlformats.org/drawingml/2006/main">
-            <a:off x="6391275" y="4171950"/>
+                <a16:creationId xmlns:a16="http://schemas.microsoft.com/office/drawing/2014/main" id="{61FC67C4-9C84-41F1-A53A-0DB429993844}"/>
+              </a:ext>
+            </a:extLst>
+          </p:cNvPr>
+          <p:cNvSpPr>
+            <a:spLocks xmlns:a="http://schemas.openxmlformats.org/drawingml/2006/main" noGrp="1"/>
+          </p:cNvSpPr>
+          <p:nvPr/>
+        </p:nvSpPr>
+        <p:spPr>
+          <a:xfrm xmlns:a="http://schemas.openxmlformats.org/drawingml/2006/main">
+            <a:off x="6391275" y="4162425"/>
             <a:ext cx="5038725" cy="419100"/>
           </a:xfrm>
           <a:prstGeom xmlns:a="http://schemas.openxmlformats.org/drawingml/2006/main" prst="rect">
@@ -12041,19 +12041,19 @@
           <p:cNvPr id="21" name="">
             <a:extLst xmlns:a="http://schemas.openxmlformats.org/drawingml/2006/main">
               <a:ext uri="{FF2B5EF4-FFF2-40B4-BE49-F238E27FC236}">
-                <a16:creationId xmlns:a16="http://schemas.microsoft.com/office/drawing/2014/main" id="{6CE4F80A-ABFA-4CF6-BA8D-A8B9E19CC7E0}"/>
-              </a:ext>
-            </a:extLst>
-          </p:cNvPr>
-          <p:cNvSpPr>
-            <a:spLocks xmlns:a="http://schemas.openxmlformats.org/drawingml/2006/main" noGrp="1"/>
-          </p:cNvSpPr>
-          <p:nvPr/>
-        </p:nvSpPr>
-        <p:spPr>
-          <a:xfrm xmlns:a="http://schemas.openxmlformats.org/drawingml/2006/main">
-            <a:off x="609600" y="5943600"/>
-            <a:ext cx="10972800" cy="361950"/>
+                <a16:creationId xmlns:a16="http://schemas.microsoft.com/office/drawing/2014/main" id="{4C420523-2ABB-4987-BD63-E4ADC77ADC8C}"/>
+              </a:ext>
+            </a:extLst>
+          </p:cNvPr>
+          <p:cNvSpPr>
+            <a:spLocks xmlns:a="http://schemas.openxmlformats.org/drawingml/2006/main" noGrp="1"/>
+          </p:cNvSpPr>
+          <p:nvPr/>
+        </p:nvSpPr>
+        <p:spPr>
+          <a:xfrm xmlns:a="http://schemas.openxmlformats.org/drawingml/2006/main">
+            <a:off x="609600" y="5753100"/>
+            <a:ext cx="10972800" cy="457200"/>
           </a:xfrm>
           <a:prstGeom xmlns:a="http://schemas.openxmlformats.org/drawingml/2006/main" prst="rect">
             <a:avLst/>
@@ -12103,7 +12103,7 @@
     </p:spTree>
     <p:extLst>
       <p:ext uri="{BB962C8B-B14F-4D97-AF65-F5344CB8AC3E}">
-        <p14:creationId xmlns:p14="http://schemas.microsoft.com/office/powerpoint/2010/main" val="396191155"/>
+        <p14:creationId xmlns:p14="http://schemas.microsoft.com/office/powerpoint/2010/main" val="339581847"/>
       </p:ext>
     </p:extLst>
   </p:cSld>
@@ -12134,7 +12134,7 @@
           <p:cNvPr id="22" name="">
             <a:extLst xmlns:a="http://schemas.openxmlformats.org/drawingml/2006/main">
               <a:ext uri="{FF2B5EF4-FFF2-40B4-BE49-F238E27FC236}">
-                <a16:creationId xmlns:a16="http://schemas.microsoft.com/office/drawing/2014/main" id="{6FDD1C48-2CCD-4783-A44F-F16035433021}"/>
+                <a16:creationId xmlns:a16="http://schemas.microsoft.com/office/drawing/2014/main" id="{0AE49756-514A-49B3-9346-BF909D349441}"/>
               </a:ext>
             </a:extLst>
           </p:cNvPr>
@@ -12165,7 +12165,7 @@
           <p:cNvPr id="2" name="">
             <a:extLst xmlns:a="http://schemas.openxmlformats.org/drawingml/2006/main">
               <a:ext uri="{FF2B5EF4-FFF2-40B4-BE49-F238E27FC236}">
-                <a16:creationId xmlns:a16="http://schemas.microsoft.com/office/drawing/2014/main" id="{718AD4FC-21C3-40E6-9373-00855718B1FE}"/>
+                <a16:creationId xmlns:a16="http://schemas.microsoft.com/office/drawing/2014/main" id="{F55EABB7-01CB-4544-BC22-D726F9F58C2F}"/>
               </a:ext>
             </a:extLst>
           </p:cNvPr>
@@ -12227,7 +12227,7 @@
           <p:cNvPr id="3" name="">
             <a:extLst xmlns:a="http://schemas.openxmlformats.org/drawingml/2006/main">
               <a:ext uri="{FF2B5EF4-FFF2-40B4-BE49-F238E27FC236}">
-                <a16:creationId xmlns:a16="http://schemas.microsoft.com/office/drawing/2014/main" id="{A774BCD2-4FC1-4E46-90AA-C3F9CEB3AA0E}"/>
+                <a16:creationId xmlns:a16="http://schemas.microsoft.com/office/drawing/2014/main" id="{A6041C98-C86E-4F15-95DD-5EFE661A3161}"/>
               </a:ext>
             </a:extLst>
           </p:cNvPr>
@@ -12289,7 +12289,7 @@
           <p:cNvPr id="4" name="">
             <a:extLst xmlns:a="http://schemas.openxmlformats.org/drawingml/2006/main">
               <a:ext uri="{FF2B5EF4-FFF2-40B4-BE49-F238E27FC236}">
-                <a16:creationId xmlns:a16="http://schemas.microsoft.com/office/drawing/2014/main" id="{FC85754F-C20C-4CE6-B259-2CFDD87804D4}"/>
+                <a16:creationId xmlns:a16="http://schemas.microsoft.com/office/drawing/2014/main" id="{7059E889-CB03-426D-80B7-B91586BD30E6}"/>
               </a:ext>
             </a:extLst>
           </p:cNvPr>
@@ -12324,7 +12324,7 @@
           <p:nvPr/>
         </p:nvPicPr>
         <p:blipFill>
-          <a:blip xmlns:r="http://schemas.openxmlformats.org/officeDocument/2006/relationships" xmlns:a="http://schemas.openxmlformats.org/drawingml/2006/main" r:embed="Rf41d5c4573db41ca"/>
+          <a:blip xmlns:r="http://schemas.openxmlformats.org/officeDocument/2006/relationships" xmlns:a="http://schemas.openxmlformats.org/drawingml/2006/main" r:embed="Rbabc3beea2814789"/>
           <a:srcRect xmlns:a="http://schemas.openxmlformats.org/drawingml/2006/main" l="0" t="0" r="0" b="0"/>
           <a:stretch xmlns:a="http://schemas.openxmlformats.org/drawingml/2006/main">
             <a:fillRect l="0" t="0" r="0" b="0"/>
@@ -12345,7 +12345,7 @@
           <p:cNvPr id="6" name="">
             <a:extLst xmlns:a="http://schemas.openxmlformats.org/drawingml/2006/main">
               <a:ext uri="{FF2B5EF4-FFF2-40B4-BE49-F238E27FC236}">
-                <a16:creationId xmlns:a16="http://schemas.microsoft.com/office/drawing/2014/main" id="{0C61193A-10F0-4528-B455-BC12A8381914}"/>
+                <a16:creationId xmlns:a16="http://schemas.microsoft.com/office/drawing/2014/main" id="{E83A4CEA-BF91-4E6F-ABA3-BCE2AA475CEB}"/>
               </a:ext>
             </a:extLst>
           </p:cNvPr>
@@ -12407,7 +12407,7 @@
           <p:cNvPr id="7" name="">
             <a:extLst xmlns:a="http://schemas.openxmlformats.org/drawingml/2006/main">
               <a:ext uri="{FF2B5EF4-FFF2-40B4-BE49-F238E27FC236}">
-                <a16:creationId xmlns:a16="http://schemas.microsoft.com/office/drawing/2014/main" id="{8B6E3134-5469-4AD8-AB1E-DF407E434424}"/>
+                <a16:creationId xmlns:a16="http://schemas.microsoft.com/office/drawing/2014/main" id="{79F5FBEA-7D3C-406E-BCED-D1A218055372}"/>
               </a:ext>
             </a:extLst>
           </p:cNvPr>
@@ -12469,7 +12469,7 @@
           <p:cNvPr id="8" name="">
             <a:extLst xmlns:a="http://schemas.openxmlformats.org/drawingml/2006/main">
               <a:ext uri="{FF2B5EF4-FFF2-40B4-BE49-F238E27FC236}">
-                <a16:creationId xmlns:a16="http://schemas.microsoft.com/office/drawing/2014/main" id="{DF033419-F465-41A1-8983-5B2DC1D29AA3}"/>
+                <a16:creationId xmlns:a16="http://schemas.microsoft.com/office/drawing/2014/main" id="{8087C995-58BF-4799-B0CD-3DC3E86833AA}"/>
               </a:ext>
             </a:extLst>
           </p:cNvPr>
@@ -12531,7 +12531,7 @@
           <p:cNvPr id="9" name="">
             <a:extLst xmlns:a="http://schemas.openxmlformats.org/drawingml/2006/main">
               <a:ext uri="{FF2B5EF4-FFF2-40B4-BE49-F238E27FC236}">
-                <a16:creationId xmlns:a16="http://schemas.microsoft.com/office/drawing/2014/main" id="{A0A30822-8F24-473F-96DA-D4F2C22F3D92}"/>
+                <a16:creationId xmlns:a16="http://schemas.microsoft.com/office/drawing/2014/main" id="{15D85268-C8DE-4C40-84AB-CD2A1A0F5747}"/>
               </a:ext>
             </a:extLst>
           </p:cNvPr>
@@ -12566,7 +12566,7 @@
           <p:cNvPr id="10" name="">
             <a:extLst xmlns:a="http://schemas.openxmlformats.org/drawingml/2006/main">
               <a:ext uri="{FF2B5EF4-FFF2-40B4-BE49-F238E27FC236}">
-                <a16:creationId xmlns:a16="http://schemas.microsoft.com/office/drawing/2014/main" id="{33611D8D-E95D-4FA6-A509-512B4B7E1426}"/>
+                <a16:creationId xmlns:a16="http://schemas.microsoft.com/office/drawing/2014/main" id="{E16E1EB6-765E-4AF9-BD5C-981FF5B811D0}"/>
               </a:ext>
             </a:extLst>
           </p:cNvPr>
@@ -12597,19 +12597,19 @@
           <p:cNvPr id="11" name="">
             <a:extLst xmlns:a="http://schemas.openxmlformats.org/drawingml/2006/main">
               <a:ext uri="{FF2B5EF4-FFF2-40B4-BE49-F238E27FC236}">
-                <a16:creationId xmlns:a16="http://schemas.microsoft.com/office/drawing/2014/main" id="{60908C6D-6B08-43F8-8C8E-7F33D6F830E7}"/>
-              </a:ext>
-            </a:extLst>
-          </p:cNvPr>
-          <p:cNvSpPr>
-            <a:spLocks xmlns:a="http://schemas.openxmlformats.org/drawingml/2006/main" noGrp="1"/>
-          </p:cNvSpPr>
-          <p:nvPr/>
-        </p:nvSpPr>
-        <p:spPr>
-          <a:xfrm xmlns:a="http://schemas.openxmlformats.org/drawingml/2006/main">
-            <a:off x="819150" y="2476500"/>
-            <a:ext cx="2252663" cy="419100"/>
+                <a16:creationId xmlns:a16="http://schemas.microsoft.com/office/drawing/2014/main" id="{EE03B99F-A4B8-48D3-878D-30CE73ADFC43}"/>
+              </a:ext>
+            </a:extLst>
+          </p:cNvPr>
+          <p:cNvSpPr>
+            <a:spLocks xmlns:a="http://schemas.openxmlformats.org/drawingml/2006/main" noGrp="1"/>
+          </p:cNvSpPr>
+          <p:nvPr/>
+        </p:nvSpPr>
+        <p:spPr>
+          <a:xfrm xmlns:a="http://schemas.openxmlformats.org/drawingml/2006/main">
+            <a:off x="819150" y="2590800"/>
+            <a:ext cx="2252663" cy="819150"/>
           </a:xfrm>
           <a:prstGeom xmlns:a="http://schemas.openxmlformats.org/drawingml/2006/main" prst="rect">
             <a:avLst/>
@@ -12622,7 +12622,7 @@
         </p:spPr>
         <p:txBody>
           <a:bodyPr xmlns:a="http://schemas.openxmlformats.org/drawingml/2006/main" lIns="76200" tIns="57150" rIns="76200" bIns="57150" anchor="ctr">
-            <a:normAutofit fontScale="55425"/>
+            <a:normAutofit fontScale="90081"/>
           </a:bodyPr>
           <a:lstStyle xmlns:a="http://schemas.openxmlformats.org/drawingml/2006/main"/>
           <a:p xmlns:a="http://schemas.openxmlformats.org/drawingml/2006/main">
@@ -12631,7 +12631,7 @@
                 <a:spcPct val="108000"/>
               </a:lnSpc>
               <a:buNone/>
-              <a:defRPr sz="1650" b="1">
+              <a:defRPr sz="1350" b="1">
                 <a:solidFill>
                   <a:srgbClr val="071426"/>
                 </a:solidFill>
@@ -12641,7 +12641,7 @@
               </a:defRPr>
             </a:pPr>
             <a:r>
-              <a:rPr sz="1650" b="1">
+              <a:rPr sz="1350" b="1">
                 <a:solidFill>
                   <a:srgbClr val="071426"/>
                 </a:solidFill>
@@ -12659,7 +12659,7 @@
           <p:cNvPr id="12" name="">
             <a:extLst xmlns:a="http://schemas.openxmlformats.org/drawingml/2006/main">
               <a:ext uri="{FF2B5EF4-FFF2-40B4-BE49-F238E27FC236}">
-                <a16:creationId xmlns:a16="http://schemas.microsoft.com/office/drawing/2014/main" id="{A487F651-EA89-46A2-98FA-E2624922F986}"/>
+                <a16:creationId xmlns:a16="http://schemas.microsoft.com/office/drawing/2014/main" id="{B9CC9332-3C77-44E4-B36A-2E789E22326E}"/>
               </a:ext>
             </a:extLst>
           </p:cNvPr>
@@ -12694,7 +12694,7 @@
           <p:cNvPr id="13" name="">
             <a:extLst xmlns:a="http://schemas.openxmlformats.org/drawingml/2006/main">
               <a:ext uri="{FF2B5EF4-FFF2-40B4-BE49-F238E27FC236}">
-                <a16:creationId xmlns:a16="http://schemas.microsoft.com/office/drawing/2014/main" id="{0BCCECA8-F79E-4950-8333-4012B9E99AE2}"/>
+                <a16:creationId xmlns:a16="http://schemas.microsoft.com/office/drawing/2014/main" id="{8756F79B-23C2-4DC3-8136-6D6581D4D719}"/>
               </a:ext>
             </a:extLst>
           </p:cNvPr>
@@ -12725,19 +12725,19 @@
           <p:cNvPr id="14" name="">
             <a:extLst xmlns:a="http://schemas.openxmlformats.org/drawingml/2006/main">
               <a:ext uri="{FF2B5EF4-FFF2-40B4-BE49-F238E27FC236}">
-                <a16:creationId xmlns:a16="http://schemas.microsoft.com/office/drawing/2014/main" id="{1BA0818D-6B35-4885-A38B-B4234928F7E1}"/>
-              </a:ext>
-            </a:extLst>
-          </p:cNvPr>
-          <p:cNvSpPr>
-            <a:spLocks xmlns:a="http://schemas.openxmlformats.org/drawingml/2006/main" noGrp="1"/>
-          </p:cNvSpPr>
-          <p:nvPr/>
-        </p:nvSpPr>
-        <p:spPr>
-          <a:xfrm xmlns:a="http://schemas.openxmlformats.org/drawingml/2006/main">
-            <a:off x="3605213" y="2476500"/>
-            <a:ext cx="2252663" cy="419100"/>
+                <a16:creationId xmlns:a16="http://schemas.microsoft.com/office/drawing/2014/main" id="{E4580FF0-ACE1-457F-9965-215DF5A45FCA}"/>
+              </a:ext>
+            </a:extLst>
+          </p:cNvPr>
+          <p:cNvSpPr>
+            <a:spLocks xmlns:a="http://schemas.openxmlformats.org/drawingml/2006/main" noGrp="1"/>
+          </p:cNvSpPr>
+          <p:nvPr/>
+        </p:nvSpPr>
+        <p:spPr>
+          <a:xfrm xmlns:a="http://schemas.openxmlformats.org/drawingml/2006/main">
+            <a:off x="3605213" y="2590800"/>
+            <a:ext cx="2252663" cy="819150"/>
           </a:xfrm>
           <a:prstGeom xmlns:a="http://schemas.openxmlformats.org/drawingml/2006/main" prst="rect">
             <a:avLst/>
@@ -12750,7 +12750,7 @@
         </p:spPr>
         <p:txBody>
           <a:bodyPr xmlns:a="http://schemas.openxmlformats.org/drawingml/2006/main" lIns="76200" tIns="57150" rIns="76200" bIns="57150" anchor="ctr">
-            <a:normAutofit fontScale="56117"/>
+            <a:normAutofit fontScale="100000"/>
           </a:bodyPr>
           <a:lstStyle xmlns:a="http://schemas.openxmlformats.org/drawingml/2006/main"/>
           <a:p xmlns:a="http://schemas.openxmlformats.org/drawingml/2006/main">
@@ -12759,7 +12759,7 @@
                 <a:spcPct val="108000"/>
               </a:lnSpc>
               <a:buNone/>
-              <a:defRPr sz="1650" b="1">
+              <a:defRPr sz="1350" b="1">
                 <a:solidFill>
                   <a:srgbClr val="071426"/>
                 </a:solidFill>
@@ -12769,7 +12769,7 @@
               </a:defRPr>
             </a:pPr>
             <a:r>
-              <a:rPr sz="1650" b="1">
+              <a:rPr sz="1350" b="1">
                 <a:solidFill>
                   <a:srgbClr val="071426"/>
                 </a:solidFill>
@@ -12787,7 +12787,7 @@
           <p:cNvPr id="15" name="">
             <a:extLst xmlns:a="http://schemas.openxmlformats.org/drawingml/2006/main">
               <a:ext uri="{FF2B5EF4-FFF2-40B4-BE49-F238E27FC236}">
-                <a16:creationId xmlns:a16="http://schemas.microsoft.com/office/drawing/2014/main" id="{407A3BC4-1033-41A6-A3D6-D1E484295796}"/>
+                <a16:creationId xmlns:a16="http://schemas.microsoft.com/office/drawing/2014/main" id="{CD446063-F015-47B7-9E9D-E0F52F53B672}"/>
               </a:ext>
             </a:extLst>
           </p:cNvPr>
@@ -12822,7 +12822,7 @@
           <p:cNvPr id="16" name="">
             <a:extLst xmlns:a="http://schemas.openxmlformats.org/drawingml/2006/main">
               <a:ext uri="{FF2B5EF4-FFF2-40B4-BE49-F238E27FC236}">
-                <a16:creationId xmlns:a16="http://schemas.microsoft.com/office/drawing/2014/main" id="{BF60BF4A-EF3F-48F8-AFBC-C3D7E76671FA}"/>
+                <a16:creationId xmlns:a16="http://schemas.microsoft.com/office/drawing/2014/main" id="{C6976732-BB64-48AB-9DEE-691AD3DF2292}"/>
               </a:ext>
             </a:extLst>
           </p:cNvPr>
@@ -12853,19 +12853,19 @@
           <p:cNvPr id="17" name="">
             <a:extLst xmlns:a="http://schemas.openxmlformats.org/drawingml/2006/main">
               <a:ext uri="{FF2B5EF4-FFF2-40B4-BE49-F238E27FC236}">
-                <a16:creationId xmlns:a16="http://schemas.microsoft.com/office/drawing/2014/main" id="{59C5BDBF-0FD0-4752-9496-ADCA4D7B4BEA}"/>
-              </a:ext>
-            </a:extLst>
-          </p:cNvPr>
-          <p:cNvSpPr>
-            <a:spLocks xmlns:a="http://schemas.openxmlformats.org/drawingml/2006/main" noGrp="1"/>
-          </p:cNvSpPr>
-          <p:nvPr/>
-        </p:nvSpPr>
-        <p:spPr>
-          <a:xfrm xmlns:a="http://schemas.openxmlformats.org/drawingml/2006/main">
-            <a:off x="6391275" y="2476500"/>
-            <a:ext cx="2252663" cy="419100"/>
+                <a16:creationId xmlns:a16="http://schemas.microsoft.com/office/drawing/2014/main" id="{6D8E6D66-275C-4FB0-9301-07B85688D82D}"/>
+              </a:ext>
+            </a:extLst>
+          </p:cNvPr>
+          <p:cNvSpPr>
+            <a:spLocks xmlns:a="http://schemas.openxmlformats.org/drawingml/2006/main" noGrp="1"/>
+          </p:cNvSpPr>
+          <p:nvPr/>
+        </p:nvSpPr>
+        <p:spPr>
+          <a:xfrm xmlns:a="http://schemas.openxmlformats.org/drawingml/2006/main">
+            <a:off x="6391275" y="2590800"/>
+            <a:ext cx="2252663" cy="819150"/>
           </a:xfrm>
           <a:prstGeom xmlns:a="http://schemas.openxmlformats.org/drawingml/2006/main" prst="rect">
             <a:avLst/>
@@ -12887,7 +12887,7 @@
                 <a:spcPct val="108000"/>
               </a:lnSpc>
               <a:buNone/>
-              <a:defRPr sz="1650" b="1">
+              <a:defRPr sz="1350" b="1">
                 <a:solidFill>
                   <a:srgbClr val="071426"/>
                 </a:solidFill>
@@ -12897,7 +12897,7 @@
               </a:defRPr>
             </a:pPr>
             <a:r>
-              <a:rPr sz="1650" b="1">
+              <a:rPr sz="1350" b="1">
                 <a:solidFill>
                   <a:srgbClr val="071426"/>
                 </a:solidFill>
@@ -12915,7 +12915,7 @@
           <p:cNvPr id="18" name="">
             <a:extLst xmlns:a="http://schemas.openxmlformats.org/drawingml/2006/main">
               <a:ext uri="{FF2B5EF4-FFF2-40B4-BE49-F238E27FC236}">
-                <a16:creationId xmlns:a16="http://schemas.microsoft.com/office/drawing/2014/main" id="{69FFFAFC-1421-4765-B1E5-91CECC49E124}"/>
+                <a16:creationId xmlns:a16="http://schemas.microsoft.com/office/drawing/2014/main" id="{0A159282-0275-4659-B1E2-652ED01299F5}"/>
               </a:ext>
             </a:extLst>
           </p:cNvPr>
@@ -12950,7 +12950,7 @@
           <p:cNvPr id="19" name="">
             <a:extLst xmlns:a="http://schemas.openxmlformats.org/drawingml/2006/main">
               <a:ext uri="{FF2B5EF4-FFF2-40B4-BE49-F238E27FC236}">
-                <a16:creationId xmlns:a16="http://schemas.microsoft.com/office/drawing/2014/main" id="{0131C1E3-4741-40A8-B8A3-D493F3CA18E9}"/>
+                <a16:creationId xmlns:a16="http://schemas.microsoft.com/office/drawing/2014/main" id="{2E66CAAE-FB23-4F0A-BF4D-6725F11E03FE}"/>
               </a:ext>
             </a:extLst>
           </p:cNvPr>
@@ -12981,19 +12981,19 @@
           <p:cNvPr id="20" name="">
             <a:extLst xmlns:a="http://schemas.openxmlformats.org/drawingml/2006/main">
               <a:ext uri="{FF2B5EF4-FFF2-40B4-BE49-F238E27FC236}">
-                <a16:creationId xmlns:a16="http://schemas.microsoft.com/office/drawing/2014/main" id="{2F5A9B37-83E6-44A1-9CEE-663EF34F15FE}"/>
-              </a:ext>
-            </a:extLst>
-          </p:cNvPr>
-          <p:cNvSpPr>
-            <a:spLocks xmlns:a="http://schemas.openxmlformats.org/drawingml/2006/main" noGrp="1"/>
-          </p:cNvSpPr>
-          <p:nvPr/>
-        </p:nvSpPr>
-        <p:spPr>
-          <a:xfrm xmlns:a="http://schemas.openxmlformats.org/drawingml/2006/main">
-            <a:off x="9177338" y="2476500"/>
-            <a:ext cx="2252663" cy="419100"/>
+                <a16:creationId xmlns:a16="http://schemas.microsoft.com/office/drawing/2014/main" id="{07BCDCC7-B780-4E03-A085-C132528D9D4A}"/>
+              </a:ext>
+            </a:extLst>
+          </p:cNvPr>
+          <p:cNvSpPr>
+            <a:spLocks xmlns:a="http://schemas.openxmlformats.org/drawingml/2006/main" noGrp="1"/>
+          </p:cNvSpPr>
+          <p:nvPr/>
+        </p:nvSpPr>
+        <p:spPr>
+          <a:xfrm xmlns:a="http://schemas.openxmlformats.org/drawingml/2006/main">
+            <a:off x="9177338" y="2590800"/>
+            <a:ext cx="2252663" cy="819150"/>
           </a:xfrm>
           <a:prstGeom xmlns:a="http://schemas.openxmlformats.org/drawingml/2006/main" prst="rect">
             <a:avLst/>
@@ -13015,7 +13015,7 @@
                 <a:spcPct val="108000"/>
               </a:lnSpc>
               <a:buNone/>
-              <a:defRPr sz="1650" b="1">
+              <a:defRPr sz="1350" b="1">
                 <a:solidFill>
                   <a:srgbClr val="071426"/>
                 </a:solidFill>
@@ -13025,7 +13025,7 @@
               </a:defRPr>
             </a:pPr>
             <a:r>
-              <a:rPr sz="1650" b="1">
+              <a:rPr sz="1350" b="1">
                 <a:solidFill>
                   <a:srgbClr val="071426"/>
                 </a:solidFill>
@@ -13043,7 +13043,7 @@
           <p:cNvPr id="21" name="">
             <a:extLst xmlns:a="http://schemas.openxmlformats.org/drawingml/2006/main">
               <a:ext uri="{FF2B5EF4-FFF2-40B4-BE49-F238E27FC236}">
-                <a16:creationId xmlns:a16="http://schemas.microsoft.com/office/drawing/2014/main" id="{83629626-AE38-4C3E-831F-AD5D07F01D59}"/>
+                <a16:creationId xmlns:a16="http://schemas.microsoft.com/office/drawing/2014/main" id="{7994D210-5F7E-4187-A54A-0E20205A29B6}"/>
               </a:ext>
             </a:extLst>
           </p:cNvPr>
@@ -13105,7 +13105,7 @@
     </p:spTree>
     <p:extLst>
       <p:ext uri="{BB962C8B-B14F-4D97-AF65-F5344CB8AC3E}">
-        <p14:creationId xmlns:p14="http://schemas.microsoft.com/office/powerpoint/2010/main" val="1666499873"/>
+        <p14:creationId xmlns:p14="http://schemas.microsoft.com/office/powerpoint/2010/main" val="1582153878"/>
       </p:ext>
     </p:extLst>
   </p:cSld>
@@ -13136,7 +13136,7 @@
           <p:cNvPr id="22" name="">
             <a:extLst xmlns:a="http://schemas.openxmlformats.org/drawingml/2006/main">
               <a:ext uri="{FF2B5EF4-FFF2-40B4-BE49-F238E27FC236}">
-                <a16:creationId xmlns:a16="http://schemas.microsoft.com/office/drawing/2014/main" id="{F737C1A7-F8A0-4C71-8D65-62CB930F50C6}"/>
+                <a16:creationId xmlns:a16="http://schemas.microsoft.com/office/drawing/2014/main" id="{4FBA61A6-6113-4C7D-99B2-37A4B362665A}"/>
               </a:ext>
             </a:extLst>
           </p:cNvPr>
@@ -13167,7 +13167,7 @@
           <p:cNvPr id="2" name="">
             <a:extLst xmlns:a="http://schemas.openxmlformats.org/drawingml/2006/main">
               <a:ext uri="{FF2B5EF4-FFF2-40B4-BE49-F238E27FC236}">
-                <a16:creationId xmlns:a16="http://schemas.microsoft.com/office/drawing/2014/main" id="{753EACFD-3F8B-4B6E-BA68-68CC43C48A1F}"/>
+                <a16:creationId xmlns:a16="http://schemas.microsoft.com/office/drawing/2014/main" id="{75C4F73E-864D-40C4-983A-5188E3F6DF47}"/>
               </a:ext>
             </a:extLst>
           </p:cNvPr>
@@ -13219,7 +13219,7 @@
                 <a:ea typeface="Aptos"/>
                 <a:cs typeface="Aptos"/>
               </a:rPr>
-              <a:t>ΠΡΩΤΟΚΟΛΛΟ</a:t>
+              <a:t>ΝΟΜΙΣΜΑΤΙΚΟ ΣΥΝΤΑΓΜΑ</a:t>
             </a:r>
           </a:p>
         </p:txBody>
@@ -13229,7 +13229,7 @@
           <p:cNvPr id="3" name="">
             <a:extLst xmlns:a="http://schemas.openxmlformats.org/drawingml/2006/main">
               <a:ext uri="{FF2B5EF4-FFF2-40B4-BE49-F238E27FC236}">
-                <a16:creationId xmlns:a16="http://schemas.microsoft.com/office/drawing/2014/main" id="{86BF8426-0A24-4651-98FE-77B9C8D3304C}"/>
+                <a16:creationId xmlns:a16="http://schemas.microsoft.com/office/drawing/2014/main" id="{8BCA1C35-95EA-4C17-8524-FA3DE9BF97E7}"/>
               </a:ext>
             </a:extLst>
           </p:cNvPr>
@@ -13291,7 +13291,7 @@
           <p:cNvPr id="4" name="">
             <a:extLst xmlns:a="http://schemas.openxmlformats.org/drawingml/2006/main">
               <a:ext uri="{FF2B5EF4-FFF2-40B4-BE49-F238E27FC236}">
-                <a16:creationId xmlns:a16="http://schemas.microsoft.com/office/drawing/2014/main" id="{1C61CF5E-994C-439C-AFFB-709F9164CC23}"/>
+                <a16:creationId xmlns:a16="http://schemas.microsoft.com/office/drawing/2014/main" id="{5ACD3570-DAC3-4961-9275-5385993D3531}"/>
               </a:ext>
             </a:extLst>
           </p:cNvPr>
@@ -13326,7 +13326,7 @@
           <p:nvPr/>
         </p:nvPicPr>
         <p:blipFill>
-          <a:blip xmlns:r="http://schemas.openxmlformats.org/officeDocument/2006/relationships" xmlns:a="http://schemas.openxmlformats.org/drawingml/2006/main" r:embed="Rd4e6cb32e183439d"/>
+          <a:blip xmlns:r="http://schemas.openxmlformats.org/officeDocument/2006/relationships" xmlns:a="http://schemas.openxmlformats.org/drawingml/2006/main" r:embed="R426639df789b40a0"/>
           <a:srcRect xmlns:a="http://schemas.openxmlformats.org/drawingml/2006/main" l="0" t="0" r="0" b="0"/>
           <a:stretch xmlns:a="http://schemas.openxmlformats.org/drawingml/2006/main">
             <a:fillRect l="0" t="0" r="0" b="0"/>
@@ -13347,7 +13347,7 @@
           <p:cNvPr id="6" name="">
             <a:extLst xmlns:a="http://schemas.openxmlformats.org/drawingml/2006/main">
               <a:ext uri="{FF2B5EF4-FFF2-40B4-BE49-F238E27FC236}">
-                <a16:creationId xmlns:a16="http://schemas.microsoft.com/office/drawing/2014/main" id="{1BA68C5D-FFC7-4B54-89E7-9D1420C612F6}"/>
+                <a16:creationId xmlns:a16="http://schemas.microsoft.com/office/drawing/2014/main" id="{CB143BF5-D084-4D2E-ABC2-4A9B5AE08AFB}"/>
               </a:ext>
             </a:extLst>
           </p:cNvPr>
@@ -13409,7 +13409,7 @@
           <p:cNvPr id="7" name="">
             <a:extLst xmlns:a="http://schemas.openxmlformats.org/drawingml/2006/main">
               <a:ext uri="{FF2B5EF4-FFF2-40B4-BE49-F238E27FC236}">
-                <a16:creationId xmlns:a16="http://schemas.microsoft.com/office/drawing/2014/main" id="{08F0B850-170A-435E-8B1C-8F573960C106}"/>
+                <a16:creationId xmlns:a16="http://schemas.microsoft.com/office/drawing/2014/main" id="{5413B973-01CA-4999-95EA-4D96BAEEA622}"/>
               </a:ext>
             </a:extLst>
           </p:cNvPr>
@@ -13471,7 +13471,7 @@
           <p:cNvPr id="8" name="">
             <a:extLst xmlns:a="http://schemas.openxmlformats.org/drawingml/2006/main">
               <a:ext uri="{FF2B5EF4-FFF2-40B4-BE49-F238E27FC236}">
-                <a16:creationId xmlns:a16="http://schemas.microsoft.com/office/drawing/2014/main" id="{23B6EC50-57F6-4B3B-BF0B-CF574984AADF}"/>
+                <a16:creationId xmlns:a16="http://schemas.microsoft.com/office/drawing/2014/main" id="{74428B6D-BA5E-41A2-9038-8A158E210AC0}"/>
               </a:ext>
             </a:extLst>
           </p:cNvPr>
@@ -13535,7 +13535,7 @@
           <p:cNvPr id="9" name="">
             <a:extLst xmlns:a="http://schemas.openxmlformats.org/drawingml/2006/main">
               <a:ext uri="{FF2B5EF4-FFF2-40B4-BE49-F238E27FC236}">
-                <a16:creationId xmlns:a16="http://schemas.microsoft.com/office/drawing/2014/main" id="{712ADF6D-D823-4065-952D-AC7B1783B9A0}"/>
+                <a16:creationId xmlns:a16="http://schemas.microsoft.com/office/drawing/2014/main" id="{50D96A47-312C-4CD4-95D4-C912795C85B8}"/>
               </a:ext>
             </a:extLst>
           </p:cNvPr>
@@ -13570,7 +13570,7 @@
           <p:cNvPr id="10" name="">
             <a:extLst xmlns:a="http://schemas.openxmlformats.org/drawingml/2006/main">
               <a:ext uri="{FF2B5EF4-FFF2-40B4-BE49-F238E27FC236}">
-                <a16:creationId xmlns:a16="http://schemas.microsoft.com/office/drawing/2014/main" id="{DB8424C9-AC85-49C8-BB60-1EC6511051C4}"/>
+                <a16:creationId xmlns:a16="http://schemas.microsoft.com/office/drawing/2014/main" id="{03C80A32-3507-4C5B-9634-A553A51D8BFF}"/>
               </a:ext>
             </a:extLst>
           </p:cNvPr>
@@ -13601,7 +13601,7 @@
           <p:cNvPr id="11" name="">
             <a:extLst xmlns:a="http://schemas.openxmlformats.org/drawingml/2006/main">
               <a:ext uri="{FF2B5EF4-FFF2-40B4-BE49-F238E27FC236}">
-                <a16:creationId xmlns:a16="http://schemas.microsoft.com/office/drawing/2014/main" id="{5756BCA7-F90D-4805-A608-75418EB24706}"/>
+                <a16:creationId xmlns:a16="http://schemas.microsoft.com/office/drawing/2014/main" id="{FC02C969-134B-4DCA-B34D-1C45EC0C08AC}"/>
               </a:ext>
             </a:extLst>
           </p:cNvPr>
@@ -13690,7 +13690,7 @@
           <p:cNvPr id="12" name="">
             <a:extLst xmlns:a="http://schemas.openxmlformats.org/drawingml/2006/main">
               <a:ext uri="{FF2B5EF4-FFF2-40B4-BE49-F238E27FC236}">
-                <a16:creationId xmlns:a16="http://schemas.microsoft.com/office/drawing/2014/main" id="{E6CB37F4-9DAB-4232-A1F1-69351E977746}"/>
+                <a16:creationId xmlns:a16="http://schemas.microsoft.com/office/drawing/2014/main" id="{846742A0-5F39-431B-991E-71B938FC8054}"/>
               </a:ext>
             </a:extLst>
           </p:cNvPr>
@@ -13725,7 +13725,7 @@
           <p:cNvPr id="13" name="">
             <a:extLst xmlns:a="http://schemas.openxmlformats.org/drawingml/2006/main">
               <a:ext uri="{FF2B5EF4-FFF2-40B4-BE49-F238E27FC236}">
-                <a16:creationId xmlns:a16="http://schemas.microsoft.com/office/drawing/2014/main" id="{8B249E8E-26C5-4E6C-BD35-C9C251279D1F}"/>
+                <a16:creationId xmlns:a16="http://schemas.microsoft.com/office/drawing/2014/main" id="{50C908AC-4DA4-4FF6-A544-E658383321C2}"/>
               </a:ext>
             </a:extLst>
           </p:cNvPr>
@@ -13756,7 +13756,7 @@
           <p:cNvPr id="14" name="">
             <a:extLst xmlns:a="http://schemas.openxmlformats.org/drawingml/2006/main">
               <a:ext uri="{FF2B5EF4-FFF2-40B4-BE49-F238E27FC236}">
-                <a16:creationId xmlns:a16="http://schemas.microsoft.com/office/drawing/2014/main" id="{99036F4D-4794-4EF5-A4F9-3A851C145F0C}"/>
+                <a16:creationId xmlns:a16="http://schemas.microsoft.com/office/drawing/2014/main" id="{3DB3F924-F754-4484-BA80-DEDFFAD91623}"/>
               </a:ext>
             </a:extLst>
           </p:cNvPr>
@@ -13845,7 +13845,7 @@
           <p:cNvPr id="15" name="">
             <a:extLst xmlns:a="http://schemas.openxmlformats.org/drawingml/2006/main">
               <a:ext uri="{FF2B5EF4-FFF2-40B4-BE49-F238E27FC236}">
-                <a16:creationId xmlns:a16="http://schemas.microsoft.com/office/drawing/2014/main" id="{AEB6DA03-FF82-4C89-8474-7C70F362A6E5}"/>
+                <a16:creationId xmlns:a16="http://schemas.microsoft.com/office/drawing/2014/main" id="{D5F2D4FD-6766-4EE4-8933-2F49BD0DAE52}"/>
               </a:ext>
             </a:extLst>
           </p:cNvPr>
@@ -13880,7 +13880,7 @@
           <p:cNvPr id="16" name="">
             <a:extLst xmlns:a="http://schemas.openxmlformats.org/drawingml/2006/main">
               <a:ext uri="{FF2B5EF4-FFF2-40B4-BE49-F238E27FC236}">
-                <a16:creationId xmlns:a16="http://schemas.microsoft.com/office/drawing/2014/main" id="{D3E09B6E-6834-45DA-8262-C3140A68EFF9}"/>
+                <a16:creationId xmlns:a16="http://schemas.microsoft.com/office/drawing/2014/main" id="{93892D73-0E04-40C5-BCB3-C3B6680091E4}"/>
               </a:ext>
             </a:extLst>
           </p:cNvPr>
@@ -13911,7 +13911,7 @@
           <p:cNvPr id="17" name="">
             <a:extLst xmlns:a="http://schemas.openxmlformats.org/drawingml/2006/main">
               <a:ext uri="{FF2B5EF4-FFF2-40B4-BE49-F238E27FC236}">
-                <a16:creationId xmlns:a16="http://schemas.microsoft.com/office/drawing/2014/main" id="{106C228E-D513-4768-9927-56E31D617AA4}"/>
+                <a16:creationId xmlns:a16="http://schemas.microsoft.com/office/drawing/2014/main" id="{B0A404A8-5884-4EAD-8118-45217B2D364F}"/>
               </a:ext>
             </a:extLst>
           </p:cNvPr>
@@ -14000,7 +14000,7 @@
           <p:cNvPr id="18" name="">
             <a:extLst xmlns:a="http://schemas.openxmlformats.org/drawingml/2006/main">
               <a:ext uri="{FF2B5EF4-FFF2-40B4-BE49-F238E27FC236}">
-                <a16:creationId xmlns:a16="http://schemas.microsoft.com/office/drawing/2014/main" id="{05F191AA-9A21-4A59-9B80-6E10FFAF0EAA}"/>
+                <a16:creationId xmlns:a16="http://schemas.microsoft.com/office/drawing/2014/main" id="{02513C30-7EEA-4F36-B2E3-16F9BD82D066}"/>
               </a:ext>
             </a:extLst>
           </p:cNvPr>
@@ -14035,7 +14035,7 @@
           <p:cNvPr id="19" name="">
             <a:extLst xmlns:a="http://schemas.openxmlformats.org/drawingml/2006/main">
               <a:ext uri="{FF2B5EF4-FFF2-40B4-BE49-F238E27FC236}">
-                <a16:creationId xmlns:a16="http://schemas.microsoft.com/office/drawing/2014/main" id="{1CA90740-BC8B-44F1-8894-04264AA2B62A}"/>
+                <a16:creationId xmlns:a16="http://schemas.microsoft.com/office/drawing/2014/main" id="{83A98AD8-D3C3-449A-B5A2-D76CC88D6429}"/>
               </a:ext>
             </a:extLst>
           </p:cNvPr>
@@ -14066,7 +14066,7 @@
           <p:cNvPr id="20" name="">
             <a:extLst xmlns:a="http://schemas.openxmlformats.org/drawingml/2006/main">
               <a:ext uri="{FF2B5EF4-FFF2-40B4-BE49-F238E27FC236}">
-                <a16:creationId xmlns:a16="http://schemas.microsoft.com/office/drawing/2014/main" id="{C231F7FA-CDFC-40C4-9764-D8276169C1A1}"/>
+                <a16:creationId xmlns:a16="http://schemas.microsoft.com/office/drawing/2014/main" id="{77A8ABC2-BC01-453F-858B-F3C79C1B33B1}"/>
               </a:ext>
             </a:extLst>
           </p:cNvPr>
@@ -14155,7 +14155,7 @@
           <p:cNvPr id="21" name="">
             <a:extLst xmlns:a="http://schemas.openxmlformats.org/drawingml/2006/main">
               <a:ext uri="{FF2B5EF4-FFF2-40B4-BE49-F238E27FC236}">
-                <a16:creationId xmlns:a16="http://schemas.microsoft.com/office/drawing/2014/main" id="{834BAC1D-7D48-4CB0-A892-84CB496896D2}"/>
+                <a16:creationId xmlns:a16="http://schemas.microsoft.com/office/drawing/2014/main" id="{85AB20C5-961E-4AFF-A8BC-55DE0DA58C88}"/>
               </a:ext>
             </a:extLst>
           </p:cNvPr>
@@ -14217,7 +14217,7 @@
     </p:spTree>
     <p:extLst>
       <p:ext uri="{BB962C8B-B14F-4D97-AF65-F5344CB8AC3E}">
-        <p14:creationId xmlns:p14="http://schemas.microsoft.com/office/powerpoint/2010/main" val="602156974"/>
+        <p14:creationId xmlns:p14="http://schemas.microsoft.com/office/powerpoint/2010/main" val="179631233"/>
       </p:ext>
     </p:extLst>
   </p:cSld>
@@ -14248,7 +14248,7 @@
           <p:cNvPr id="25" name="">
             <a:extLst xmlns:a="http://schemas.openxmlformats.org/drawingml/2006/main">
               <a:ext uri="{FF2B5EF4-FFF2-40B4-BE49-F238E27FC236}">
-                <a16:creationId xmlns:a16="http://schemas.microsoft.com/office/drawing/2014/main" id="{03E62D8D-7EBB-4B8C-8D39-C501A5E96EE3}"/>
+                <a16:creationId xmlns:a16="http://schemas.microsoft.com/office/drawing/2014/main" id="{F06D74D8-EAAD-4113-9503-089B04BB0709}"/>
               </a:ext>
             </a:extLst>
           </p:cNvPr>
@@ -14279,7 +14279,7 @@
           <p:cNvPr id="2" name="">
             <a:extLst xmlns:a="http://schemas.openxmlformats.org/drawingml/2006/main">
               <a:ext uri="{FF2B5EF4-FFF2-40B4-BE49-F238E27FC236}">
-                <a16:creationId xmlns:a16="http://schemas.microsoft.com/office/drawing/2014/main" id="{B03415B9-1E4D-45DF-B1A5-1261D15760F1}"/>
+                <a16:creationId xmlns:a16="http://schemas.microsoft.com/office/drawing/2014/main" id="{534276D8-61C9-4216-902E-1DF845977063}"/>
               </a:ext>
             </a:extLst>
           </p:cNvPr>
@@ -14341,7 +14341,7 @@
           <p:cNvPr id="3" name="">
             <a:extLst xmlns:a="http://schemas.openxmlformats.org/drawingml/2006/main">
               <a:ext uri="{FF2B5EF4-FFF2-40B4-BE49-F238E27FC236}">
-                <a16:creationId xmlns:a16="http://schemas.microsoft.com/office/drawing/2014/main" id="{36B98F2F-B8E1-4A81-948B-1CBE28A9CEDB}"/>
+                <a16:creationId xmlns:a16="http://schemas.microsoft.com/office/drawing/2014/main" id="{4284A893-A37C-4647-8CAC-C63419C7C760}"/>
               </a:ext>
             </a:extLst>
           </p:cNvPr>
@@ -14375,7 +14375,7 @@
                 <a:spcPct val="108000"/>
               </a:lnSpc>
               <a:buNone/>
-              <a:defRPr sz="3150" b="1">
+              <a:defRPr sz="2550" b="1">
                 <a:solidFill>
                   <a:srgbClr val="071426"/>
                 </a:solidFill>
@@ -14385,7 +14385,7 @@
               </a:defRPr>
             </a:pPr>
             <a:r>
-              <a:rPr sz="3150" b="1">
+              <a:rPr sz="2550" b="1">
                 <a:solidFill>
                   <a:srgbClr val="071426"/>
                 </a:solidFill>
@@ -14403,7 +14403,7 @@
           <p:cNvPr id="4" name="">
             <a:extLst xmlns:a="http://schemas.openxmlformats.org/drawingml/2006/main">
               <a:ext uri="{FF2B5EF4-FFF2-40B4-BE49-F238E27FC236}">
-                <a16:creationId xmlns:a16="http://schemas.microsoft.com/office/drawing/2014/main" id="{1CA27C7A-3753-4F07-8C99-0E331A6D5A58}"/>
+                <a16:creationId xmlns:a16="http://schemas.microsoft.com/office/drawing/2014/main" id="{E450B1C6-5BA4-4F41-B426-1D8E6BBAEF2E}"/>
               </a:ext>
             </a:extLst>
           </p:cNvPr>
@@ -14438,7 +14438,7 @@
           <p:nvPr/>
         </p:nvPicPr>
         <p:blipFill>
-          <a:blip xmlns:r="http://schemas.openxmlformats.org/officeDocument/2006/relationships" xmlns:a="http://schemas.openxmlformats.org/drawingml/2006/main" r:embed="R791e3133fbdb430d"/>
+          <a:blip xmlns:r="http://schemas.openxmlformats.org/officeDocument/2006/relationships" xmlns:a="http://schemas.openxmlformats.org/drawingml/2006/main" r:embed="R7e144dccfeb34034"/>
           <a:srcRect xmlns:a="http://schemas.openxmlformats.org/drawingml/2006/main" l="0" t="0" r="0" b="0"/>
           <a:stretch xmlns:a="http://schemas.openxmlformats.org/drawingml/2006/main">
             <a:fillRect l="0" t="0" r="0" b="0"/>
@@ -14459,7 +14459,7 @@
           <p:cNvPr id="6" name="">
             <a:extLst xmlns:a="http://schemas.openxmlformats.org/drawingml/2006/main">
               <a:ext uri="{FF2B5EF4-FFF2-40B4-BE49-F238E27FC236}">
-                <a16:creationId xmlns:a16="http://schemas.microsoft.com/office/drawing/2014/main" id="{05E80727-B9EF-43BB-8C72-0FDE9603DDDC}"/>
+                <a16:creationId xmlns:a16="http://schemas.microsoft.com/office/drawing/2014/main" id="{873D2605-4900-41CF-8376-8DCE8B5B6A6B}"/>
               </a:ext>
             </a:extLst>
           </p:cNvPr>
@@ -14521,7 +14521,7 @@
           <p:cNvPr id="7" name="">
             <a:extLst xmlns:a="http://schemas.openxmlformats.org/drawingml/2006/main">
               <a:ext uri="{FF2B5EF4-FFF2-40B4-BE49-F238E27FC236}">
-                <a16:creationId xmlns:a16="http://schemas.microsoft.com/office/drawing/2014/main" id="{8B9C7C53-3832-48E8-BEA0-DE23312A2C87}"/>
+                <a16:creationId xmlns:a16="http://schemas.microsoft.com/office/drawing/2014/main" id="{F282BB9F-0E77-4588-80F3-12F182B81A4E}"/>
               </a:ext>
             </a:extLst>
           </p:cNvPr>
@@ -14583,7 +14583,7 @@
           <p:cNvPr id="8" name="">
             <a:extLst xmlns:a="http://schemas.openxmlformats.org/drawingml/2006/main">
               <a:ext uri="{FF2B5EF4-FFF2-40B4-BE49-F238E27FC236}">
-                <a16:creationId xmlns:a16="http://schemas.microsoft.com/office/drawing/2014/main" id="{42E25CBC-D0CA-49FB-80FA-641EA7BDE008}"/>
+                <a16:creationId xmlns:a16="http://schemas.microsoft.com/office/drawing/2014/main" id="{F4D9ACB7-904E-4517-90CE-3568F9D24B31}"/>
               </a:ext>
             </a:extLst>
           </p:cNvPr>
@@ -14616,7 +14616,7 @@
           <p:cNvPr id="9" name="">
             <a:extLst xmlns:a="http://schemas.openxmlformats.org/drawingml/2006/main">
               <a:ext uri="{FF2B5EF4-FFF2-40B4-BE49-F238E27FC236}">
-                <a16:creationId xmlns:a16="http://schemas.microsoft.com/office/drawing/2014/main" id="{FD544A9A-F2D4-4995-8549-439B59F03B4F}"/>
+                <a16:creationId xmlns:a16="http://schemas.microsoft.com/office/drawing/2014/main" id="{3C6C383B-B288-4D82-9333-2F1700A35940}"/>
               </a:ext>
             </a:extLst>
           </p:cNvPr>
@@ -14678,7 +14678,7 @@
           <p:cNvPr id="10" name="">
             <a:extLst xmlns:a="http://schemas.openxmlformats.org/drawingml/2006/main">
               <a:ext uri="{FF2B5EF4-FFF2-40B4-BE49-F238E27FC236}">
-                <a16:creationId xmlns:a16="http://schemas.microsoft.com/office/drawing/2014/main" id="{F34A615D-29B6-4A17-9535-5BD8D2D56773}"/>
+                <a16:creationId xmlns:a16="http://schemas.microsoft.com/office/drawing/2014/main" id="{C226268C-8EDC-433E-9E3B-42985DED6C4F}"/>
               </a:ext>
             </a:extLst>
           </p:cNvPr>
@@ -14767,7 +14767,7 @@
           <p:cNvPr id="11" name="">
             <a:extLst xmlns:a="http://schemas.openxmlformats.org/drawingml/2006/main">
               <a:ext uri="{FF2B5EF4-FFF2-40B4-BE49-F238E27FC236}">
-                <a16:creationId xmlns:a16="http://schemas.microsoft.com/office/drawing/2014/main" id="{1D54CFE4-0D98-4559-96B1-69C5EB69B86C}"/>
+                <a16:creationId xmlns:a16="http://schemas.microsoft.com/office/drawing/2014/main" id="{2362B503-E830-455A-A850-3A073B7763CA}"/>
               </a:ext>
             </a:extLst>
           </p:cNvPr>
@@ -14856,7 +14856,7 @@
           <p:cNvPr id="12" name="">
             <a:extLst xmlns:a="http://schemas.openxmlformats.org/drawingml/2006/main">
               <a:ext uri="{FF2B5EF4-FFF2-40B4-BE49-F238E27FC236}">
-                <a16:creationId xmlns:a16="http://schemas.microsoft.com/office/drawing/2014/main" id="{AA8CE7C7-F384-4393-9C3D-6D02BF1D7D62}"/>
+                <a16:creationId xmlns:a16="http://schemas.microsoft.com/office/drawing/2014/main" id="{6C8E9CE4-FCFA-45E1-8FFB-01051F3ACBBD}"/>
               </a:ext>
             </a:extLst>
           </p:cNvPr>
@@ -14891,7 +14891,7 @@
           <p:cNvPr id="13" name="">
             <a:extLst xmlns:a="http://schemas.openxmlformats.org/drawingml/2006/main">
               <a:ext uri="{FF2B5EF4-FFF2-40B4-BE49-F238E27FC236}">
-                <a16:creationId xmlns:a16="http://schemas.microsoft.com/office/drawing/2014/main" id="{674C92F5-12D7-4F8F-A771-2931F5C1F41A}"/>
+                <a16:creationId xmlns:a16="http://schemas.microsoft.com/office/drawing/2014/main" id="{63763DD2-8BE0-45CD-BF81-C4C906C31064}"/>
               </a:ext>
             </a:extLst>
           </p:cNvPr>
@@ -14922,7 +14922,7 @@
           <p:cNvPr id="14" name="">
             <a:extLst xmlns:a="http://schemas.openxmlformats.org/drawingml/2006/main">
               <a:ext uri="{FF2B5EF4-FFF2-40B4-BE49-F238E27FC236}">
-                <a16:creationId xmlns:a16="http://schemas.microsoft.com/office/drawing/2014/main" id="{F53507D6-5A66-48A4-BD74-4141DAA83A78}"/>
+                <a16:creationId xmlns:a16="http://schemas.microsoft.com/office/drawing/2014/main" id="{B6E514B2-80D3-4A12-8963-EADE079184FD}"/>
               </a:ext>
             </a:extLst>
           </p:cNvPr>
@@ -14984,7 +14984,7 @@
           <p:cNvPr id="15" name="">
             <a:extLst xmlns:a="http://schemas.openxmlformats.org/drawingml/2006/main">
               <a:ext uri="{FF2B5EF4-FFF2-40B4-BE49-F238E27FC236}">
-                <a16:creationId xmlns:a16="http://schemas.microsoft.com/office/drawing/2014/main" id="{D6E356A8-46BC-4AD0-8AF5-ED15DA731F93}"/>
+                <a16:creationId xmlns:a16="http://schemas.microsoft.com/office/drawing/2014/main" id="{6BC478ED-67EF-4441-96A6-637E6DE75EDD}"/>
               </a:ext>
             </a:extLst>
           </p:cNvPr>
@@ -15019,7 +15019,7 @@
           <p:cNvPr id="16" name="">
             <a:extLst xmlns:a="http://schemas.openxmlformats.org/drawingml/2006/main">
               <a:ext uri="{FF2B5EF4-FFF2-40B4-BE49-F238E27FC236}">
-                <a16:creationId xmlns:a16="http://schemas.microsoft.com/office/drawing/2014/main" id="{95654364-6A4B-41BD-957A-582DD43964FC}"/>
+                <a16:creationId xmlns:a16="http://schemas.microsoft.com/office/drawing/2014/main" id="{1B3469B5-7AD7-4417-946B-32893D5CBA95}"/>
               </a:ext>
             </a:extLst>
           </p:cNvPr>
@@ -15050,7 +15050,7 @@
           <p:cNvPr id="17" name="">
             <a:extLst xmlns:a="http://schemas.openxmlformats.org/drawingml/2006/main">
               <a:ext uri="{FF2B5EF4-FFF2-40B4-BE49-F238E27FC236}">
-                <a16:creationId xmlns:a16="http://schemas.microsoft.com/office/drawing/2014/main" id="{11D8F197-8AD4-40BB-B63B-4FB227C92E23}"/>
+                <a16:creationId xmlns:a16="http://schemas.microsoft.com/office/drawing/2014/main" id="{FA8D4BCC-03D2-4706-8CAD-4A29EF92A47A}"/>
               </a:ext>
             </a:extLst>
           </p:cNvPr>
@@ -15112,7 +15112,7 @@
           <p:cNvPr id="18" name="">
             <a:extLst xmlns:a="http://schemas.openxmlformats.org/drawingml/2006/main">
               <a:ext uri="{FF2B5EF4-FFF2-40B4-BE49-F238E27FC236}">
-                <a16:creationId xmlns:a16="http://schemas.microsoft.com/office/drawing/2014/main" id="{307F219D-4FF8-4F9A-8951-321B51C5A429}"/>
+                <a16:creationId xmlns:a16="http://schemas.microsoft.com/office/drawing/2014/main" id="{515D0E10-CFE9-4BE9-85D5-0822E2D66C95}"/>
               </a:ext>
             </a:extLst>
           </p:cNvPr>
@@ -15147,7 +15147,7 @@
           <p:cNvPr id="19" name="">
             <a:extLst xmlns:a="http://schemas.openxmlformats.org/drawingml/2006/main">
               <a:ext uri="{FF2B5EF4-FFF2-40B4-BE49-F238E27FC236}">
-                <a16:creationId xmlns:a16="http://schemas.microsoft.com/office/drawing/2014/main" id="{E7B28040-E3B0-41D9-BD55-C100ADDED7EB}"/>
+                <a16:creationId xmlns:a16="http://schemas.microsoft.com/office/drawing/2014/main" id="{022A320A-3CF9-4D6D-AFBA-8D938A5C50EF}"/>
               </a:ext>
             </a:extLst>
           </p:cNvPr>
@@ -15178,7 +15178,7 @@
           <p:cNvPr id="20" name="">
             <a:extLst xmlns:a="http://schemas.openxmlformats.org/drawingml/2006/main">
               <a:ext uri="{FF2B5EF4-FFF2-40B4-BE49-F238E27FC236}">
-                <a16:creationId xmlns:a16="http://schemas.microsoft.com/office/drawing/2014/main" id="{8BC8ADD4-92FC-4448-859C-4CA1578485C6}"/>
+                <a16:creationId xmlns:a16="http://schemas.microsoft.com/office/drawing/2014/main" id="{011F5C97-E1EA-4300-9C2A-FBD791305EDC}"/>
               </a:ext>
             </a:extLst>
           </p:cNvPr>
@@ -15240,7 +15240,7 @@
           <p:cNvPr id="21" name="">
             <a:extLst xmlns:a="http://schemas.openxmlformats.org/drawingml/2006/main">
               <a:ext uri="{FF2B5EF4-FFF2-40B4-BE49-F238E27FC236}">
-                <a16:creationId xmlns:a16="http://schemas.microsoft.com/office/drawing/2014/main" id="{9E1150A6-5CD8-4303-A4A3-28BB7B74374A}"/>
+                <a16:creationId xmlns:a16="http://schemas.microsoft.com/office/drawing/2014/main" id="{340B1CE3-DE7B-45FA-8F6A-F150F920CDBE}"/>
               </a:ext>
             </a:extLst>
           </p:cNvPr>
@@ -15275,7 +15275,7 @@
           <p:cNvPr id="22" name="">
             <a:extLst xmlns:a="http://schemas.openxmlformats.org/drawingml/2006/main">
               <a:ext uri="{FF2B5EF4-FFF2-40B4-BE49-F238E27FC236}">
-                <a16:creationId xmlns:a16="http://schemas.microsoft.com/office/drawing/2014/main" id="{C643B078-79E1-4BEB-95C5-F641C597C53D}"/>
+                <a16:creationId xmlns:a16="http://schemas.microsoft.com/office/drawing/2014/main" id="{69B1FD3F-2A01-4002-B0BE-8192101C351A}"/>
               </a:ext>
             </a:extLst>
           </p:cNvPr>
@@ -15306,7 +15306,7 @@
           <p:cNvPr id="23" name="">
             <a:extLst xmlns:a="http://schemas.openxmlformats.org/drawingml/2006/main">
               <a:ext uri="{FF2B5EF4-FFF2-40B4-BE49-F238E27FC236}">
-                <a16:creationId xmlns:a16="http://schemas.microsoft.com/office/drawing/2014/main" id="{C1E1B901-689A-44A0-9431-AD9D5E6463EF}"/>
+                <a16:creationId xmlns:a16="http://schemas.microsoft.com/office/drawing/2014/main" id="{E9505DF9-FA65-406B-BC52-2C045A477D96}"/>
               </a:ext>
             </a:extLst>
           </p:cNvPr>
@@ -15368,7 +15368,7 @@
           <p:cNvPr id="24" name="">
             <a:extLst xmlns:a="http://schemas.openxmlformats.org/drawingml/2006/main">
               <a:ext uri="{FF2B5EF4-FFF2-40B4-BE49-F238E27FC236}">
-                <a16:creationId xmlns:a16="http://schemas.microsoft.com/office/drawing/2014/main" id="{443FCC77-C609-4C00-977F-85270A12DC91}"/>
+                <a16:creationId xmlns:a16="http://schemas.microsoft.com/office/drawing/2014/main" id="{80242D7B-DB0E-4E6F-BFD3-6D2B31850212}"/>
               </a:ext>
             </a:extLst>
           </p:cNvPr>
@@ -15430,7 +15430,7 @@
     </p:spTree>
     <p:extLst>
       <p:ext uri="{BB962C8B-B14F-4D97-AF65-F5344CB8AC3E}">
-        <p14:creationId xmlns:p14="http://schemas.microsoft.com/office/powerpoint/2010/main" val="225010075"/>
+        <p14:creationId xmlns:p14="http://schemas.microsoft.com/office/powerpoint/2010/main" val="1016403664"/>
       </p:ext>
     </p:extLst>
   </p:cSld>
@@ -15461,7 +15461,7 @@
           <p:cNvPr id="29" name="">
             <a:extLst xmlns:a="http://schemas.openxmlformats.org/drawingml/2006/main">
               <a:ext uri="{FF2B5EF4-FFF2-40B4-BE49-F238E27FC236}">
-                <a16:creationId xmlns:a16="http://schemas.microsoft.com/office/drawing/2014/main" id="{7824A557-6B1F-443C-8816-B0E07DC0D074}"/>
+                <a16:creationId xmlns:a16="http://schemas.microsoft.com/office/drawing/2014/main" id="{E5AADF5B-D595-4815-BCD2-D427D29EEB2F}"/>
               </a:ext>
             </a:extLst>
           </p:cNvPr>
@@ -15492,7 +15492,7 @@
           <p:cNvPr id="2" name="">
             <a:extLst xmlns:a="http://schemas.openxmlformats.org/drawingml/2006/main">
               <a:ext uri="{FF2B5EF4-FFF2-40B4-BE49-F238E27FC236}">
-                <a16:creationId xmlns:a16="http://schemas.microsoft.com/office/drawing/2014/main" id="{675B0FE8-BA03-456D-8561-5BCEBC6EDE3B}"/>
+                <a16:creationId xmlns:a16="http://schemas.microsoft.com/office/drawing/2014/main" id="{F93111BA-7271-4543-BEF9-4415AC083C52}"/>
               </a:ext>
             </a:extLst>
           </p:cNvPr>
@@ -15554,7 +15554,7 @@
           <p:cNvPr id="3" name="">
             <a:extLst xmlns:a="http://schemas.openxmlformats.org/drawingml/2006/main">
               <a:ext uri="{FF2B5EF4-FFF2-40B4-BE49-F238E27FC236}">
-                <a16:creationId xmlns:a16="http://schemas.microsoft.com/office/drawing/2014/main" id="{FC93EF38-B450-46B5-8208-BC8C6E0A2ADA}"/>
+                <a16:creationId xmlns:a16="http://schemas.microsoft.com/office/drawing/2014/main" id="{CFFE33B7-B246-46C7-AE96-B5A3F80C7080}"/>
               </a:ext>
             </a:extLst>
           </p:cNvPr>
@@ -15616,7 +15616,7 @@
           <p:cNvPr id="4" name="">
             <a:extLst xmlns:a="http://schemas.openxmlformats.org/drawingml/2006/main">
               <a:ext uri="{FF2B5EF4-FFF2-40B4-BE49-F238E27FC236}">
-                <a16:creationId xmlns:a16="http://schemas.microsoft.com/office/drawing/2014/main" id="{6A15DE6B-BA52-4375-B37D-40819CF534E7}"/>
+                <a16:creationId xmlns:a16="http://schemas.microsoft.com/office/drawing/2014/main" id="{E99BB0E9-D3F0-445E-B707-183CDA5DF125}"/>
               </a:ext>
             </a:extLst>
           </p:cNvPr>
@@ -15651,7 +15651,7 @@
           <p:nvPr/>
         </p:nvPicPr>
         <p:blipFill>
-          <a:blip xmlns:r="http://schemas.openxmlformats.org/officeDocument/2006/relationships" xmlns:a="http://schemas.openxmlformats.org/drawingml/2006/main" r:embed="R158c3a9f758c4ea4"/>
+          <a:blip xmlns:r="http://schemas.openxmlformats.org/officeDocument/2006/relationships" xmlns:a="http://schemas.openxmlformats.org/drawingml/2006/main" r:embed="Rcbf91acffcdf4cb8"/>
           <a:srcRect xmlns:a="http://schemas.openxmlformats.org/drawingml/2006/main" l="0" t="0" r="0" b="0"/>
           <a:stretch xmlns:a="http://schemas.openxmlformats.org/drawingml/2006/main">
             <a:fillRect l="0" t="0" r="0" b="0"/>
@@ -15672,7 +15672,7 @@
           <p:cNvPr id="6" name="">
             <a:extLst xmlns:a="http://schemas.openxmlformats.org/drawingml/2006/main">
               <a:ext uri="{FF2B5EF4-FFF2-40B4-BE49-F238E27FC236}">
-                <a16:creationId xmlns:a16="http://schemas.microsoft.com/office/drawing/2014/main" id="{1F89F631-8542-4F3F-B51D-0FD153B540CD}"/>
+                <a16:creationId xmlns:a16="http://schemas.microsoft.com/office/drawing/2014/main" id="{805BC479-96C2-40B4-9430-D619164EA9BF}"/>
               </a:ext>
             </a:extLst>
           </p:cNvPr>
@@ -15734,7 +15734,7 @@
           <p:cNvPr id="7" name="">
             <a:extLst xmlns:a="http://schemas.openxmlformats.org/drawingml/2006/main">
               <a:ext uri="{FF2B5EF4-FFF2-40B4-BE49-F238E27FC236}">
-                <a16:creationId xmlns:a16="http://schemas.microsoft.com/office/drawing/2014/main" id="{441A90A1-8B22-4544-808B-E0270C0F047F}"/>
+                <a16:creationId xmlns:a16="http://schemas.microsoft.com/office/drawing/2014/main" id="{95D71681-56D9-420E-9BE0-4B4ABCC30050}"/>
               </a:ext>
             </a:extLst>
           </p:cNvPr>
@@ -15796,7 +15796,7 @@
           <p:cNvPr id="8" name="">
             <a:extLst xmlns:a="http://schemas.openxmlformats.org/drawingml/2006/main">
               <a:ext uri="{FF2B5EF4-FFF2-40B4-BE49-F238E27FC236}">
-                <a16:creationId xmlns:a16="http://schemas.microsoft.com/office/drawing/2014/main" id="{8E6E8B9F-E348-4188-A800-94D148BBE882}"/>
+                <a16:creationId xmlns:a16="http://schemas.microsoft.com/office/drawing/2014/main" id="{19CBC1F8-5BF4-4579-9351-148C22FE22EA}"/>
               </a:ext>
             </a:extLst>
           </p:cNvPr>
@@ -15831,7 +15831,7 @@
           <p:cNvPr id="9" name="">
             <a:extLst xmlns:a="http://schemas.openxmlformats.org/drawingml/2006/main">
               <a:ext uri="{FF2B5EF4-FFF2-40B4-BE49-F238E27FC236}">
-                <a16:creationId xmlns:a16="http://schemas.microsoft.com/office/drawing/2014/main" id="{A213D76D-2ADC-4134-BACB-F6E0B0849CDE}"/>
+                <a16:creationId xmlns:a16="http://schemas.microsoft.com/office/drawing/2014/main" id="{31F353FF-FB89-4456-9972-B83AD049309F}"/>
               </a:ext>
             </a:extLst>
           </p:cNvPr>
@@ -15862,7 +15862,7 @@
           <p:cNvPr id="10" name="">
             <a:extLst xmlns:a="http://schemas.openxmlformats.org/drawingml/2006/main">
               <a:ext uri="{FF2B5EF4-FFF2-40B4-BE49-F238E27FC236}">
-                <a16:creationId xmlns:a16="http://schemas.microsoft.com/office/drawing/2014/main" id="{12E064C8-1BC9-4F70-A3C1-CC86FFDBD532}"/>
+                <a16:creationId xmlns:a16="http://schemas.microsoft.com/office/drawing/2014/main" id="{B8D1FE3C-3D4B-4FA1-9A77-A886122BB435}"/>
               </a:ext>
             </a:extLst>
           </p:cNvPr>
@@ -15924,7 +15924,7 @@
           <p:cNvPr id="11" name="">
             <a:extLst xmlns:a="http://schemas.openxmlformats.org/drawingml/2006/main">
               <a:ext uri="{FF2B5EF4-FFF2-40B4-BE49-F238E27FC236}">
-                <a16:creationId xmlns:a16="http://schemas.microsoft.com/office/drawing/2014/main" id="{DF14227E-D325-412F-A5B1-77DC2D205C88}"/>
+                <a16:creationId xmlns:a16="http://schemas.microsoft.com/office/drawing/2014/main" id="{D5FC7894-AEAA-4121-BE63-675EF3972C98}"/>
               </a:ext>
             </a:extLst>
           </p:cNvPr>
@@ -15986,7 +15986,7 @@
           <p:cNvPr id="12" name="">
             <a:extLst xmlns:a="http://schemas.openxmlformats.org/drawingml/2006/main">
               <a:ext uri="{FF2B5EF4-FFF2-40B4-BE49-F238E27FC236}">
-                <a16:creationId xmlns:a16="http://schemas.microsoft.com/office/drawing/2014/main" id="{5C8569B2-A792-40BD-8682-278C39323147}"/>
+                <a16:creationId xmlns:a16="http://schemas.microsoft.com/office/drawing/2014/main" id="{C0C24469-48A2-4DF6-B1E4-63C2B0F8DBF6}"/>
               </a:ext>
             </a:extLst>
           </p:cNvPr>
@@ -16021,7 +16021,7 @@
           <p:cNvPr id="13" name="">
             <a:extLst xmlns:a="http://schemas.openxmlformats.org/drawingml/2006/main">
               <a:ext uri="{FF2B5EF4-FFF2-40B4-BE49-F238E27FC236}">
-                <a16:creationId xmlns:a16="http://schemas.microsoft.com/office/drawing/2014/main" id="{694EB5C8-2AB8-4AAC-BA2E-59C69334464B}"/>
+                <a16:creationId xmlns:a16="http://schemas.microsoft.com/office/drawing/2014/main" id="{EFF34A43-1EC3-45DF-8C84-1A95D9B8DC8A}"/>
               </a:ext>
             </a:extLst>
           </p:cNvPr>
@@ -16052,7 +16052,7 @@
           <p:cNvPr id="14" name="">
             <a:extLst xmlns:a="http://schemas.openxmlformats.org/drawingml/2006/main">
               <a:ext uri="{FF2B5EF4-FFF2-40B4-BE49-F238E27FC236}">
-                <a16:creationId xmlns:a16="http://schemas.microsoft.com/office/drawing/2014/main" id="{100EF394-9FF0-4911-9581-BAA550B81CF2}"/>
+                <a16:creationId xmlns:a16="http://schemas.microsoft.com/office/drawing/2014/main" id="{4BA74D96-FC00-42B2-A784-EA5EAC20E06F}"/>
               </a:ext>
             </a:extLst>
           </p:cNvPr>
@@ -16114,7 +16114,7 @@
           <p:cNvPr id="15" name="">
             <a:extLst xmlns:a="http://schemas.openxmlformats.org/drawingml/2006/main">
               <a:ext uri="{FF2B5EF4-FFF2-40B4-BE49-F238E27FC236}">
-                <a16:creationId xmlns:a16="http://schemas.microsoft.com/office/drawing/2014/main" id="{47383361-A2C1-4204-B7BD-54A9C2DF9A21}"/>
+                <a16:creationId xmlns:a16="http://schemas.microsoft.com/office/drawing/2014/main" id="{BB245889-DB47-473D-AA74-49C8DB20232A}"/>
               </a:ext>
             </a:extLst>
           </p:cNvPr>
@@ -16176,7 +16176,7 @@
           <p:cNvPr id="16" name="">
             <a:extLst xmlns:a="http://schemas.openxmlformats.org/drawingml/2006/main">
               <a:ext uri="{FF2B5EF4-FFF2-40B4-BE49-F238E27FC236}">
-                <a16:creationId xmlns:a16="http://schemas.microsoft.com/office/drawing/2014/main" id="{974DF78F-BE1B-4D80-A563-C2036A37DEE2}"/>
+                <a16:creationId xmlns:a16="http://schemas.microsoft.com/office/drawing/2014/main" id="{B0DF78B1-EFD7-4971-9EDE-CCB95C08BD4A}"/>
               </a:ext>
             </a:extLst>
           </p:cNvPr>
@@ -16211,7 +16211,7 @@
           <p:cNvPr id="17" name="">
             <a:extLst xmlns:a="http://schemas.openxmlformats.org/drawingml/2006/main">
               <a:ext uri="{FF2B5EF4-FFF2-40B4-BE49-F238E27FC236}">
-                <a16:creationId xmlns:a16="http://schemas.microsoft.com/office/drawing/2014/main" id="{DB14B63F-3B3C-431D-BC95-DFD0910B1E3D}"/>
+                <a16:creationId xmlns:a16="http://schemas.microsoft.com/office/drawing/2014/main" id="{DACCF714-306B-4A29-90CC-1FED8C5A6738}"/>
               </a:ext>
             </a:extLst>
           </p:cNvPr>
@@ -16242,7 +16242,7 @@
           <p:cNvPr id="18" name="">
             <a:extLst xmlns:a="http://schemas.openxmlformats.org/drawingml/2006/main">
               <a:ext uri="{FF2B5EF4-FFF2-40B4-BE49-F238E27FC236}">
-                <a16:creationId xmlns:a16="http://schemas.microsoft.com/office/drawing/2014/main" id="{76F43012-63EC-4CF2-B163-E5C4ED283934}"/>
+                <a16:creationId xmlns:a16="http://schemas.microsoft.com/office/drawing/2014/main" id="{D228A528-8474-40A4-99AA-3D93940ED891}"/>
               </a:ext>
             </a:extLst>
           </p:cNvPr>
@@ -16304,7 +16304,7 @@
           <p:cNvPr id="19" name="">
             <a:extLst xmlns:a="http://schemas.openxmlformats.org/drawingml/2006/main">
               <a:ext uri="{FF2B5EF4-FFF2-40B4-BE49-F238E27FC236}">
-                <a16:creationId xmlns:a16="http://schemas.microsoft.com/office/drawing/2014/main" id="{F392B5B7-91D4-4E2D-B4B4-852903A3CCBD}"/>
+                <a16:creationId xmlns:a16="http://schemas.microsoft.com/office/drawing/2014/main" id="{B8C6348E-13EF-4617-8F2C-5A68A80FE2B1}"/>
               </a:ext>
             </a:extLst>
           </p:cNvPr>
@@ -16366,7 +16366,7 @@
           <p:cNvPr id="20" name="">
             <a:extLst xmlns:a="http://schemas.openxmlformats.org/drawingml/2006/main">
               <a:ext uri="{FF2B5EF4-FFF2-40B4-BE49-F238E27FC236}">
-                <a16:creationId xmlns:a16="http://schemas.microsoft.com/office/drawing/2014/main" id="{38228517-D15E-4C16-ACD9-7D5896A1CBF9}"/>
+                <a16:creationId xmlns:a16="http://schemas.microsoft.com/office/drawing/2014/main" id="{7FCCB2DC-3BD9-4AD1-93ED-822D61F48471}"/>
               </a:ext>
             </a:extLst>
           </p:cNvPr>
@@ -16401,7 +16401,7 @@
           <p:cNvPr id="21" name="">
             <a:extLst xmlns:a="http://schemas.openxmlformats.org/drawingml/2006/main">
               <a:ext uri="{FF2B5EF4-FFF2-40B4-BE49-F238E27FC236}">
-                <a16:creationId xmlns:a16="http://schemas.microsoft.com/office/drawing/2014/main" id="{E432BCE2-A0E2-4908-BF42-E9076FE08418}"/>
+                <a16:creationId xmlns:a16="http://schemas.microsoft.com/office/drawing/2014/main" id="{36DBD890-2CF6-43EE-A84B-FE3B64793DFE}"/>
               </a:ext>
             </a:extLst>
           </p:cNvPr>
@@ -16432,7 +16432,7 @@
           <p:cNvPr id="22" name="">
             <a:extLst xmlns:a="http://schemas.openxmlformats.org/drawingml/2006/main">
               <a:ext uri="{FF2B5EF4-FFF2-40B4-BE49-F238E27FC236}">
-                <a16:creationId xmlns:a16="http://schemas.microsoft.com/office/drawing/2014/main" id="{924E4449-76E9-4599-9894-03409DB34F29}"/>
+                <a16:creationId xmlns:a16="http://schemas.microsoft.com/office/drawing/2014/main" id="{3AEB6C63-A73E-40FA-AE08-008B38DB4E31}"/>
               </a:ext>
             </a:extLst>
           </p:cNvPr>
@@ -16494,7 +16494,7 @@
           <p:cNvPr id="23" name="">
             <a:extLst xmlns:a="http://schemas.openxmlformats.org/drawingml/2006/main">
               <a:ext uri="{FF2B5EF4-FFF2-40B4-BE49-F238E27FC236}">
-                <a16:creationId xmlns:a16="http://schemas.microsoft.com/office/drawing/2014/main" id="{EAFA7F09-605B-4949-B4EA-349CCEDD3A94}"/>
+                <a16:creationId xmlns:a16="http://schemas.microsoft.com/office/drawing/2014/main" id="{3F675AA4-FBC8-4026-B426-52F2ACDEC6BA}"/>
               </a:ext>
             </a:extLst>
           </p:cNvPr>
@@ -16556,7 +16556,7 @@
           <p:cNvPr id="24" name="">
             <a:extLst xmlns:a="http://schemas.openxmlformats.org/drawingml/2006/main">
               <a:ext uri="{FF2B5EF4-FFF2-40B4-BE49-F238E27FC236}">
-                <a16:creationId xmlns:a16="http://schemas.microsoft.com/office/drawing/2014/main" id="{DC50897C-AE45-4048-A4C5-427F94E7F380}"/>
+                <a16:creationId xmlns:a16="http://schemas.microsoft.com/office/drawing/2014/main" id="{18427A9B-D69C-4EE8-9FDA-63F845048B3B}"/>
               </a:ext>
             </a:extLst>
           </p:cNvPr>
@@ -16591,7 +16591,7 @@
           <p:cNvPr id="25" name="">
             <a:extLst xmlns:a="http://schemas.openxmlformats.org/drawingml/2006/main">
               <a:ext uri="{FF2B5EF4-FFF2-40B4-BE49-F238E27FC236}">
-                <a16:creationId xmlns:a16="http://schemas.microsoft.com/office/drawing/2014/main" id="{1D402EA7-53D5-491F-8DD2-7C10E855B8E8}"/>
+                <a16:creationId xmlns:a16="http://schemas.microsoft.com/office/drawing/2014/main" id="{237E610A-6419-4DF1-AF50-CF66EB1F83CF}"/>
               </a:ext>
             </a:extLst>
           </p:cNvPr>
@@ -16622,7 +16622,7 @@
           <p:cNvPr id="26" name="">
             <a:extLst xmlns:a="http://schemas.openxmlformats.org/drawingml/2006/main">
               <a:ext uri="{FF2B5EF4-FFF2-40B4-BE49-F238E27FC236}">
-                <a16:creationId xmlns:a16="http://schemas.microsoft.com/office/drawing/2014/main" id="{DBDE2DAB-1F64-412B-B76B-F67EBDC6EFB6}"/>
+                <a16:creationId xmlns:a16="http://schemas.microsoft.com/office/drawing/2014/main" id="{BD9EA9F1-FCEA-4AA9-9051-5C60CAB185DD}"/>
               </a:ext>
             </a:extLst>
           </p:cNvPr>
@@ -16684,7 +16684,7 @@
           <p:cNvPr id="27" name="">
             <a:extLst xmlns:a="http://schemas.openxmlformats.org/drawingml/2006/main">
               <a:ext uri="{FF2B5EF4-FFF2-40B4-BE49-F238E27FC236}">
-                <a16:creationId xmlns:a16="http://schemas.microsoft.com/office/drawing/2014/main" id="{DC8184AE-F5BE-4588-BA68-019990F62BF3}"/>
+                <a16:creationId xmlns:a16="http://schemas.microsoft.com/office/drawing/2014/main" id="{1120ADE5-FDDA-4163-BAAF-ACB738DB4EFC}"/>
               </a:ext>
             </a:extLst>
           </p:cNvPr>
@@ -16746,7 +16746,7 @@
           <p:cNvPr id="28" name="">
             <a:extLst xmlns:a="http://schemas.openxmlformats.org/drawingml/2006/main">
               <a:ext uri="{FF2B5EF4-FFF2-40B4-BE49-F238E27FC236}">
-                <a16:creationId xmlns:a16="http://schemas.microsoft.com/office/drawing/2014/main" id="{B1B2E9A4-168F-41D1-B75F-02D8EE9D7EE9}"/>
+                <a16:creationId xmlns:a16="http://schemas.microsoft.com/office/drawing/2014/main" id="{DAF83124-FE8B-41D2-8692-6B7E86FD16A0}"/>
               </a:ext>
             </a:extLst>
           </p:cNvPr>
@@ -16808,7 +16808,7 @@
     </p:spTree>
     <p:extLst>
       <p:ext uri="{BB962C8B-B14F-4D97-AF65-F5344CB8AC3E}">
-        <p14:creationId xmlns:p14="http://schemas.microsoft.com/office/powerpoint/2010/main" val="246224704"/>
+        <p14:creationId xmlns:p14="http://schemas.microsoft.com/office/powerpoint/2010/main" val="644794912"/>
       </p:ext>
     </p:extLst>
   </p:cSld>
@@ -16839,7 +16839,7 @@
           <p:cNvPr id="29" name="">
             <a:extLst xmlns:a="http://schemas.openxmlformats.org/drawingml/2006/main">
               <a:ext uri="{FF2B5EF4-FFF2-40B4-BE49-F238E27FC236}">
-                <a16:creationId xmlns:a16="http://schemas.microsoft.com/office/drawing/2014/main" id="{D809B6BB-1489-4155-ADA5-728A47B646F2}"/>
+                <a16:creationId xmlns:a16="http://schemas.microsoft.com/office/drawing/2014/main" id="{AAF1E8B7-EC03-4D5C-8BA5-B6A4D64BB8EB}"/>
               </a:ext>
             </a:extLst>
           </p:cNvPr>
@@ -16870,7 +16870,7 @@
           <p:cNvPr id="2" name="">
             <a:extLst xmlns:a="http://schemas.openxmlformats.org/drawingml/2006/main">
               <a:ext uri="{FF2B5EF4-FFF2-40B4-BE49-F238E27FC236}">
-                <a16:creationId xmlns:a16="http://schemas.microsoft.com/office/drawing/2014/main" id="{DCE70943-E4F4-4288-A742-E6DEF1ECB5D1}"/>
+                <a16:creationId xmlns:a16="http://schemas.microsoft.com/office/drawing/2014/main" id="{6C0E8703-97F8-44ED-8E35-ACD81A0E9942}"/>
               </a:ext>
             </a:extLst>
           </p:cNvPr>
@@ -16932,7 +16932,7 @@
           <p:cNvPr id="3" name="">
             <a:extLst xmlns:a="http://schemas.openxmlformats.org/drawingml/2006/main">
               <a:ext uri="{FF2B5EF4-FFF2-40B4-BE49-F238E27FC236}">
-                <a16:creationId xmlns:a16="http://schemas.microsoft.com/office/drawing/2014/main" id="{7486C5D0-949E-4AA7-8395-50B1BE63DFA3}"/>
+                <a16:creationId xmlns:a16="http://schemas.microsoft.com/office/drawing/2014/main" id="{F1C1D39D-4DEB-4C89-BFEC-2F51B5BE9A11}"/>
               </a:ext>
             </a:extLst>
           </p:cNvPr>
@@ -16966,7 +16966,7 @@
                 <a:spcPct val="108000"/>
               </a:lnSpc>
               <a:buNone/>
-              <a:defRPr sz="3150" b="1">
+              <a:defRPr sz="2250" b="1">
                 <a:solidFill>
                   <a:srgbClr val="071426"/>
                 </a:solidFill>
@@ -16976,7 +16976,7 @@
               </a:defRPr>
             </a:pPr>
             <a:r>
-              <a:rPr sz="3150" b="1">
+              <a:rPr sz="2250" b="1">
                 <a:solidFill>
                   <a:srgbClr val="071426"/>
                 </a:solidFill>
@@ -16994,7 +16994,7 @@
           <p:cNvPr id="4" name="">
             <a:extLst xmlns:a="http://schemas.openxmlformats.org/drawingml/2006/main">
               <a:ext uri="{FF2B5EF4-FFF2-40B4-BE49-F238E27FC236}">
-                <a16:creationId xmlns:a16="http://schemas.microsoft.com/office/drawing/2014/main" id="{AF832E3B-CA7F-42F5-912A-0BF28C37B5D3}"/>
+                <a16:creationId xmlns:a16="http://schemas.microsoft.com/office/drawing/2014/main" id="{EF0E61E1-5BC8-4788-A8DB-758C2093256B}"/>
               </a:ext>
             </a:extLst>
           </p:cNvPr>
@@ -17029,7 +17029,7 @@
           <p:nvPr/>
         </p:nvPicPr>
         <p:blipFill>
-          <a:blip xmlns:r="http://schemas.openxmlformats.org/officeDocument/2006/relationships" xmlns:a="http://schemas.openxmlformats.org/drawingml/2006/main" r:embed="R3fe89a9457ae4fd2"/>
+          <a:blip xmlns:r="http://schemas.openxmlformats.org/officeDocument/2006/relationships" xmlns:a="http://schemas.openxmlformats.org/drawingml/2006/main" r:embed="R8d4a45efc0054565"/>
           <a:srcRect xmlns:a="http://schemas.openxmlformats.org/drawingml/2006/main" l="0" t="0" r="0" b="0"/>
           <a:stretch xmlns:a="http://schemas.openxmlformats.org/drawingml/2006/main">
             <a:fillRect l="0" t="0" r="0" b="0"/>
@@ -17050,7 +17050,7 @@
           <p:cNvPr id="6" name="">
             <a:extLst xmlns:a="http://schemas.openxmlformats.org/drawingml/2006/main">
               <a:ext uri="{FF2B5EF4-FFF2-40B4-BE49-F238E27FC236}">
-                <a16:creationId xmlns:a16="http://schemas.microsoft.com/office/drawing/2014/main" id="{FF2D04A1-790B-47DF-8C38-EAE6BE8459F7}"/>
+                <a16:creationId xmlns:a16="http://schemas.microsoft.com/office/drawing/2014/main" id="{670943BC-C7C6-4D8E-8931-A4F5DA7AC555}"/>
               </a:ext>
             </a:extLst>
           </p:cNvPr>
@@ -17112,7 +17112,7 @@
           <p:cNvPr id="7" name="">
             <a:extLst xmlns:a="http://schemas.openxmlformats.org/drawingml/2006/main">
               <a:ext uri="{FF2B5EF4-FFF2-40B4-BE49-F238E27FC236}">
-                <a16:creationId xmlns:a16="http://schemas.microsoft.com/office/drawing/2014/main" id="{62038152-1F49-4592-9B0C-0C12068D6CE2}"/>
+                <a16:creationId xmlns:a16="http://schemas.microsoft.com/office/drawing/2014/main" id="{8CEF84CE-2B9D-4B51-B3ED-79A2FFA24E45}"/>
               </a:ext>
             </a:extLst>
           </p:cNvPr>
@@ -17174,7 +17174,7 @@
           <p:cNvPr id="8" name="">
             <a:extLst xmlns:a="http://schemas.openxmlformats.org/drawingml/2006/main">
               <a:ext uri="{FF2B5EF4-FFF2-40B4-BE49-F238E27FC236}">
-                <a16:creationId xmlns:a16="http://schemas.microsoft.com/office/drawing/2014/main" id="{1D3E50DB-23D1-4FD4-B81C-2DE6234CABBF}"/>
+                <a16:creationId xmlns:a16="http://schemas.microsoft.com/office/drawing/2014/main" id="{780E6224-9B79-4C5F-9744-B6B89717E01D}"/>
               </a:ext>
             </a:extLst>
           </p:cNvPr>
@@ -17209,7 +17209,7 @@
           <p:cNvPr id="9" name="">
             <a:extLst xmlns:a="http://schemas.openxmlformats.org/drawingml/2006/main">
               <a:ext uri="{FF2B5EF4-FFF2-40B4-BE49-F238E27FC236}">
-                <a16:creationId xmlns:a16="http://schemas.microsoft.com/office/drawing/2014/main" id="{B0086C43-EC4A-4B25-9FC6-E887E719DDEC}"/>
+                <a16:creationId xmlns:a16="http://schemas.microsoft.com/office/drawing/2014/main" id="{3CE7DE47-C7F9-4F97-8F6D-9406A3290301}"/>
               </a:ext>
             </a:extLst>
           </p:cNvPr>
@@ -17240,7 +17240,7 @@
           <p:cNvPr id="10" name="">
             <a:extLst xmlns:a="http://schemas.openxmlformats.org/drawingml/2006/main">
               <a:ext uri="{FF2B5EF4-FFF2-40B4-BE49-F238E27FC236}">
-                <a16:creationId xmlns:a16="http://schemas.microsoft.com/office/drawing/2014/main" id="{FAADEDD1-F10E-41D6-9773-C2017EA6BEA1}"/>
+                <a16:creationId xmlns:a16="http://schemas.microsoft.com/office/drawing/2014/main" id="{FDED6628-0E9C-49C8-A662-EBC59A532646}"/>
               </a:ext>
             </a:extLst>
           </p:cNvPr>
@@ -17302,7 +17302,7 @@
           <p:cNvPr id="11" name="">
             <a:extLst xmlns:a="http://schemas.openxmlformats.org/drawingml/2006/main">
               <a:ext uri="{FF2B5EF4-FFF2-40B4-BE49-F238E27FC236}">
-                <a16:creationId xmlns:a16="http://schemas.microsoft.com/office/drawing/2014/main" id="{F13A5A98-CC0A-4179-95A1-F116DE3403D6}"/>
+                <a16:creationId xmlns:a16="http://schemas.microsoft.com/office/drawing/2014/main" id="{4299F61D-BD1A-4E4A-A123-A0B1EFCE9EFC}"/>
               </a:ext>
             </a:extLst>
           </p:cNvPr>
@@ -17364,7 +17364,7 @@
           <p:cNvPr id="12" name="">
             <a:extLst xmlns:a="http://schemas.openxmlformats.org/drawingml/2006/main">
               <a:ext uri="{FF2B5EF4-FFF2-40B4-BE49-F238E27FC236}">
-                <a16:creationId xmlns:a16="http://schemas.microsoft.com/office/drawing/2014/main" id="{256DBF13-08E7-45B2-9F35-304669D0E084}"/>
+                <a16:creationId xmlns:a16="http://schemas.microsoft.com/office/drawing/2014/main" id="{E94F2B62-BB5E-42BE-BF59-2C678F8334E1}"/>
               </a:ext>
             </a:extLst>
           </p:cNvPr>
@@ -17399,7 +17399,7 @@
           <p:cNvPr id="13" name="">
             <a:extLst xmlns:a="http://schemas.openxmlformats.org/drawingml/2006/main">
               <a:ext uri="{FF2B5EF4-FFF2-40B4-BE49-F238E27FC236}">
-                <a16:creationId xmlns:a16="http://schemas.microsoft.com/office/drawing/2014/main" id="{EE2A86EA-0FA4-444D-BEE4-5CC7E12CE889}"/>
+                <a16:creationId xmlns:a16="http://schemas.microsoft.com/office/drawing/2014/main" id="{E73BD857-8264-4683-8F3F-81D357170B9B}"/>
               </a:ext>
             </a:extLst>
           </p:cNvPr>
@@ -17430,7 +17430,7 @@
           <p:cNvPr id="14" name="">
             <a:extLst xmlns:a="http://schemas.openxmlformats.org/drawingml/2006/main">
               <a:ext uri="{FF2B5EF4-FFF2-40B4-BE49-F238E27FC236}">
-                <a16:creationId xmlns:a16="http://schemas.microsoft.com/office/drawing/2014/main" id="{59C5A9CA-2352-43F9-B08A-B9C9223B4D70}"/>
+                <a16:creationId xmlns:a16="http://schemas.microsoft.com/office/drawing/2014/main" id="{6A12B2D8-721F-4D9E-ABFC-58AD0ABE1F05}"/>
               </a:ext>
             </a:extLst>
           </p:cNvPr>
@@ -17492,7 +17492,7 @@
           <p:cNvPr id="15" name="">
             <a:extLst xmlns:a="http://schemas.openxmlformats.org/drawingml/2006/main">
               <a:ext uri="{FF2B5EF4-FFF2-40B4-BE49-F238E27FC236}">
-                <a16:creationId xmlns:a16="http://schemas.microsoft.com/office/drawing/2014/main" id="{5A96411F-AB76-43CC-A007-4B347A30F4C5}"/>
+                <a16:creationId xmlns:a16="http://schemas.microsoft.com/office/drawing/2014/main" id="{B82A3A73-7F06-4F6A-B771-DFB7036BB7F6}"/>
               </a:ext>
             </a:extLst>
           </p:cNvPr>
@@ -17554,7 +17554,7 @@
           <p:cNvPr id="16" name="">
             <a:extLst xmlns:a="http://schemas.openxmlformats.org/drawingml/2006/main">
               <a:ext uri="{FF2B5EF4-FFF2-40B4-BE49-F238E27FC236}">
-                <a16:creationId xmlns:a16="http://schemas.microsoft.com/office/drawing/2014/main" id="{75555B6F-74F9-4417-A15E-41BA55D3BF78}"/>
+                <a16:creationId xmlns:a16="http://schemas.microsoft.com/office/drawing/2014/main" id="{BA58EC22-D62F-4427-9E4C-FF5F8D9EFC45}"/>
               </a:ext>
             </a:extLst>
           </p:cNvPr>
@@ -17589,7 +17589,7 @@
           <p:cNvPr id="17" name="">
             <a:extLst xmlns:a="http://schemas.openxmlformats.org/drawingml/2006/main">
               <a:ext uri="{FF2B5EF4-FFF2-40B4-BE49-F238E27FC236}">
-                <a16:creationId xmlns:a16="http://schemas.microsoft.com/office/drawing/2014/main" id="{85D31956-5C97-41E7-86B6-FDB34B7BFF94}"/>
+                <a16:creationId xmlns:a16="http://schemas.microsoft.com/office/drawing/2014/main" id="{EF471E77-38FC-4F59-A6E7-6A53105B253A}"/>
               </a:ext>
             </a:extLst>
           </p:cNvPr>
@@ -17620,7 +17620,7 @@
           <p:cNvPr id="18" name="">
             <a:extLst xmlns:a="http://schemas.openxmlformats.org/drawingml/2006/main">
               <a:ext uri="{FF2B5EF4-FFF2-40B4-BE49-F238E27FC236}">
-                <a16:creationId xmlns:a16="http://schemas.microsoft.com/office/drawing/2014/main" id="{56274E37-A79C-496A-8CEB-E75CA3AFF144}"/>
+                <a16:creationId xmlns:a16="http://schemas.microsoft.com/office/drawing/2014/main" id="{8E53307E-46DF-45C4-94C9-9B0CEFBECBE0}"/>
               </a:ext>
             </a:extLst>
           </p:cNvPr>
@@ -17682,7 +17682,7 @@
           <p:cNvPr id="19" name="">
             <a:extLst xmlns:a="http://schemas.openxmlformats.org/drawingml/2006/main">
               <a:ext uri="{FF2B5EF4-FFF2-40B4-BE49-F238E27FC236}">
-                <a16:creationId xmlns:a16="http://schemas.microsoft.com/office/drawing/2014/main" id="{54CDC9BF-F28C-4891-AF11-E246FC1203C8}"/>
+                <a16:creationId xmlns:a16="http://schemas.microsoft.com/office/drawing/2014/main" id="{7590704F-8947-48FD-B0A7-614F5321DD3C}"/>
               </a:ext>
             </a:extLst>
           </p:cNvPr>
@@ -17744,7 +17744,7 @@
           <p:cNvPr id="20" name="">
             <a:extLst xmlns:a="http://schemas.openxmlformats.org/drawingml/2006/main">
               <a:ext uri="{FF2B5EF4-FFF2-40B4-BE49-F238E27FC236}">
-                <a16:creationId xmlns:a16="http://schemas.microsoft.com/office/drawing/2014/main" id="{9EF147C5-0B0C-4875-B165-636CC31E9950}"/>
+                <a16:creationId xmlns:a16="http://schemas.microsoft.com/office/drawing/2014/main" id="{10E0483F-626B-4B44-B8BF-770B1BF21F29}"/>
               </a:ext>
             </a:extLst>
           </p:cNvPr>
@@ -17806,7 +17806,7 @@
           <p:cNvPr id="21" name="">
             <a:extLst xmlns:a="http://schemas.openxmlformats.org/drawingml/2006/main">
               <a:ext uri="{FF2B5EF4-FFF2-40B4-BE49-F238E27FC236}">
-                <a16:creationId xmlns:a16="http://schemas.microsoft.com/office/drawing/2014/main" id="{EF385708-BE27-42C2-8947-393E041DED7F}"/>
+                <a16:creationId xmlns:a16="http://schemas.microsoft.com/office/drawing/2014/main" id="{4E09B08B-9630-4FD8-A934-BAC2A3E386F8}"/>
               </a:ext>
             </a:extLst>
           </p:cNvPr>
@@ -17841,7 +17841,7 @@
           <p:cNvPr id="22" name="">
             <a:extLst xmlns:a="http://schemas.openxmlformats.org/drawingml/2006/main">
               <a:ext uri="{FF2B5EF4-FFF2-40B4-BE49-F238E27FC236}">
-                <a16:creationId xmlns:a16="http://schemas.microsoft.com/office/drawing/2014/main" id="{25FA8798-0792-472E-A932-ABC66DBD42C9}"/>
+                <a16:creationId xmlns:a16="http://schemas.microsoft.com/office/drawing/2014/main" id="{6D36F0E6-4398-4BF2-B642-46CC5928B4B0}"/>
               </a:ext>
             </a:extLst>
           </p:cNvPr>
@@ -17872,7 +17872,7 @@
           <p:cNvPr id="23" name="">
             <a:extLst xmlns:a="http://schemas.openxmlformats.org/drawingml/2006/main">
               <a:ext uri="{FF2B5EF4-FFF2-40B4-BE49-F238E27FC236}">
-                <a16:creationId xmlns:a16="http://schemas.microsoft.com/office/drawing/2014/main" id="{C54430A8-7EE4-477E-87D5-DE99C5F312C3}"/>
+                <a16:creationId xmlns:a16="http://schemas.microsoft.com/office/drawing/2014/main" id="{D08F1D9E-AA3C-46FA-BB70-BF304F160A55}"/>
               </a:ext>
             </a:extLst>
           </p:cNvPr>
@@ -17934,7 +17934,7 @@
           <p:cNvPr id="24" name="">
             <a:extLst xmlns:a="http://schemas.openxmlformats.org/drawingml/2006/main">
               <a:ext uri="{FF2B5EF4-FFF2-40B4-BE49-F238E27FC236}">
-                <a16:creationId xmlns:a16="http://schemas.microsoft.com/office/drawing/2014/main" id="{4B07CF28-AC99-4AB2-98F2-25E8F686A093}"/>
+                <a16:creationId xmlns:a16="http://schemas.microsoft.com/office/drawing/2014/main" id="{429C2DA9-5EB8-4303-89A0-803F6FDB48EC}"/>
               </a:ext>
             </a:extLst>
           </p:cNvPr>
@@ -17996,7 +17996,7 @@
           <p:cNvPr id="25" name="">
             <a:extLst xmlns:a="http://schemas.openxmlformats.org/drawingml/2006/main">
               <a:ext uri="{FF2B5EF4-FFF2-40B4-BE49-F238E27FC236}">
-                <a16:creationId xmlns:a16="http://schemas.microsoft.com/office/drawing/2014/main" id="{36B14C66-7978-4804-A1CD-DE4F47A37FC0}"/>
+                <a16:creationId xmlns:a16="http://schemas.microsoft.com/office/drawing/2014/main" id="{48B089F7-8787-4D12-A86C-FB169B601B72}"/>
               </a:ext>
             </a:extLst>
           </p:cNvPr>
@@ -18031,7 +18031,7 @@
           <p:cNvPr id="26" name="">
             <a:extLst xmlns:a="http://schemas.openxmlformats.org/drawingml/2006/main">
               <a:ext uri="{FF2B5EF4-FFF2-40B4-BE49-F238E27FC236}">
-                <a16:creationId xmlns:a16="http://schemas.microsoft.com/office/drawing/2014/main" id="{E70F1CAB-B72A-4053-B01D-07B25F158C78}"/>
+                <a16:creationId xmlns:a16="http://schemas.microsoft.com/office/drawing/2014/main" id="{3A7A3D32-83FE-4FA1-838B-5BFA046B5E3F}"/>
               </a:ext>
             </a:extLst>
           </p:cNvPr>
@@ -18062,7 +18062,7 @@
           <p:cNvPr id="27" name="">
             <a:extLst xmlns:a="http://schemas.openxmlformats.org/drawingml/2006/main">
               <a:ext uri="{FF2B5EF4-FFF2-40B4-BE49-F238E27FC236}">
-                <a16:creationId xmlns:a16="http://schemas.microsoft.com/office/drawing/2014/main" id="{60324E8D-CC10-4714-B2F7-B3C9C66AE472}"/>
+                <a16:creationId xmlns:a16="http://schemas.microsoft.com/office/drawing/2014/main" id="{489099DD-7D53-471C-BE2C-94B4CC2670C2}"/>
               </a:ext>
             </a:extLst>
           </p:cNvPr>
@@ -18124,7 +18124,7 @@
           <p:cNvPr id="28" name="">
             <a:extLst xmlns:a="http://schemas.openxmlformats.org/drawingml/2006/main">
               <a:ext uri="{FF2B5EF4-FFF2-40B4-BE49-F238E27FC236}">
-                <a16:creationId xmlns:a16="http://schemas.microsoft.com/office/drawing/2014/main" id="{7B862E46-78F4-47EC-AC16-EAAC26671AEB}"/>
+                <a16:creationId xmlns:a16="http://schemas.microsoft.com/office/drawing/2014/main" id="{BFE68878-45F8-4606-B70C-0CF2C68950BD}"/>
               </a:ext>
             </a:extLst>
           </p:cNvPr>
@@ -18186,7 +18186,7 @@
     </p:spTree>
     <p:extLst>
       <p:ext uri="{BB962C8B-B14F-4D97-AF65-F5344CB8AC3E}">
-        <p14:creationId xmlns:p14="http://schemas.microsoft.com/office/powerpoint/2010/main" val="488955453"/>
+        <p14:creationId xmlns:p14="http://schemas.microsoft.com/office/powerpoint/2010/main" val="389067291"/>
       </p:ext>
     </p:extLst>
   </p:cSld>
@@ -18217,7 +18217,7 @@
           <p:cNvPr id="22" name="">
             <a:extLst xmlns:a="http://schemas.openxmlformats.org/drawingml/2006/main">
               <a:ext uri="{FF2B5EF4-FFF2-40B4-BE49-F238E27FC236}">
-                <a16:creationId xmlns:a16="http://schemas.microsoft.com/office/drawing/2014/main" id="{402704F5-8645-49C5-8DAE-9E46929A017A}"/>
+                <a16:creationId xmlns:a16="http://schemas.microsoft.com/office/drawing/2014/main" id="{1960E8C7-A41D-4CBD-834F-20BCC3784409}"/>
               </a:ext>
             </a:extLst>
           </p:cNvPr>
@@ -18248,7 +18248,7 @@
           <p:cNvPr id="2" name="">
             <a:extLst xmlns:a="http://schemas.openxmlformats.org/drawingml/2006/main">
               <a:ext uri="{FF2B5EF4-FFF2-40B4-BE49-F238E27FC236}">
-                <a16:creationId xmlns:a16="http://schemas.microsoft.com/office/drawing/2014/main" id="{594B6BBB-862A-4FC8-B889-D6347436E61B}"/>
+                <a16:creationId xmlns:a16="http://schemas.microsoft.com/office/drawing/2014/main" id="{FBE1C841-9CD9-4994-890F-A0292D0BA397}"/>
               </a:ext>
             </a:extLst>
           </p:cNvPr>
@@ -18300,7 +18300,7 @@
                 <a:ea typeface="Aptos"/>
                 <a:cs typeface="Aptos"/>
               </a:rPr>
-              <a:t>ΜΕΤΡΗΤΑ</a:t>
+              <a:t>OFFLINE</a:t>
             </a:r>
           </a:p>
         </p:txBody>
@@ -18310,7 +18310,7 @@
           <p:cNvPr id="3" name="">
             <a:extLst xmlns:a="http://schemas.openxmlformats.org/drawingml/2006/main">
               <a:ext uri="{FF2B5EF4-FFF2-40B4-BE49-F238E27FC236}">
-                <a16:creationId xmlns:a16="http://schemas.microsoft.com/office/drawing/2014/main" id="{C222AE26-A78B-4FD6-9DB6-520BCDA0EA47}"/>
+                <a16:creationId xmlns:a16="http://schemas.microsoft.com/office/drawing/2014/main" id="{F053195D-AD49-49E8-A201-948586E526BE}"/>
               </a:ext>
             </a:extLst>
           </p:cNvPr>
@@ -18344,7 +18344,7 @@
                 <a:spcPct val="108000"/>
               </a:lnSpc>
               <a:buNone/>
-              <a:defRPr sz="3150" b="1">
+              <a:defRPr sz="2550" b="1">
                 <a:solidFill>
                   <a:srgbClr val="071426"/>
                 </a:solidFill>
@@ -18354,7 +18354,7 @@
               </a:defRPr>
             </a:pPr>
             <a:r>
-              <a:rPr sz="3150" b="1">
+              <a:rPr sz="2550" b="1">
                 <a:solidFill>
                   <a:srgbClr val="071426"/>
                 </a:solidFill>
@@ -18372,7 +18372,7 @@
           <p:cNvPr id="4" name="">
             <a:extLst xmlns:a="http://schemas.openxmlformats.org/drawingml/2006/main">
               <a:ext uri="{FF2B5EF4-FFF2-40B4-BE49-F238E27FC236}">
-                <a16:creationId xmlns:a16="http://schemas.microsoft.com/office/drawing/2014/main" id="{36C14853-F577-4818-AF2F-55E6D9A4938B}"/>
+                <a16:creationId xmlns:a16="http://schemas.microsoft.com/office/drawing/2014/main" id="{00A83A97-649E-45E9-A87E-148F4B6E985F}"/>
               </a:ext>
             </a:extLst>
           </p:cNvPr>
@@ -18407,7 +18407,7 @@
           <p:nvPr/>
         </p:nvPicPr>
         <p:blipFill>
-          <a:blip xmlns:r="http://schemas.openxmlformats.org/officeDocument/2006/relationships" xmlns:a="http://schemas.openxmlformats.org/drawingml/2006/main" r:embed="R6599e7e7142e489b"/>
+          <a:blip xmlns:r="http://schemas.openxmlformats.org/officeDocument/2006/relationships" xmlns:a="http://schemas.openxmlformats.org/drawingml/2006/main" r:embed="Re746ba4a7560419f"/>
           <a:srcRect xmlns:a="http://schemas.openxmlformats.org/drawingml/2006/main" l="0" t="0" r="0" b="0"/>
           <a:stretch xmlns:a="http://schemas.openxmlformats.org/drawingml/2006/main">
             <a:fillRect l="0" t="0" r="0" b="0"/>
@@ -18428,7 +18428,7 @@
           <p:cNvPr id="6" name="">
             <a:extLst xmlns:a="http://schemas.openxmlformats.org/drawingml/2006/main">
               <a:ext uri="{FF2B5EF4-FFF2-40B4-BE49-F238E27FC236}">
-                <a16:creationId xmlns:a16="http://schemas.microsoft.com/office/drawing/2014/main" id="{F5D01B8B-D3B3-4EB1-8222-6C48BAD10AFC}"/>
+                <a16:creationId xmlns:a16="http://schemas.microsoft.com/office/drawing/2014/main" id="{79EE8E0A-248F-4D7F-9EF3-B7CC25E29D5C}"/>
               </a:ext>
             </a:extLst>
           </p:cNvPr>
@@ -18490,7 +18490,7 @@
           <p:cNvPr id="7" name="">
             <a:extLst xmlns:a="http://schemas.openxmlformats.org/drawingml/2006/main">
               <a:ext uri="{FF2B5EF4-FFF2-40B4-BE49-F238E27FC236}">
-                <a16:creationId xmlns:a16="http://schemas.microsoft.com/office/drawing/2014/main" id="{036962FA-E7BD-4695-8E32-190EB26462A1}"/>
+                <a16:creationId xmlns:a16="http://schemas.microsoft.com/office/drawing/2014/main" id="{42C60D90-CC07-4AAF-8585-80D8CA1FD243}"/>
               </a:ext>
             </a:extLst>
           </p:cNvPr>
@@ -18552,7 +18552,7 @@
           <p:cNvPr id="8" name="">
             <a:extLst xmlns:a="http://schemas.openxmlformats.org/drawingml/2006/main">
               <a:ext uri="{FF2B5EF4-FFF2-40B4-BE49-F238E27FC236}">
-                <a16:creationId xmlns:a16="http://schemas.microsoft.com/office/drawing/2014/main" id="{DABF8A4D-36D3-4E0E-ABA6-772D6B509A8A}"/>
+                <a16:creationId xmlns:a16="http://schemas.microsoft.com/office/drawing/2014/main" id="{9B850BDE-C910-482A-B9D1-7E383DD23C58}"/>
               </a:ext>
             </a:extLst>
           </p:cNvPr>
@@ -18587,7 +18587,7 @@
           <p:cNvPr id="9" name="">
             <a:extLst xmlns:a="http://schemas.openxmlformats.org/drawingml/2006/main">
               <a:ext uri="{FF2B5EF4-FFF2-40B4-BE49-F238E27FC236}">
-                <a16:creationId xmlns:a16="http://schemas.microsoft.com/office/drawing/2014/main" id="{63361F3B-0D8F-43AB-AD77-A4FF7FD7ACE2}"/>
+                <a16:creationId xmlns:a16="http://schemas.microsoft.com/office/drawing/2014/main" id="{39F33DFC-0BD3-49B3-8497-0467E2EA92AB}"/>
               </a:ext>
             </a:extLst>
           </p:cNvPr>
@@ -18618,7 +18618,7 @@
           <p:cNvPr id="10" name="">
             <a:extLst xmlns:a="http://schemas.openxmlformats.org/drawingml/2006/main">
               <a:ext uri="{FF2B5EF4-FFF2-40B4-BE49-F238E27FC236}">
-                <a16:creationId xmlns:a16="http://schemas.microsoft.com/office/drawing/2014/main" id="{29CB7250-A8E1-4D08-9C62-38BB4624B5E9}"/>
+                <a16:creationId xmlns:a16="http://schemas.microsoft.com/office/drawing/2014/main" id="{BE002898-0559-435A-B8F0-C7DAF4F2AC76}"/>
               </a:ext>
             </a:extLst>
           </p:cNvPr>
@@ -18680,7 +18680,7 @@
           <p:cNvPr id="11" name="">
             <a:extLst xmlns:a="http://schemas.openxmlformats.org/drawingml/2006/main">
               <a:ext uri="{FF2B5EF4-FFF2-40B4-BE49-F238E27FC236}">
-                <a16:creationId xmlns:a16="http://schemas.microsoft.com/office/drawing/2014/main" id="{9DEF9814-DB49-44FB-9E75-A147A1096B31}"/>
+                <a16:creationId xmlns:a16="http://schemas.microsoft.com/office/drawing/2014/main" id="{69227273-AD2E-436F-A206-13B8D110609C}"/>
               </a:ext>
             </a:extLst>
           </p:cNvPr>
@@ -18715,7 +18715,7 @@
           <p:cNvPr id="12" name="">
             <a:extLst xmlns:a="http://schemas.openxmlformats.org/drawingml/2006/main">
               <a:ext uri="{FF2B5EF4-FFF2-40B4-BE49-F238E27FC236}">
-                <a16:creationId xmlns:a16="http://schemas.microsoft.com/office/drawing/2014/main" id="{161E5F3D-41DD-4B16-B4FD-197760008405}"/>
+                <a16:creationId xmlns:a16="http://schemas.microsoft.com/office/drawing/2014/main" id="{AD54AE2E-6074-43AB-817D-C955FE002AA1}"/>
               </a:ext>
             </a:extLst>
           </p:cNvPr>
@@ -18746,7 +18746,7 @@
           <p:cNvPr id="13" name="">
             <a:extLst xmlns:a="http://schemas.openxmlformats.org/drawingml/2006/main">
               <a:ext uri="{FF2B5EF4-FFF2-40B4-BE49-F238E27FC236}">
-                <a16:creationId xmlns:a16="http://schemas.microsoft.com/office/drawing/2014/main" id="{59BF55FB-B4F0-4CD5-932A-1341B21D64B3}"/>
+                <a16:creationId xmlns:a16="http://schemas.microsoft.com/office/drawing/2014/main" id="{5FFC2648-AD90-4446-850F-328C52B61100}"/>
               </a:ext>
             </a:extLst>
           </p:cNvPr>
@@ -18808,7 +18808,7 @@
           <p:cNvPr id="14" name="">
             <a:extLst xmlns:a="http://schemas.openxmlformats.org/drawingml/2006/main">
               <a:ext uri="{FF2B5EF4-FFF2-40B4-BE49-F238E27FC236}">
-                <a16:creationId xmlns:a16="http://schemas.microsoft.com/office/drawing/2014/main" id="{8F807CFF-912C-4B10-96BB-BC5F224DE64F}"/>
+                <a16:creationId xmlns:a16="http://schemas.microsoft.com/office/drawing/2014/main" id="{45D61D61-7FA5-4039-B466-3A4590FC80BF}"/>
               </a:ext>
             </a:extLst>
           </p:cNvPr>
@@ -18843,7 +18843,7 @@
           <p:cNvPr id="15" name="">
             <a:extLst xmlns:a="http://schemas.openxmlformats.org/drawingml/2006/main">
               <a:ext uri="{FF2B5EF4-FFF2-40B4-BE49-F238E27FC236}">
-                <a16:creationId xmlns:a16="http://schemas.microsoft.com/office/drawing/2014/main" id="{E433A54D-B0AE-4BA6-9197-3BDC7295862B}"/>
+                <a16:creationId xmlns:a16="http://schemas.microsoft.com/office/drawing/2014/main" id="{5ADDDA39-D4C4-4DCC-90F3-972DBB5114D4}"/>
               </a:ext>
             </a:extLst>
           </p:cNvPr>
@@ -18874,7 +18874,7 @@
           <p:cNvPr id="16" name="">
             <a:extLst xmlns:a="http://schemas.openxmlformats.org/drawingml/2006/main">
               <a:ext uri="{FF2B5EF4-FFF2-40B4-BE49-F238E27FC236}">
-                <a16:creationId xmlns:a16="http://schemas.microsoft.com/office/drawing/2014/main" id="{3E564261-8407-47C7-BB5E-4BBAE3CBA24C}"/>
+                <a16:creationId xmlns:a16="http://schemas.microsoft.com/office/drawing/2014/main" id="{3C7441F2-7B1C-428E-A5D5-46F8C82EDF42}"/>
               </a:ext>
             </a:extLst>
           </p:cNvPr>
@@ -18936,7 +18936,7 @@
           <p:cNvPr id="17" name="">
             <a:extLst xmlns:a="http://schemas.openxmlformats.org/drawingml/2006/main">
               <a:ext uri="{FF2B5EF4-FFF2-40B4-BE49-F238E27FC236}">
-                <a16:creationId xmlns:a16="http://schemas.microsoft.com/office/drawing/2014/main" id="{606412A4-D4BF-4941-95F3-9138C580BB49}"/>
+                <a16:creationId xmlns:a16="http://schemas.microsoft.com/office/drawing/2014/main" id="{398E2965-8572-42D6-A69D-912186EF1973}"/>
               </a:ext>
             </a:extLst>
           </p:cNvPr>
@@ -18971,7 +18971,7 @@
           <p:cNvPr id="18" name="">
             <a:extLst xmlns:a="http://schemas.openxmlformats.org/drawingml/2006/main">
               <a:ext uri="{FF2B5EF4-FFF2-40B4-BE49-F238E27FC236}">
-                <a16:creationId xmlns:a16="http://schemas.microsoft.com/office/drawing/2014/main" id="{926AB879-B8BE-47B8-A0B3-459A01F9209A}"/>
+                <a16:creationId xmlns:a16="http://schemas.microsoft.com/office/drawing/2014/main" id="{874E5A78-DEC7-44BC-A317-D81DD8F8A909}"/>
               </a:ext>
             </a:extLst>
           </p:cNvPr>
@@ -19002,7 +19002,7 @@
           <p:cNvPr id="19" name="">
             <a:extLst xmlns:a="http://schemas.openxmlformats.org/drawingml/2006/main">
               <a:ext uri="{FF2B5EF4-FFF2-40B4-BE49-F238E27FC236}">
-                <a16:creationId xmlns:a16="http://schemas.microsoft.com/office/drawing/2014/main" id="{6614A847-CE37-47AD-B60A-0971A895D692}"/>
+                <a16:creationId xmlns:a16="http://schemas.microsoft.com/office/drawing/2014/main" id="{B122C1C1-95E4-49B3-87B2-5AB2ECD1DB01}"/>
               </a:ext>
             </a:extLst>
           </p:cNvPr>
@@ -19064,7 +19064,7 @@
           <p:cNvPr id="20" name="">
             <a:extLst xmlns:a="http://schemas.openxmlformats.org/drawingml/2006/main">
               <a:ext uri="{FF2B5EF4-FFF2-40B4-BE49-F238E27FC236}">
-                <a16:creationId xmlns:a16="http://schemas.microsoft.com/office/drawing/2014/main" id="{567C4889-D27F-421F-8590-3BA886871716}"/>
+                <a16:creationId xmlns:a16="http://schemas.microsoft.com/office/drawing/2014/main" id="{7823C84B-8FA1-4CB8-903B-14B7A9116A24}"/>
               </a:ext>
             </a:extLst>
           </p:cNvPr>
@@ -19126,7 +19126,7 @@
           <p:cNvPr id="21" name="">
             <a:extLst xmlns:a="http://schemas.openxmlformats.org/drawingml/2006/main">
               <a:ext uri="{FF2B5EF4-FFF2-40B4-BE49-F238E27FC236}">
-                <a16:creationId xmlns:a16="http://schemas.microsoft.com/office/drawing/2014/main" id="{041C46FC-E4D2-4516-B360-244FA50A9E85}"/>
+                <a16:creationId xmlns:a16="http://schemas.microsoft.com/office/drawing/2014/main" id="{5EA35C89-3ECB-4052-BE90-2D5907B70F7E}"/>
               </a:ext>
             </a:extLst>
           </p:cNvPr>
@@ -19188,7 +19188,7 @@
     </p:spTree>
     <p:extLst>
       <p:ext uri="{BB962C8B-B14F-4D97-AF65-F5344CB8AC3E}">
-        <p14:creationId xmlns:p14="http://schemas.microsoft.com/office/powerpoint/2010/main" val="1907053507"/>
+        <p14:creationId xmlns:p14="http://schemas.microsoft.com/office/powerpoint/2010/main" val="509567581"/>
       </p:ext>
     </p:extLst>
   </p:cSld>
@@ -19219,7 +19219,7 @@
           <p:cNvPr id="33" name="">
             <a:extLst xmlns:a="http://schemas.openxmlformats.org/drawingml/2006/main">
               <a:ext uri="{FF2B5EF4-FFF2-40B4-BE49-F238E27FC236}">
-                <a16:creationId xmlns:a16="http://schemas.microsoft.com/office/drawing/2014/main" id="{C1A8B08A-992F-48A0-9AA2-99967EA056AA}"/>
+                <a16:creationId xmlns:a16="http://schemas.microsoft.com/office/drawing/2014/main" id="{14C3F854-C2B7-440F-894A-6332CDC5B506}"/>
               </a:ext>
             </a:extLst>
           </p:cNvPr>
@@ -19250,7 +19250,7 @@
           <p:cNvPr id="2" name="">
             <a:extLst xmlns:a="http://schemas.openxmlformats.org/drawingml/2006/main">
               <a:ext uri="{FF2B5EF4-FFF2-40B4-BE49-F238E27FC236}">
-                <a16:creationId xmlns:a16="http://schemas.microsoft.com/office/drawing/2014/main" id="{41951EA5-917A-468E-A1DF-9D0C2157CAFE}"/>
+                <a16:creationId xmlns:a16="http://schemas.microsoft.com/office/drawing/2014/main" id="{B3420E29-842D-48FF-9456-88AAB353F0B8}"/>
               </a:ext>
             </a:extLst>
           </p:cNvPr>
@@ -19302,7 +19302,7 @@
                 <a:ea typeface="Aptos"/>
                 <a:cs typeface="Aptos"/>
               </a:rPr>
-              <a:t>OFFLINE</a:t>
+              <a:t>ΔΙΑΚΥΒΕΡΝΗΣΗ</a:t>
             </a:r>
           </a:p>
         </p:txBody>
@@ -19312,7 +19312,7 @@
           <p:cNvPr id="3" name="">
             <a:extLst xmlns:a="http://schemas.openxmlformats.org/drawingml/2006/main">
               <a:ext uri="{FF2B5EF4-FFF2-40B4-BE49-F238E27FC236}">
-                <a16:creationId xmlns:a16="http://schemas.microsoft.com/office/drawing/2014/main" id="{742291AA-FC22-4DDA-89D8-443BA384751C}"/>
+                <a16:creationId xmlns:a16="http://schemas.microsoft.com/office/drawing/2014/main" id="{42BDB04F-6E9B-4081-B3EE-5DAA75452289}"/>
               </a:ext>
             </a:extLst>
           </p:cNvPr>
@@ -19346,7 +19346,7 @@
                 <a:spcPct val="108000"/>
               </a:lnSpc>
               <a:buNone/>
-              <a:defRPr sz="3150" b="1">
+              <a:defRPr sz="2550" b="1">
                 <a:solidFill>
                   <a:srgbClr val="071426"/>
                 </a:solidFill>
@@ -19356,7 +19356,7 @@
               </a:defRPr>
             </a:pPr>
             <a:r>
-              <a:rPr sz="3150" b="1">
+              <a:rPr sz="2550" b="1">
                 <a:solidFill>
                   <a:srgbClr val="071426"/>
                 </a:solidFill>
@@ -19374,7 +19374,7 @@
           <p:cNvPr id="4" name="">
             <a:extLst xmlns:a="http://schemas.openxmlformats.org/drawingml/2006/main">
               <a:ext uri="{FF2B5EF4-FFF2-40B4-BE49-F238E27FC236}">
-                <a16:creationId xmlns:a16="http://schemas.microsoft.com/office/drawing/2014/main" id="{6262F421-9D3E-4B6C-A82F-F4ECFE20CAB1}"/>
+                <a16:creationId xmlns:a16="http://schemas.microsoft.com/office/drawing/2014/main" id="{97C48DEB-46E0-4824-B6D4-6ADF04E6827B}"/>
               </a:ext>
             </a:extLst>
           </p:cNvPr>
@@ -19409,7 +19409,7 @@
           <p:nvPr/>
         </p:nvPicPr>
         <p:blipFill>
-          <a:blip xmlns:r="http://schemas.openxmlformats.org/officeDocument/2006/relationships" xmlns:a="http://schemas.openxmlformats.org/drawingml/2006/main" r:embed="R2dc8a788321a43ea"/>
+          <a:blip xmlns:r="http://schemas.openxmlformats.org/officeDocument/2006/relationships" xmlns:a="http://schemas.openxmlformats.org/drawingml/2006/main" r:embed="R07cef605e3b146b0"/>
           <a:srcRect xmlns:a="http://schemas.openxmlformats.org/drawingml/2006/main" l="0" t="0" r="0" b="0"/>
           <a:stretch xmlns:a="http://schemas.openxmlformats.org/drawingml/2006/main">
             <a:fillRect l="0" t="0" r="0" b="0"/>
@@ -19430,7 +19430,7 @@
           <p:cNvPr id="6" name="">
             <a:extLst xmlns:a="http://schemas.openxmlformats.org/drawingml/2006/main">
               <a:ext uri="{FF2B5EF4-FFF2-40B4-BE49-F238E27FC236}">
-                <a16:creationId xmlns:a16="http://schemas.microsoft.com/office/drawing/2014/main" id="{10A460F6-8225-4798-8D18-5920B3B85B5B}"/>
+                <a16:creationId xmlns:a16="http://schemas.microsoft.com/office/drawing/2014/main" id="{81A7465A-1135-4367-AD66-7C03A295A52C}"/>
               </a:ext>
             </a:extLst>
           </p:cNvPr>
@@ -19492,7 +19492,7 @@
           <p:cNvPr id="7" name="">
             <a:extLst xmlns:a="http://schemas.openxmlformats.org/drawingml/2006/main">
               <a:ext uri="{FF2B5EF4-FFF2-40B4-BE49-F238E27FC236}">
-                <a16:creationId xmlns:a16="http://schemas.microsoft.com/office/drawing/2014/main" id="{FBD5CD19-83C6-47A9-A265-135249B554D5}"/>
+                <a16:creationId xmlns:a16="http://schemas.microsoft.com/office/drawing/2014/main" id="{0F4C587D-805B-4986-8384-E44734E98227}"/>
               </a:ext>
             </a:extLst>
           </p:cNvPr>
@@ -19554,7 +19554,7 @@
           <p:cNvPr id="8" name="">
             <a:extLst xmlns:a="http://schemas.openxmlformats.org/drawingml/2006/main">
               <a:ext uri="{FF2B5EF4-FFF2-40B4-BE49-F238E27FC236}">
-                <a16:creationId xmlns:a16="http://schemas.microsoft.com/office/drawing/2014/main" id="{C45E0411-18A8-43FF-A697-EA4184DED478}"/>
+                <a16:creationId xmlns:a16="http://schemas.microsoft.com/office/drawing/2014/main" id="{45966D9D-3DC0-4333-BB1F-7047924F8EE5}"/>
               </a:ext>
             </a:extLst>
           </p:cNvPr>
@@ -19585,7 +19585,7 @@
           <p:cNvPr id="9" name="">
             <a:extLst xmlns:a="http://schemas.openxmlformats.org/drawingml/2006/main">
               <a:ext uri="{FF2B5EF4-FFF2-40B4-BE49-F238E27FC236}">
-                <a16:creationId xmlns:a16="http://schemas.microsoft.com/office/drawing/2014/main" id="{F5125C37-F128-495E-B9E9-C2146F2C06B1}"/>
+                <a16:creationId xmlns:a16="http://schemas.microsoft.com/office/drawing/2014/main" id="{E62E6A41-C4B3-4F5B-9E6C-849F5AA7B040}"/>
               </a:ext>
             </a:extLst>
           </p:cNvPr>
@@ -19647,7 +19647,7 @@
           <p:cNvPr id="10" name="">
             <a:extLst xmlns:a="http://schemas.openxmlformats.org/drawingml/2006/main">
               <a:ext uri="{FF2B5EF4-FFF2-40B4-BE49-F238E27FC236}">
-                <a16:creationId xmlns:a16="http://schemas.microsoft.com/office/drawing/2014/main" id="{28D97896-D9A5-4715-B107-406B8F2B38DF}"/>
+                <a16:creationId xmlns:a16="http://schemas.microsoft.com/office/drawing/2014/main" id="{8B5F68A5-994C-4F12-8CE8-663486C951EB}"/>
               </a:ext>
             </a:extLst>
           </p:cNvPr>
@@ -19682,7 +19682,7 @@
           <p:cNvPr id="11" name="">
             <a:extLst xmlns:a="http://schemas.openxmlformats.org/drawingml/2006/main">
               <a:ext uri="{FF2B5EF4-FFF2-40B4-BE49-F238E27FC236}">
-                <a16:creationId xmlns:a16="http://schemas.microsoft.com/office/drawing/2014/main" id="{9C195468-13A2-4E24-8279-3D2958838A1C}"/>
+                <a16:creationId xmlns:a16="http://schemas.microsoft.com/office/drawing/2014/main" id="{8803989F-D925-4658-98F8-BAA05722A65C}"/>
               </a:ext>
             </a:extLst>
           </p:cNvPr>
@@ -19713,7 +19713,7 @@
           <p:cNvPr id="12" name="">
             <a:extLst xmlns:a="http://schemas.openxmlformats.org/drawingml/2006/main">
               <a:ext uri="{FF2B5EF4-FFF2-40B4-BE49-F238E27FC236}">
-                <a16:creationId xmlns:a16="http://schemas.microsoft.com/office/drawing/2014/main" id="{20010FCD-6D92-4072-9BBF-4A0D32920330}"/>
+                <a16:creationId xmlns:a16="http://schemas.microsoft.com/office/drawing/2014/main" id="{2A6CD742-6F7D-4C47-9D4B-1E68A967A870}"/>
               </a:ext>
             </a:extLst>
           </p:cNvPr>
@@ -19775,7 +19775,7 @@
           <p:cNvPr id="13" name="">
             <a:extLst xmlns:a="http://schemas.openxmlformats.org/drawingml/2006/main">
               <a:ext uri="{FF2B5EF4-FFF2-40B4-BE49-F238E27FC236}">
-                <a16:creationId xmlns:a16="http://schemas.microsoft.com/office/drawing/2014/main" id="{7EE7C489-CCEA-4B3A-80AC-430D42F9E63C}"/>
+                <a16:creationId xmlns:a16="http://schemas.microsoft.com/office/drawing/2014/main" id="{8DCB7AA1-4308-423A-A98C-0D3DC5F0664B}"/>
               </a:ext>
             </a:extLst>
           </p:cNvPr>
@@ -19827,7 +19827,7 @@
                 <a:ea typeface="Aptos"/>
                 <a:cs typeface="Aptos"/>
               </a:rPr>
-              <a:t>testnet/διορθώσεις σφαλμάτων</a:t>
+              <a:t>testnet/διορθώσεις σφαλμάτων · 4 από 7 · 48 ώρες</a:t>
             </a:r>
           </a:p>
         </p:txBody>
@@ -19837,7 +19837,7 @@
           <p:cNvPr id="14" name="">
             <a:extLst xmlns:a="http://schemas.openxmlformats.org/drawingml/2006/main">
               <a:ext uri="{FF2B5EF4-FFF2-40B4-BE49-F238E27FC236}">
-                <a16:creationId xmlns:a16="http://schemas.microsoft.com/office/drawing/2014/main" id="{06840C25-D4B4-4FD7-9919-152C89F9A69D}"/>
+                <a16:creationId xmlns:a16="http://schemas.microsoft.com/office/drawing/2014/main" id="{6884421F-689A-4C2B-9E92-A7F432D17F8B}"/>
               </a:ext>
             </a:extLst>
           </p:cNvPr>
@@ -19868,7 +19868,7 @@
           <p:cNvPr id="15" name="">
             <a:extLst xmlns:a="http://schemas.openxmlformats.org/drawingml/2006/main">
               <a:ext uri="{FF2B5EF4-FFF2-40B4-BE49-F238E27FC236}">
-                <a16:creationId xmlns:a16="http://schemas.microsoft.com/office/drawing/2014/main" id="{26316660-8F53-4B7A-AA25-BBC09155F0B3}"/>
+                <a16:creationId xmlns:a16="http://schemas.microsoft.com/office/drawing/2014/main" id="{043A2242-A8BD-4A70-BCA4-EA43DDAD50A7}"/>
               </a:ext>
             </a:extLst>
           </p:cNvPr>
@@ -19930,7 +19930,7 @@
           <p:cNvPr id="16" name="">
             <a:extLst xmlns:a="http://schemas.openxmlformats.org/drawingml/2006/main">
               <a:ext uri="{FF2B5EF4-FFF2-40B4-BE49-F238E27FC236}">
-                <a16:creationId xmlns:a16="http://schemas.microsoft.com/office/drawing/2014/main" id="{4425FBDC-5E7C-4389-B2C5-9651D508902F}"/>
+                <a16:creationId xmlns:a16="http://schemas.microsoft.com/office/drawing/2014/main" id="{DFBF946A-C204-4702-AFB7-9775D9FBA5E3}"/>
               </a:ext>
             </a:extLst>
           </p:cNvPr>
@@ -19965,7 +19965,7 @@
           <p:cNvPr id="17" name="">
             <a:extLst xmlns:a="http://schemas.openxmlformats.org/drawingml/2006/main">
               <a:ext uri="{FF2B5EF4-FFF2-40B4-BE49-F238E27FC236}">
-                <a16:creationId xmlns:a16="http://schemas.microsoft.com/office/drawing/2014/main" id="{A0D104D0-1124-431E-86E2-DE0470D17FB9}"/>
+                <a16:creationId xmlns:a16="http://schemas.microsoft.com/office/drawing/2014/main" id="{CC9A3ECC-0804-4362-8774-2B1478DA0717}"/>
               </a:ext>
             </a:extLst>
           </p:cNvPr>
@@ -19996,7 +19996,7 @@
           <p:cNvPr id="18" name="">
             <a:extLst xmlns:a="http://schemas.openxmlformats.org/drawingml/2006/main">
               <a:ext uri="{FF2B5EF4-FFF2-40B4-BE49-F238E27FC236}">
-                <a16:creationId xmlns:a16="http://schemas.microsoft.com/office/drawing/2014/main" id="{39826227-B33A-4AC3-B93B-FEA9E29DF81F}"/>
+                <a16:creationId xmlns:a16="http://schemas.microsoft.com/office/drawing/2014/main" id="{F36A9111-0872-4975-81F7-9281424A0740}"/>
               </a:ext>
             </a:extLst>
           </p:cNvPr>
@@ -20058,7 +20058,7 @@
           <p:cNvPr id="19" name="">
             <a:extLst xmlns:a="http://schemas.openxmlformats.org/drawingml/2006/main">
               <a:ext uri="{FF2B5EF4-FFF2-40B4-BE49-F238E27FC236}">
-                <a16:creationId xmlns:a16="http://schemas.microsoft.com/office/drawing/2014/main" id="{203211C4-5511-43AD-84BB-4F26B331CC67}"/>
+                <a16:creationId xmlns:a16="http://schemas.microsoft.com/office/drawing/2014/main" id="{4F87C970-0B8F-4B88-B801-0B77FF8C7A09}"/>
               </a:ext>
             </a:extLst>
           </p:cNvPr>
@@ -20110,7 +20110,7 @@
                 <a:ea typeface="Aptos"/>
                 <a:cs typeface="Aptos"/>
               </a:rPr>
-              <a:t>μόνο ασφάλεια</a:t>
+              <a:t>μόνο ασφάλεια · 5 από 9 · 14 ημέρες</a:t>
             </a:r>
           </a:p>
         </p:txBody>
@@ -20120,7 +20120,7 @@
           <p:cNvPr id="20" name="">
             <a:extLst xmlns:a="http://schemas.openxmlformats.org/drawingml/2006/main">
               <a:ext uri="{FF2B5EF4-FFF2-40B4-BE49-F238E27FC236}">
-                <a16:creationId xmlns:a16="http://schemas.microsoft.com/office/drawing/2014/main" id="{B7E474C4-4E59-460C-B24B-4E66D9396E89}"/>
+                <a16:creationId xmlns:a16="http://schemas.microsoft.com/office/drawing/2014/main" id="{6E8C272D-3554-4AF0-855D-C4E4773FDC79}"/>
               </a:ext>
             </a:extLst>
           </p:cNvPr>
@@ -20151,7 +20151,7 @@
           <p:cNvPr id="21" name="">
             <a:extLst xmlns:a="http://schemas.openxmlformats.org/drawingml/2006/main">
               <a:ext uri="{FF2B5EF4-FFF2-40B4-BE49-F238E27FC236}">
-                <a16:creationId xmlns:a16="http://schemas.microsoft.com/office/drawing/2014/main" id="{F23ED785-C211-4F6A-83AE-6526D34C88DB}"/>
+                <a16:creationId xmlns:a16="http://schemas.microsoft.com/office/drawing/2014/main" id="{08AC42C4-4729-4516-BC34-4EBA17AF34B3}"/>
               </a:ext>
             </a:extLst>
           </p:cNvPr>
@@ -20213,7 +20213,7 @@
           <p:cNvPr id="22" name="">
             <a:extLst xmlns:a="http://schemas.openxmlformats.org/drawingml/2006/main">
               <a:ext uri="{FF2B5EF4-FFF2-40B4-BE49-F238E27FC236}">
-                <a16:creationId xmlns:a16="http://schemas.microsoft.com/office/drawing/2014/main" id="{6D512082-E5CE-4DB0-9533-862B07B47CDE}"/>
+                <a16:creationId xmlns:a16="http://schemas.microsoft.com/office/drawing/2014/main" id="{39DFD324-E921-4EE6-B2B2-D178332D9C23}"/>
               </a:ext>
             </a:extLst>
           </p:cNvPr>
@@ -20248,7 +20248,7 @@
           <p:cNvPr id="23" name="">
             <a:extLst xmlns:a="http://schemas.openxmlformats.org/drawingml/2006/main">
               <a:ext uri="{FF2B5EF4-FFF2-40B4-BE49-F238E27FC236}">
-                <a16:creationId xmlns:a16="http://schemas.microsoft.com/office/drawing/2014/main" id="{3694A58A-2699-4358-8421-A3C7382BFBAD}"/>
+                <a16:creationId xmlns:a16="http://schemas.microsoft.com/office/drawing/2014/main" id="{5378ECD5-44C6-4DA3-B7E7-6EDE74DD62F3}"/>
               </a:ext>
             </a:extLst>
           </p:cNvPr>
@@ -20279,7 +20279,7 @@
           <p:cNvPr id="24" name="">
             <a:extLst xmlns:a="http://schemas.openxmlformats.org/drawingml/2006/main">
               <a:ext uri="{FF2B5EF4-FFF2-40B4-BE49-F238E27FC236}">
-                <a16:creationId xmlns:a16="http://schemas.microsoft.com/office/drawing/2014/main" id="{B28DC9D1-95BF-4E9B-9511-A97D793355E1}"/>
+                <a16:creationId xmlns:a16="http://schemas.microsoft.com/office/drawing/2014/main" id="{4179F6EF-6AB0-4077-B6C4-A250C1D84525}"/>
               </a:ext>
             </a:extLst>
           </p:cNvPr>
@@ -20341,7 +20341,7 @@
           <p:cNvPr id="25" name="">
             <a:extLst xmlns:a="http://schemas.openxmlformats.org/drawingml/2006/main">
               <a:ext uri="{FF2B5EF4-FFF2-40B4-BE49-F238E27FC236}">
-                <a16:creationId xmlns:a16="http://schemas.microsoft.com/office/drawing/2014/main" id="{C0C47D90-69D5-410A-B3EC-D231010451F4}"/>
+                <a16:creationId xmlns:a16="http://schemas.microsoft.com/office/drawing/2014/main" id="{27BC41C9-7CB8-445A-8770-CD236B25584C}"/>
               </a:ext>
             </a:extLst>
           </p:cNvPr>
@@ -20393,7 +20393,7 @@
                 <a:ea typeface="Aptos"/>
                 <a:cs typeface="Aptos"/>
               </a:rPr>
-              <a:t>παράδοση</a:t>
+              <a:t>παράδοση · 6 από 11 · 30 ημέρες</a:t>
             </a:r>
           </a:p>
         </p:txBody>
@@ -20403,7 +20403,7 @@
           <p:cNvPr id="26" name="">
             <a:extLst xmlns:a="http://schemas.openxmlformats.org/drawingml/2006/main">
               <a:ext uri="{FF2B5EF4-FFF2-40B4-BE49-F238E27FC236}">
-                <a16:creationId xmlns:a16="http://schemas.microsoft.com/office/drawing/2014/main" id="{31AD4479-DFB1-4A0D-A277-A99C3A669FFB}"/>
+                <a16:creationId xmlns:a16="http://schemas.microsoft.com/office/drawing/2014/main" id="{6AC9E50B-1F99-45AA-942B-3C359B38B661}"/>
               </a:ext>
             </a:extLst>
           </p:cNvPr>
@@ -20434,7 +20434,7 @@
           <p:cNvPr id="27" name="">
             <a:extLst xmlns:a="http://schemas.openxmlformats.org/drawingml/2006/main">
               <a:ext uri="{FF2B5EF4-FFF2-40B4-BE49-F238E27FC236}">
-                <a16:creationId xmlns:a16="http://schemas.microsoft.com/office/drawing/2014/main" id="{EC43A1BF-DF25-4A6A-94DC-79B0C547AB8E}"/>
+                <a16:creationId xmlns:a16="http://schemas.microsoft.com/office/drawing/2014/main" id="{D34DB0C6-4A57-4FDE-A546-3B4F5B438455}"/>
               </a:ext>
             </a:extLst>
           </p:cNvPr>
@@ -20496,7 +20496,7 @@
           <p:cNvPr id="28" name="">
             <a:extLst xmlns:a="http://schemas.openxmlformats.org/drawingml/2006/main">
               <a:ext uri="{FF2B5EF4-FFF2-40B4-BE49-F238E27FC236}">
-                <a16:creationId xmlns:a16="http://schemas.microsoft.com/office/drawing/2014/main" id="{48EEB8CF-3959-4533-A9D1-0F3A22B8D8E3}"/>
+                <a16:creationId xmlns:a16="http://schemas.microsoft.com/office/drawing/2014/main" id="{9F6D0FA9-9258-4E2A-84E7-DFDDED1A356C}"/>
               </a:ext>
             </a:extLst>
           </p:cNvPr>
@@ -20531,7 +20531,7 @@
           <p:cNvPr id="29" name="">
             <a:extLst xmlns:a="http://schemas.openxmlformats.org/drawingml/2006/main">
               <a:ext uri="{FF2B5EF4-FFF2-40B4-BE49-F238E27FC236}">
-                <a16:creationId xmlns:a16="http://schemas.microsoft.com/office/drawing/2014/main" id="{A2F80842-A49E-4D3D-ACB7-349C3246FA9A}"/>
+                <a16:creationId xmlns:a16="http://schemas.microsoft.com/office/drawing/2014/main" id="{F3968137-9BEB-45BD-9F74-DD5DAB3E250B}"/>
               </a:ext>
             </a:extLst>
           </p:cNvPr>
@@ -20562,7 +20562,7 @@
           <p:cNvPr id="30" name="">
             <a:extLst xmlns:a="http://schemas.openxmlformats.org/drawingml/2006/main">
               <a:ext uri="{FF2B5EF4-FFF2-40B4-BE49-F238E27FC236}">
-                <a16:creationId xmlns:a16="http://schemas.microsoft.com/office/drawing/2014/main" id="{9FE1DCB0-D361-4267-8674-48B3F0688C1D}"/>
+                <a16:creationId xmlns:a16="http://schemas.microsoft.com/office/drawing/2014/main" id="{0BAADB26-7938-48DD-BD5D-407D87F05D32}"/>
               </a:ext>
             </a:extLst>
           </p:cNvPr>
@@ -20624,7 +20624,7 @@
           <p:cNvPr id="31" name="">
             <a:extLst xmlns:a="http://schemas.openxmlformats.org/drawingml/2006/main">
               <a:ext uri="{FF2B5EF4-FFF2-40B4-BE49-F238E27FC236}">
-                <a16:creationId xmlns:a16="http://schemas.microsoft.com/office/drawing/2014/main" id="{AB1806D8-3DBE-4DE1-9753-CFB8175ED153}"/>
+                <a16:creationId xmlns:a16="http://schemas.microsoft.com/office/drawing/2014/main" id="{D24CC432-6027-4A90-9B0C-ABD5EABF8AC6}"/>
               </a:ext>
             </a:extLst>
           </p:cNvPr>
@@ -20686,7 +20686,7 @@
           <p:cNvPr id="32" name="">
             <a:extLst xmlns:a="http://schemas.openxmlformats.org/drawingml/2006/main">
               <a:ext uri="{FF2B5EF4-FFF2-40B4-BE49-F238E27FC236}">
-                <a16:creationId xmlns:a16="http://schemas.microsoft.com/office/drawing/2014/main" id="{1B1BCCC1-D0D4-470A-BC5B-F7F84EA8FF77}"/>
+                <a16:creationId xmlns:a16="http://schemas.microsoft.com/office/drawing/2014/main" id="{B0AE174A-1BB5-45FA-BB09-9A53E12359BA}"/>
               </a:ext>
             </a:extLst>
           </p:cNvPr>
@@ -20748,7 +20748,7 @@
     </p:spTree>
     <p:extLst>
       <p:ext uri="{BB962C8B-B14F-4D97-AF65-F5344CB8AC3E}">
-        <p14:creationId xmlns:p14="http://schemas.microsoft.com/office/powerpoint/2010/main" val="2036040490"/>
+        <p14:creationId xmlns:p14="http://schemas.microsoft.com/office/powerpoint/2010/main" val="1132315795"/>
       </p:ext>
     </p:extLst>
   </p:cSld>

</xml_diff>